<commit_message>
Update SmartTune slide to alternate layout
</commit_message>
<xml_diff>
--- a/docs/presentations/smartune_q3_milestone_slide.pptx
+++ b/docs/presentations/smartune_q3_milestone_slide.pptx
@@ -3103,7 +3103,7 @@
             <a:avLst/>
           </a:prstGeom>
           <a:solidFill>
-            <a:srgbClr val="F4F7FC"/>
+            <a:srgbClr val="F5F7FB"/>
           </a:solidFill>
           <a:ln>
             <a:noFill/>
@@ -3133,53 +3133,20 @@
       </p:sp>
       <p:sp>
         <p:nvSpPr>
-          <p:cNvPr id="3" name="TextBox 2"/>
-          <p:cNvSpPr txBox="1"/>
+          <p:cNvPr id="3" name="Rectangle 2"/>
+          <p:cNvSpPr/>
           <p:nvPr/>
         </p:nvSpPr>
         <p:spPr>
           <a:xfrm>
-            <a:off x="320040" y="137160"/>
-            <a:ext cx="3657600" cy="274320"/>
+            <a:off x="0" y="0"/>
+            <a:ext cx="12191695" cy="1325880"/>
           </a:xfrm>
           <a:prstGeom prst="rect">
             <a:avLst/>
           </a:prstGeom>
-          <a:noFill/>
-        </p:spPr>
-        <p:txBody>
-          <a:bodyPr wrap="none">
-            <a:spAutoFit/>
-          </a:bodyPr>
-          <a:lstStyle/>
-          <a:p>
-            <a:r>
-              <a:rPr sz="1200" b="1">
-                <a:solidFill>
-                  <a:srgbClr val="106BBF"/>
-                </a:solidFill>
-              </a:rPr>
-              <a:t>INTEL® EES PLATFORM / SMARTUNE 1.5</a:t>
-            </a:r>
-          </a:p>
-        </p:txBody>
-      </p:sp>
-      <p:sp>
-        <p:nvSpPr>
-          <p:cNvPr id="4" name="Rounded Rectangle 3"/>
-          <p:cNvSpPr/>
-          <p:nvPr/>
-        </p:nvSpPr>
-        <p:spPr>
-          <a:xfrm>
-            <a:off x="9966960" y="118872"/>
-            <a:ext cx="1828800" cy="347472"/>
-          </a:xfrm>
-          <a:prstGeom prst="roundRect">
-            <a:avLst/>
-          </a:prstGeom>
           <a:solidFill>
-            <a:srgbClr val="1A2A4C"/>
+            <a:srgbClr val="121F3A"/>
           </a:solidFill>
           <a:ln>
             <a:noFill/>
@@ -3204,165 +3171,208 @@
           <a:lstStyle/>
           <a:p>
             <a:pPr algn="ctr"/>
+          </a:p>
+        </p:txBody>
+      </p:sp>
+      <p:sp>
+        <p:nvSpPr>
+          <p:cNvPr id="4" name="TextBox 3"/>
+          <p:cNvSpPr txBox="1"/>
+          <p:nvPr/>
+        </p:nvSpPr>
+        <p:spPr>
+          <a:xfrm>
+            <a:off x="411480" y="182880"/>
+            <a:ext cx="4114800" cy="182880"/>
+          </a:xfrm>
+          <a:prstGeom prst="rect">
+            <a:avLst/>
+          </a:prstGeom>
+          <a:noFill/>
+        </p:spPr>
+        <p:txBody>
+          <a:bodyPr wrap="none">
+            <a:spAutoFit/>
+          </a:bodyPr>
+          <a:lstStyle/>
+          <a:p>
+            <a:r>
+              <a:rPr sz="1100" b="1">
+                <a:solidFill>
+                  <a:srgbClr val="549DEA"/>
+                </a:solidFill>
+              </a:rPr>
+              <a:t>INTEL® EES PLATFORM  /  SMARTUNE 1.5</a:t>
+            </a:r>
+          </a:p>
+        </p:txBody>
+      </p:sp>
+      <p:sp>
+        <p:nvSpPr>
+          <p:cNvPr id="5" name="TextBox 4"/>
+          <p:cNvSpPr txBox="1"/>
+          <p:nvPr/>
+        </p:nvSpPr>
+        <p:spPr>
+          <a:xfrm>
+            <a:off x="411480" y="411480"/>
+            <a:ext cx="2286000" cy="502920"/>
+          </a:xfrm>
+          <a:prstGeom prst="rect">
+            <a:avLst/>
+          </a:prstGeom>
+          <a:noFill/>
+        </p:spPr>
+        <p:txBody>
+          <a:bodyPr wrap="none">
+            <a:spAutoFit/>
+          </a:bodyPr>
+          <a:lstStyle/>
+          <a:p>
+            <a:r>
+              <a:rPr sz="2600" b="1">
+                <a:solidFill>
+                  <a:srgbClr val="FFFFFF"/>
+                </a:solidFill>
+              </a:rPr>
+              <a:t>SmartTune 1.5</a:t>
+            </a:r>
+          </a:p>
+        </p:txBody>
+      </p:sp>
+      <p:sp>
+        <p:nvSpPr>
+          <p:cNvPr id="6" name="TextBox 5"/>
+          <p:cNvSpPr txBox="1"/>
+          <p:nvPr/>
+        </p:nvSpPr>
+        <p:spPr>
+          <a:xfrm>
+            <a:off x="2697480" y="411480"/>
+            <a:ext cx="6583680" cy="502920"/>
+          </a:xfrm>
+          <a:prstGeom prst="rect">
+            <a:avLst/>
+          </a:prstGeom>
+          <a:noFill/>
+        </p:spPr>
+        <p:txBody>
+          <a:bodyPr wrap="none">
+            <a:spAutoFit/>
+          </a:bodyPr>
+          <a:lstStyle/>
+          <a:p>
+            <a:r>
+              <a:rPr sz="2600" b="1">
+                <a:solidFill>
+                  <a:srgbClr val="549DEA"/>
+                </a:solidFill>
+              </a:rPr>
+              <a:t>AI WORKLOAD OPTIMIZATION HUB</a:t>
+            </a:r>
+          </a:p>
+        </p:txBody>
+      </p:sp>
+      <p:sp>
+        <p:nvSpPr>
+          <p:cNvPr id="7" name="TextBox 6"/>
+          <p:cNvSpPr txBox="1"/>
+          <p:nvPr/>
+        </p:nvSpPr>
+        <p:spPr>
+          <a:xfrm>
+            <a:off x="411480" y="896112"/>
+            <a:ext cx="7863840" cy="228600"/>
+          </a:xfrm>
+          <a:prstGeom prst="rect">
+            <a:avLst/>
+          </a:prstGeom>
+          <a:noFill/>
+        </p:spPr>
+        <p:txBody>
+          <a:bodyPr wrap="none">
+            <a:spAutoFit/>
+          </a:bodyPr>
+          <a:lstStyle/>
+          <a:p>
+            <a:r>
+              <a:rPr sz="1150">
+                <a:solidFill>
+                  <a:srgbClr val="D0D8E7"/>
+                </a:solidFill>
+              </a:rPr>
+              <a:t>A new layout focused on how SmartTune observes, optimizes, and protects Intel® XPU workloads in pilot deployments.</a:t>
+            </a:r>
+          </a:p>
+        </p:txBody>
+      </p:sp>
+      <p:sp>
+        <p:nvSpPr>
+          <p:cNvPr id="8" name="Rounded Rectangle 7"/>
+          <p:cNvSpPr/>
+          <p:nvPr/>
+        </p:nvSpPr>
+        <p:spPr>
+          <a:xfrm>
+            <a:off x="10104120" y="228600"/>
+            <a:ext cx="1691640" cy="384048"/>
+          </a:xfrm>
+          <a:prstGeom prst="roundRect">
+            <a:avLst/>
+          </a:prstGeom>
+          <a:solidFill>
+            <a:srgbClr val="1168BE"/>
+          </a:solidFill>
+          <a:ln>
+            <a:noFill/>
+          </a:ln>
+        </p:spPr>
+        <p:style>
+          <a:lnRef idx="1">
+            <a:schemeClr val="accent1"/>
+          </a:lnRef>
+          <a:fillRef idx="3">
+            <a:schemeClr val="accent1"/>
+          </a:fillRef>
+          <a:effectRef idx="2">
+            <a:schemeClr val="accent1"/>
+          </a:effectRef>
+          <a:fontRef idx="minor">
+            <a:schemeClr val="lt1"/>
+          </a:fontRef>
+        </p:style>
+        <p:txBody>
+          <a:bodyPr rtlCol="0" anchor="ctr"/>
+          <a:lstStyle/>
+          <a:p>
+            <a:pPr algn="ctr"/>
             <a:r>
               <a:rPr sz="1200" b="1">
                 <a:solidFill>
                   <a:srgbClr val="FFFFFF"/>
                 </a:solidFill>
               </a:rPr>
-              <a:t>Q3'26  •  PILOT</a:t>
-            </a:r>
-          </a:p>
-        </p:txBody>
-      </p:sp>
-      <p:sp>
-        <p:nvSpPr>
-          <p:cNvPr id="5" name="TextBox 4"/>
-          <p:cNvSpPr txBox="1"/>
-          <p:nvPr/>
-        </p:nvSpPr>
-        <p:spPr>
-          <a:xfrm>
-            <a:off x="320040" y="566928"/>
-            <a:ext cx="5486400" cy="411480"/>
-          </a:xfrm>
-          <a:prstGeom prst="rect">
-            <a:avLst/>
-          </a:prstGeom>
-          <a:noFill/>
-        </p:spPr>
-        <p:txBody>
-          <a:bodyPr wrap="none">
-            <a:spAutoFit/>
-          </a:bodyPr>
-          <a:lstStyle/>
-          <a:p>
-            <a:r>
-              <a:rPr sz="2600" b="1">
-                <a:solidFill>
-                  <a:srgbClr val="1A2A4C"/>
-                </a:solidFill>
-              </a:rPr>
-              <a:t>SmarTune 1.5</a:t>
-            </a:r>
-          </a:p>
-        </p:txBody>
-      </p:sp>
-      <p:sp>
-        <p:nvSpPr>
-          <p:cNvPr id="6" name="TextBox 5"/>
-          <p:cNvSpPr txBox="1"/>
-          <p:nvPr/>
-        </p:nvSpPr>
-        <p:spPr>
-          <a:xfrm>
-            <a:off x="320040" y="1051560"/>
-            <a:ext cx="5486400" cy="411480"/>
-          </a:xfrm>
-          <a:prstGeom prst="rect">
-            <a:avLst/>
-          </a:prstGeom>
-          <a:noFill/>
-        </p:spPr>
-        <p:txBody>
-          <a:bodyPr wrap="none">
-            <a:spAutoFit/>
-          </a:bodyPr>
-          <a:lstStyle/>
-          <a:p>
-            <a:r>
-              <a:rPr sz="2800" b="1">
-                <a:solidFill>
-                  <a:srgbClr val="106BBF"/>
-                </a:solidFill>
-              </a:rPr>
-              <a:t>SMART PERFORMANCE OPTIMIZATION</a:t>
-            </a:r>
-          </a:p>
-        </p:txBody>
-      </p:sp>
-      <p:sp>
-        <p:nvSpPr>
-          <p:cNvPr id="7" name="TextBox 6"/>
-          <p:cNvSpPr txBox="1"/>
-          <p:nvPr/>
-        </p:nvSpPr>
-        <p:spPr>
-          <a:xfrm>
-            <a:off x="320040" y="1481328"/>
-            <a:ext cx="5486400" cy="411480"/>
-          </a:xfrm>
-          <a:prstGeom prst="rect">
-            <a:avLst/>
-          </a:prstGeom>
-          <a:noFill/>
-        </p:spPr>
-        <p:txBody>
-          <a:bodyPr wrap="none">
-            <a:spAutoFit/>
-          </a:bodyPr>
-          <a:lstStyle/>
-          <a:p>
-            <a:r>
-              <a:rPr sz="2400" b="1">
-                <a:solidFill>
-                  <a:srgbClr val="106BBF"/>
-                </a:solidFill>
-              </a:rPr>
-              <a:t>FOR INTEL® XPU PLATFORMS</a:t>
-            </a:r>
-          </a:p>
-        </p:txBody>
-      </p:sp>
-      <p:sp>
-        <p:nvSpPr>
-          <p:cNvPr id="8" name="TextBox 7"/>
-          <p:cNvSpPr txBox="1"/>
-          <p:nvPr/>
-        </p:nvSpPr>
-        <p:spPr>
-          <a:xfrm>
-            <a:off x="320040" y="1920240"/>
-            <a:ext cx="5486400" cy="411480"/>
-          </a:xfrm>
-          <a:prstGeom prst="rect">
-            <a:avLst/>
-          </a:prstGeom>
-          <a:noFill/>
-        </p:spPr>
-        <p:txBody>
-          <a:bodyPr wrap="none">
-            <a:spAutoFit/>
-          </a:bodyPr>
-          <a:lstStyle/>
-          <a:p>
-            <a:r>
-              <a:rPr sz="1500" b="1">
-                <a:solidFill>
-                  <a:srgbClr val="5B6982"/>
-                </a:solidFill>
-              </a:rPr>
-              <a:t>READY FOR PILOT DEPLOYMENT</a:t>
-            </a:r>
-          </a:p>
-        </p:txBody>
-      </p:sp>
-      <p:sp>
-        <p:nvSpPr>
-          <p:cNvPr id="9" name="Rectangle 8"/>
+              <a:t>Q3'26  PILOT</a:t>
+            </a:r>
+          </a:p>
+        </p:txBody>
+      </p:sp>
+      <p:sp>
+        <p:nvSpPr>
+          <p:cNvPr id="9" name="Rounded Rectangle 8"/>
           <p:cNvSpPr/>
           <p:nvPr/>
         </p:nvSpPr>
         <p:spPr>
           <a:xfrm>
-            <a:off x="320040" y="2331720"/>
-            <a:ext cx="73152" cy="1353312"/>
-          </a:xfrm>
-          <a:prstGeom prst="rect">
+            <a:off x="9829800" y="731520"/>
+            <a:ext cx="1965960" cy="384048"/>
+          </a:xfrm>
+          <a:prstGeom prst="roundRect">
             <a:avLst/>
           </a:prstGeom>
           <a:solidFill>
-            <a:srgbClr val="F7AA2D"/>
+            <a:srgbClr val="223252"/>
           </a:solidFill>
           <a:ln>
             <a:noFill/>
@@ -3387,6 +3397,14 @@
           <a:lstStyle/>
           <a:p>
             <a:pPr algn="ctr"/>
+            <a:r>
+              <a:rPr sz="1050" b="1">
+                <a:solidFill>
+                  <a:srgbClr val="FFFFFF"/>
+                </a:solidFill>
+              </a:rPr>
+              <a:t>Editable customer list</a:t>
+            </a:r>
           </a:p>
         </p:txBody>
       </p:sp>
@@ -3398,17 +3416,19 @@
         </p:nvSpPr>
         <p:spPr>
           <a:xfrm>
-            <a:off x="411480" y="2331720"/>
-            <a:ext cx="6949440" cy="1353312"/>
+            <a:off x="347472" y="1572768"/>
+            <a:ext cx="6858000" cy="4434840"/>
           </a:xfrm>
           <a:prstGeom prst="roundRect">
             <a:avLst/>
           </a:prstGeom>
           <a:solidFill>
-            <a:srgbClr val="141F36"/>
+            <a:srgbClr val="FFFFFF"/>
           </a:solidFill>
           <a:ln>
-            <a:noFill/>
+            <a:solidFill>
+              <a:srgbClr val="D5DDE8"/>
+            </a:solidFill>
           </a:ln>
         </p:spPr>
         <p:style>
@@ -3441,8 +3461,8 @@
         </p:nvSpPr>
         <p:spPr>
           <a:xfrm>
-            <a:off x="594360" y="2505456"/>
-            <a:ext cx="2926080" cy="182880"/>
+            <a:off x="594360" y="1792224"/>
+            <a:ext cx="3474720" cy="201168"/>
           </a:xfrm>
           <a:prstGeom prst="rect">
             <a:avLst/>
@@ -3458,10 +3478,10 @@
             <a:r>
               <a:rPr sz="1200" b="1">
                 <a:solidFill>
-                  <a:srgbClr val="26B370"/>
+                  <a:srgbClr val="1168BE"/>
                 </a:solidFill>
               </a:rPr>
-              <a:t>CORE OPTIMIZATION LAYER  /  WHAT IT DOES</a:t>
+              <a:t>WHAT THE MIDDLE SECTION SHOWS</a:t>
             </a:r>
           </a:p>
         </p:txBody>
@@ -3474,8 +3494,8 @@
         </p:nvSpPr>
         <p:spPr>
           <a:xfrm>
-            <a:off x="594360" y="2761488"/>
-            <a:ext cx="6355080" cy="594360"/>
+            <a:off x="594360" y="1993392"/>
+            <a:ext cx="6126480" cy="402336"/>
           </a:xfrm>
           <a:prstGeom prst="rect">
             <a:avLst/>
@@ -3488,74 +3508,144 @@
           </a:bodyPr>
           <a:lstStyle/>
           <a:p>
+            <a:r>
+              <a:rPr sz="1900" b="1">
+                <a:solidFill>
+                  <a:srgbClr val="121F3A"/>
+                </a:solidFill>
+              </a:rPr>
+              <a:t>A hub-and-spoke workflow that explains SmartTune’s role in the platform.</a:t>
+            </a:r>
+          </a:p>
+        </p:txBody>
+      </p:sp>
+      <p:sp>
+        <p:nvSpPr>
+          <p:cNvPr id="13" name="TextBox 12"/>
+          <p:cNvSpPr txBox="1"/>
+          <p:nvPr/>
+        </p:nvSpPr>
+        <p:spPr>
+          <a:xfrm>
+            <a:off x="594360" y="2377440"/>
+            <a:ext cx="6126480" cy="457200"/>
+          </a:xfrm>
+          <a:prstGeom prst="rect">
+            <a:avLst/>
+          </a:prstGeom>
+          <a:noFill/>
+        </p:spPr>
+        <p:txBody>
+          <a:bodyPr wrap="square">
+            <a:spAutoFit/>
+          </a:bodyPr>
+          <a:lstStyle/>
+          <a:p>
+            <a:r>
+              <a:rPr sz="1050">
+                <a:solidFill>
+                  <a:srgbClr val="4C5C76"/>
+                </a:solidFill>
+              </a:rPr>
+              <a:t>It highlights the core optimization loop: sense system pressure, balance resources automatically, and protect critical applications so teams can reach production readiness faster.</a:t>
+            </a:r>
+          </a:p>
+        </p:txBody>
+      </p:sp>
+      <p:sp>
+        <p:nvSpPr>
+          <p:cNvPr id="14" name="Oval 13"/>
+          <p:cNvSpPr/>
+          <p:nvPr/>
+        </p:nvSpPr>
+        <p:spPr>
+          <a:xfrm>
+            <a:off x="2514600" y="3063240"/>
+            <a:ext cx="2194560" cy="1325880"/>
+          </a:xfrm>
+          <a:prstGeom prst="ellipse">
+            <a:avLst/>
+          </a:prstGeom>
+          <a:solidFill>
+            <a:srgbClr val="121F3A"/>
+          </a:solidFill>
+          <a:ln>
+            <a:noFill/>
+          </a:ln>
+        </p:spPr>
+        <p:style>
+          <a:lnRef idx="1">
+            <a:schemeClr val="accent1"/>
+          </a:lnRef>
+          <a:fillRef idx="3">
+            <a:schemeClr val="accent1"/>
+          </a:fillRef>
+          <a:effectRef idx="2">
+            <a:schemeClr val="accent1"/>
+          </a:effectRef>
+          <a:fontRef idx="minor">
+            <a:schemeClr val="lt1"/>
+          </a:fontRef>
+        </p:style>
+        <p:txBody>
+          <a:bodyPr rtlCol="0" anchor="ctr"/>
+          <a:lstStyle/>
+          <a:p>
+            <a:pPr algn="ctr"/>
+          </a:p>
+        </p:txBody>
+      </p:sp>
+      <p:sp>
+        <p:nvSpPr>
+          <p:cNvPr id="15" name="TextBox 14"/>
+          <p:cNvSpPr txBox="1"/>
+          <p:nvPr/>
+        </p:nvSpPr>
+        <p:spPr>
+          <a:xfrm>
+            <a:off x="2743200" y="3410712"/>
+            <a:ext cx="1737360" cy="502920"/>
+          </a:xfrm>
+          <a:prstGeom prst="rect">
+            <a:avLst/>
+          </a:prstGeom>
+          <a:noFill/>
+        </p:spPr>
+        <p:txBody>
+          <a:bodyPr wrap="none">
+            <a:spAutoFit/>
+          </a:bodyPr>
+          <a:lstStyle/>
+          <a:p>
+            <a:pPr algn="ctr"/>
             <a:r>
               <a:rPr sz="1800" b="1">
                 <a:solidFill>
                   <a:srgbClr val="FFFFFF"/>
                 </a:solidFill>
               </a:rPr>
-              <a:t>SmartTune is the control center for Intel® XPU workload optimization — </a:t>
-            </a:r>
-            <a:r>
-              <a:rPr sz="1800">
-                <a:solidFill>
-                  <a:srgbClr val="FFFFFF"/>
-                </a:solidFill>
-              </a:rPr>
-              <a:t>monitoring system pressure, balancing resources, and applying policy-based tuning to keep AI and graphics workloads responsive.</a:t>
-            </a:r>
-          </a:p>
-        </p:txBody>
-      </p:sp>
-      <p:sp>
-        <p:nvSpPr>
-          <p:cNvPr id="13" name="TextBox 12"/>
-          <p:cNvSpPr txBox="1"/>
-          <p:nvPr/>
-        </p:nvSpPr>
-        <p:spPr>
-          <a:xfrm>
-            <a:off x="594360" y="3319272"/>
-            <a:ext cx="6355080" cy="228600"/>
-          </a:xfrm>
-          <a:prstGeom prst="rect">
-            <a:avLst/>
-          </a:prstGeom>
-          <a:noFill/>
-        </p:spPr>
-        <p:txBody>
-          <a:bodyPr wrap="none">
-            <a:spAutoFit/>
-          </a:bodyPr>
-          <a:lstStyle/>
-          <a:p>
-            <a:r>
-              <a:rPr sz="1050">
-                <a:solidFill>
-                  <a:srgbClr val="D0D8E7"/>
-                </a:solidFill>
-              </a:rPr>
-              <a:t>It reduces manual tuning effort, protects critical applications, and speeds platform bring-up for production deployments.</a:t>
-            </a:r>
-          </a:p>
-        </p:txBody>
-      </p:sp>
-      <p:sp>
-        <p:nvSpPr>
-          <p:cNvPr id="14" name="Oval 13"/>
+              <a:t>SMARTUNE
+OPTIMIZATION HUB</a:t>
+            </a:r>
+          </a:p>
+        </p:txBody>
+      </p:sp>
+      <p:sp>
+        <p:nvSpPr>
+          <p:cNvPr id="16" name="Rounded Rectangle 15"/>
           <p:cNvSpPr/>
           <p:nvPr/>
         </p:nvSpPr>
         <p:spPr>
           <a:xfrm>
-            <a:off x="7635240" y="566928"/>
-            <a:ext cx="3886200" cy="3063240"/>
-          </a:xfrm>
-          <a:prstGeom prst="ellipse">
+            <a:off x="822960" y="3200400"/>
+            <a:ext cx="2148840" cy="914400"/>
+          </a:xfrm>
+          <a:prstGeom prst="roundRect">
             <a:avLst/>
           </a:prstGeom>
           <a:solidFill>
-            <a:srgbClr val="E6ECF6"/>
+            <a:srgbClr val="E8EEF7"/>
           </a:solidFill>
           <a:ln>
             <a:noFill/>
@@ -3583,9 +3673,573 @@
           </a:p>
         </p:txBody>
       </p:sp>
+      <p:sp>
+        <p:nvSpPr>
+          <p:cNvPr id="17" name="Rounded Rectangle 16"/>
+          <p:cNvSpPr/>
+          <p:nvPr/>
+        </p:nvSpPr>
+        <p:spPr>
+          <a:xfrm>
+            <a:off x="932688" y="3291840"/>
+            <a:ext cx="822960" cy="201168"/>
+          </a:xfrm>
+          <a:prstGeom prst="roundRect">
+            <a:avLst/>
+          </a:prstGeom>
+          <a:solidFill>
+            <a:srgbClr val="1168BE"/>
+          </a:solidFill>
+          <a:ln>
+            <a:noFill/>
+          </a:ln>
+        </p:spPr>
+        <p:style>
+          <a:lnRef idx="1">
+            <a:schemeClr val="accent1"/>
+          </a:lnRef>
+          <a:fillRef idx="3">
+            <a:schemeClr val="accent1"/>
+          </a:fillRef>
+          <a:effectRef idx="2">
+            <a:schemeClr val="accent1"/>
+          </a:effectRef>
+          <a:fontRef idx="minor">
+            <a:schemeClr val="lt1"/>
+          </a:fontRef>
+        </p:style>
+        <p:txBody>
+          <a:bodyPr rtlCol="0" anchor="ctr"/>
+          <a:lstStyle/>
+          <a:p>
+            <a:pPr algn="ctr"/>
+            <a:r>
+              <a:rPr sz="900" b="1">
+                <a:solidFill>
+                  <a:srgbClr val="FFFFFF"/>
+                </a:solidFill>
+              </a:rPr>
+              <a:t>01  OBSERVE</a:t>
+            </a:r>
+          </a:p>
+        </p:txBody>
+      </p:sp>
+      <p:sp>
+        <p:nvSpPr>
+          <p:cNvPr id="18" name="TextBox 17"/>
+          <p:cNvSpPr txBox="1"/>
+          <p:nvPr/>
+        </p:nvSpPr>
+        <p:spPr>
+          <a:xfrm>
+            <a:off x="950976" y="3566160"/>
+            <a:ext cx="1874519" cy="438912"/>
+          </a:xfrm>
+          <a:prstGeom prst="rect">
+            <a:avLst/>
+          </a:prstGeom>
+          <a:noFill/>
+        </p:spPr>
+        <p:txBody>
+          <a:bodyPr wrap="square">
+            <a:spAutoFit/>
+          </a:bodyPr>
+          <a:lstStyle/>
+          <a:p>
+            <a:r>
+              <a:rPr sz="950">
+                <a:solidFill>
+                  <a:srgbClr val="121F3A"/>
+                </a:solidFill>
+              </a:rPr>
+              <a:t>Collects CPU, memory, disk, GPU, and NPU telemetry to detect bottlenecks in real time.</a:t>
+            </a:r>
+          </a:p>
+        </p:txBody>
+      </p:sp>
+      <p:sp>
+        <p:nvSpPr>
+          <p:cNvPr id="19" name="Rounded Rectangle 18"/>
+          <p:cNvSpPr/>
+          <p:nvPr/>
+        </p:nvSpPr>
+        <p:spPr>
+          <a:xfrm>
+            <a:off x="4800600" y="2743200"/>
+            <a:ext cx="2148840" cy="914400"/>
+          </a:xfrm>
+          <a:prstGeom prst="roundRect">
+            <a:avLst/>
+          </a:prstGeom>
+          <a:solidFill>
+            <a:srgbClr val="E8EEF7"/>
+          </a:solidFill>
+          <a:ln>
+            <a:noFill/>
+          </a:ln>
+        </p:spPr>
+        <p:style>
+          <a:lnRef idx="1">
+            <a:schemeClr val="accent1"/>
+          </a:lnRef>
+          <a:fillRef idx="3">
+            <a:schemeClr val="accent1"/>
+          </a:fillRef>
+          <a:effectRef idx="2">
+            <a:schemeClr val="accent1"/>
+          </a:effectRef>
+          <a:fontRef idx="minor">
+            <a:schemeClr val="lt1"/>
+          </a:fontRef>
+        </p:style>
+        <p:txBody>
+          <a:bodyPr rtlCol="0" anchor="ctr"/>
+          <a:lstStyle/>
+          <a:p>
+            <a:pPr algn="ctr"/>
+          </a:p>
+        </p:txBody>
+      </p:sp>
+      <p:sp>
+        <p:nvSpPr>
+          <p:cNvPr id="20" name="Rounded Rectangle 19"/>
+          <p:cNvSpPr/>
+          <p:nvPr/>
+        </p:nvSpPr>
+        <p:spPr>
+          <a:xfrm>
+            <a:off x="4910328" y="2834640"/>
+            <a:ext cx="822960" cy="201168"/>
+          </a:xfrm>
+          <a:prstGeom prst="roundRect">
+            <a:avLst/>
+          </a:prstGeom>
+          <a:solidFill>
+            <a:srgbClr val="1FB177"/>
+          </a:solidFill>
+          <a:ln>
+            <a:noFill/>
+          </a:ln>
+        </p:spPr>
+        <p:style>
+          <a:lnRef idx="1">
+            <a:schemeClr val="accent1"/>
+          </a:lnRef>
+          <a:fillRef idx="3">
+            <a:schemeClr val="accent1"/>
+          </a:fillRef>
+          <a:effectRef idx="2">
+            <a:schemeClr val="accent1"/>
+          </a:effectRef>
+          <a:fontRef idx="minor">
+            <a:schemeClr val="lt1"/>
+          </a:fontRef>
+        </p:style>
+        <p:txBody>
+          <a:bodyPr rtlCol="0" anchor="ctr"/>
+          <a:lstStyle/>
+          <a:p>
+            <a:pPr algn="ctr"/>
+            <a:r>
+              <a:rPr sz="900" b="1">
+                <a:solidFill>
+                  <a:srgbClr val="FFFFFF"/>
+                </a:solidFill>
+              </a:rPr>
+              <a:t>02  OPTIMIZE</a:t>
+            </a:r>
+          </a:p>
+        </p:txBody>
+      </p:sp>
+      <p:sp>
+        <p:nvSpPr>
+          <p:cNvPr id="21" name="TextBox 20"/>
+          <p:cNvSpPr txBox="1"/>
+          <p:nvPr/>
+        </p:nvSpPr>
+        <p:spPr>
+          <a:xfrm>
+            <a:off x="4928616" y="3108960"/>
+            <a:ext cx="1874519" cy="438912"/>
+          </a:xfrm>
+          <a:prstGeom prst="rect">
+            <a:avLst/>
+          </a:prstGeom>
+          <a:noFill/>
+        </p:spPr>
+        <p:txBody>
+          <a:bodyPr wrap="square">
+            <a:spAutoFit/>
+          </a:bodyPr>
+          <a:lstStyle/>
+          <a:p>
+            <a:r>
+              <a:rPr sz="950">
+                <a:solidFill>
+                  <a:srgbClr val="121F3A"/>
+                </a:solidFill>
+              </a:rPr>
+              <a:t>Applies policy-based balancing, launch queuing, and cgroup controls to keep workloads efficient.</a:t>
+            </a:r>
+          </a:p>
+        </p:txBody>
+      </p:sp>
+      <p:sp>
+        <p:nvSpPr>
+          <p:cNvPr id="22" name="Rounded Rectangle 21"/>
+          <p:cNvSpPr/>
+          <p:nvPr/>
+        </p:nvSpPr>
+        <p:spPr>
+          <a:xfrm>
+            <a:off x="1965960" y="4663440"/>
+            <a:ext cx="2148840" cy="914400"/>
+          </a:xfrm>
+          <a:prstGeom prst="roundRect">
+            <a:avLst/>
+          </a:prstGeom>
+          <a:solidFill>
+            <a:srgbClr val="E8EEF7"/>
+          </a:solidFill>
+          <a:ln>
+            <a:noFill/>
+          </a:ln>
+        </p:spPr>
+        <p:style>
+          <a:lnRef idx="1">
+            <a:schemeClr val="accent1"/>
+          </a:lnRef>
+          <a:fillRef idx="3">
+            <a:schemeClr val="accent1"/>
+          </a:fillRef>
+          <a:effectRef idx="2">
+            <a:schemeClr val="accent1"/>
+          </a:effectRef>
+          <a:fontRef idx="minor">
+            <a:schemeClr val="lt1"/>
+          </a:fontRef>
+        </p:style>
+        <p:txBody>
+          <a:bodyPr rtlCol="0" anchor="ctr"/>
+          <a:lstStyle/>
+          <a:p>
+            <a:pPr algn="ctr"/>
+          </a:p>
+        </p:txBody>
+      </p:sp>
+      <p:sp>
+        <p:nvSpPr>
+          <p:cNvPr id="23" name="Rounded Rectangle 22"/>
+          <p:cNvSpPr/>
+          <p:nvPr/>
+        </p:nvSpPr>
+        <p:spPr>
+          <a:xfrm>
+            <a:off x="2075688" y="4754879"/>
+            <a:ext cx="822960" cy="201168"/>
+          </a:xfrm>
+          <a:prstGeom prst="roundRect">
+            <a:avLst/>
+          </a:prstGeom>
+          <a:solidFill>
+            <a:srgbClr val="F7AA2E"/>
+          </a:solidFill>
+          <a:ln>
+            <a:noFill/>
+          </a:ln>
+        </p:spPr>
+        <p:style>
+          <a:lnRef idx="1">
+            <a:schemeClr val="accent1"/>
+          </a:lnRef>
+          <a:fillRef idx="3">
+            <a:schemeClr val="accent1"/>
+          </a:fillRef>
+          <a:effectRef idx="2">
+            <a:schemeClr val="accent1"/>
+          </a:effectRef>
+          <a:fontRef idx="minor">
+            <a:schemeClr val="lt1"/>
+          </a:fontRef>
+        </p:style>
+        <p:txBody>
+          <a:bodyPr rtlCol="0" anchor="ctr"/>
+          <a:lstStyle/>
+          <a:p>
+            <a:pPr algn="ctr"/>
+            <a:r>
+              <a:rPr sz="900" b="1">
+                <a:solidFill>
+                  <a:srgbClr val="FFFFFF"/>
+                </a:solidFill>
+              </a:rPr>
+              <a:t>03  PROTECT</a:t>
+            </a:r>
+          </a:p>
+        </p:txBody>
+      </p:sp>
+      <p:sp>
+        <p:nvSpPr>
+          <p:cNvPr id="24" name="TextBox 23"/>
+          <p:cNvSpPr txBox="1"/>
+          <p:nvPr/>
+        </p:nvSpPr>
+        <p:spPr>
+          <a:xfrm>
+            <a:off x="2093976" y="5029200"/>
+            <a:ext cx="1874519" cy="438912"/>
+          </a:xfrm>
+          <a:prstGeom prst="rect">
+            <a:avLst/>
+          </a:prstGeom>
+          <a:noFill/>
+        </p:spPr>
+        <p:txBody>
+          <a:bodyPr wrap="square">
+            <a:spAutoFit/>
+          </a:bodyPr>
+          <a:lstStyle/>
+          <a:p>
+            <a:r>
+              <a:rPr sz="950">
+                <a:solidFill>
+                  <a:srgbClr val="121F3A"/>
+                </a:solidFill>
+              </a:rPr>
+              <a:t>Preserves responsiveness for critical applications with keep-alive and priority-aware recovery.</a:t>
+            </a:r>
+          </a:p>
+        </p:txBody>
+      </p:sp>
+      <p:cxnSp>
+        <p:nvCxnSpPr>
+          <p:cNvPr id="25" name="Connector 24"/>
+          <p:cNvCxnSpPr/>
+          <p:nvPr/>
+        </p:nvCxnSpPr>
+        <p:spPr>
+          <a:xfrm>
+            <a:off x="2514600" y="3703320"/>
+            <a:ext cx="411480" cy="0"/>
+          </a:xfrm>
+          <a:prstGeom prst="line">
+            <a:avLst/>
+          </a:prstGeom>
+          <a:ln w="28575">
+            <a:solidFill>
+              <a:srgbClr val="1168BE"/>
+            </a:solidFill>
+          </a:ln>
+        </p:spPr>
+        <p:style>
+          <a:lnRef idx="2">
+            <a:schemeClr val="accent1"/>
+          </a:lnRef>
+          <a:fillRef idx="0">
+            <a:schemeClr val="accent1"/>
+          </a:fillRef>
+          <a:effectRef idx="1">
+            <a:schemeClr val="accent1"/>
+          </a:effectRef>
+          <a:fontRef idx="minor">
+            <a:schemeClr val="tx1"/>
+          </a:fontRef>
+        </p:style>
+      </p:cxnSp>
+      <p:cxnSp>
+        <p:nvCxnSpPr>
+          <p:cNvPr id="26" name="Connector 25"/>
+          <p:cNvCxnSpPr/>
+          <p:nvPr/>
+        </p:nvCxnSpPr>
+        <p:spPr>
+          <a:xfrm flipV="1">
+            <a:off x="4709160" y="3429000"/>
+            <a:ext cx="91440" cy="228600"/>
+          </a:xfrm>
+          <a:prstGeom prst="line">
+            <a:avLst/>
+          </a:prstGeom>
+          <a:ln w="28575">
+            <a:solidFill>
+              <a:srgbClr val="1FB177"/>
+            </a:solidFill>
+          </a:ln>
+        </p:spPr>
+        <p:style>
+          <a:lnRef idx="2">
+            <a:schemeClr val="accent1"/>
+          </a:lnRef>
+          <a:fillRef idx="0">
+            <a:schemeClr val="accent1"/>
+          </a:fillRef>
+          <a:effectRef idx="1">
+            <a:schemeClr val="accent1"/>
+          </a:effectRef>
+          <a:fontRef idx="minor">
+            <a:schemeClr val="tx1"/>
+          </a:fontRef>
+        </p:style>
+      </p:cxnSp>
+      <p:cxnSp>
+        <p:nvCxnSpPr>
+          <p:cNvPr id="27" name="Connector 26"/>
+          <p:cNvCxnSpPr/>
+          <p:nvPr/>
+        </p:nvCxnSpPr>
+        <p:spPr>
+          <a:xfrm flipH="1">
+            <a:off x="3291840" y="4389120"/>
+            <a:ext cx="320040" cy="274320"/>
+          </a:xfrm>
+          <a:prstGeom prst="line">
+            <a:avLst/>
+          </a:prstGeom>
+          <a:ln w="28575">
+            <a:solidFill>
+              <a:srgbClr val="F7AA2E"/>
+            </a:solidFill>
+          </a:ln>
+        </p:spPr>
+        <p:style>
+          <a:lnRef idx="2">
+            <a:schemeClr val="accent1"/>
+          </a:lnRef>
+          <a:fillRef idx="0">
+            <a:schemeClr val="accent1"/>
+          </a:fillRef>
+          <a:effectRef idx="1">
+            <a:schemeClr val="accent1"/>
+          </a:effectRef>
+          <a:fontRef idx="minor">
+            <a:schemeClr val="tx1"/>
+          </a:fontRef>
+        </p:style>
+      </p:cxnSp>
+      <p:sp>
+        <p:nvSpPr>
+          <p:cNvPr id="28" name="Rounded Rectangle 27"/>
+          <p:cNvSpPr/>
+          <p:nvPr/>
+        </p:nvSpPr>
+        <p:spPr>
+          <a:xfrm>
+            <a:off x="7388352" y="1572768"/>
+            <a:ext cx="4462272" cy="4434840"/>
+          </a:xfrm>
+          <a:prstGeom prst="roundRect">
+            <a:avLst/>
+          </a:prstGeom>
+          <a:solidFill>
+            <a:srgbClr val="FFFFFF"/>
+          </a:solidFill>
+          <a:ln>
+            <a:solidFill>
+              <a:srgbClr val="D5DDE8"/>
+            </a:solidFill>
+          </a:ln>
+        </p:spPr>
+        <p:style>
+          <a:lnRef idx="1">
+            <a:schemeClr val="accent1"/>
+          </a:lnRef>
+          <a:fillRef idx="3">
+            <a:schemeClr val="accent1"/>
+          </a:fillRef>
+          <a:effectRef idx="2">
+            <a:schemeClr val="accent1"/>
+          </a:effectRef>
+          <a:fontRef idx="minor">
+            <a:schemeClr val="lt1"/>
+          </a:fontRef>
+        </p:style>
+        <p:txBody>
+          <a:bodyPr rtlCol="0" anchor="ctr"/>
+          <a:lstStyle/>
+          <a:p>
+            <a:pPr algn="ctr"/>
+          </a:p>
+        </p:txBody>
+      </p:sp>
+      <p:sp>
+        <p:nvSpPr>
+          <p:cNvPr id="29" name="TextBox 28"/>
+          <p:cNvSpPr txBox="1"/>
+          <p:nvPr/>
+        </p:nvSpPr>
+        <p:spPr>
+          <a:xfrm>
+            <a:off x="7635240" y="1792224"/>
+            <a:ext cx="2926080" cy="201168"/>
+          </a:xfrm>
+          <a:prstGeom prst="rect">
+            <a:avLst/>
+          </a:prstGeom>
+          <a:noFill/>
+        </p:spPr>
+        <p:txBody>
+          <a:bodyPr wrap="none">
+            <a:spAutoFit/>
+          </a:bodyPr>
+          <a:lstStyle/>
+          <a:p>
+            <a:r>
+              <a:rPr sz="1200" b="1">
+                <a:solidFill>
+                  <a:srgbClr val="1168BE"/>
+                </a:solidFill>
+              </a:rPr>
+              <a:t>PLATFORM SNAPSHOT</a:t>
+            </a:r>
+          </a:p>
+        </p:txBody>
+      </p:sp>
+      <p:sp>
+        <p:nvSpPr>
+          <p:cNvPr id="30" name="Rounded Rectangle 29"/>
+          <p:cNvSpPr/>
+          <p:nvPr/>
+        </p:nvSpPr>
+        <p:spPr>
+          <a:xfrm>
+            <a:off x="7635240" y="2029968"/>
+            <a:ext cx="3977639" cy="1645920"/>
+          </a:xfrm>
+          <a:prstGeom prst="roundRect">
+            <a:avLst/>
+          </a:prstGeom>
+          <a:solidFill>
+            <a:srgbClr val="E8EEF7"/>
+          </a:solidFill>
+          <a:ln>
+            <a:noFill/>
+          </a:ln>
+        </p:spPr>
+        <p:style>
+          <a:lnRef idx="1">
+            <a:schemeClr val="accent1"/>
+          </a:lnRef>
+          <a:fillRef idx="3">
+            <a:schemeClr val="accent1"/>
+          </a:fillRef>
+          <a:effectRef idx="2">
+            <a:schemeClr val="accent1"/>
+          </a:effectRef>
+          <a:fontRef idx="minor">
+            <a:schemeClr val="lt1"/>
+          </a:fontRef>
+        </p:style>
+        <p:txBody>
+          <a:bodyPr rtlCol="0" anchor="ctr"/>
+          <a:lstStyle/>
+          <a:p>
+            <a:pPr algn="ctr"/>
+          </a:p>
+        </p:txBody>
+      </p:sp>
       <p:pic>
         <p:nvPicPr>
-          <p:cNvPr id="15" name="Picture 14" descr="architecture_15.png"/>
+          <p:cNvPr id="31" name="Picture 30" descr="architecture_15.png"/>
           <p:cNvPicPr>
             <a:picLocks noChangeAspect="1"/>
           </p:cNvPicPr>
@@ -3599,8 +4253,8 @@
         </p:blipFill>
         <p:spPr>
           <a:xfrm>
-            <a:off x="7909560" y="932688"/>
-            <a:ext cx="3108960" cy="1294351"/>
+            <a:off x="7818120" y="2212848"/>
+            <a:ext cx="3611880" cy="1503731"/>
           </a:xfrm>
           <a:prstGeom prst="rect">
             <a:avLst/>
@@ -3609,14 +4263,14 @@
       </p:pic>
       <p:sp>
         <p:nvSpPr>
-          <p:cNvPr id="16" name="TextBox 15"/>
+          <p:cNvPr id="32" name="TextBox 31"/>
           <p:cNvSpPr txBox="1"/>
           <p:nvPr/>
         </p:nvSpPr>
         <p:spPr>
           <a:xfrm>
-            <a:off x="8732520" y="3419856"/>
-            <a:ext cx="2286000" cy="274320"/>
+            <a:off x="7699248" y="3822191"/>
+            <a:ext cx="3657600" cy="237744"/>
           </a:xfrm>
           <a:prstGeom prst="rect">
             <a:avLst/>
@@ -3629,106 +4283,36 @@
           </a:bodyPr>
           <a:lstStyle/>
           <a:p>
-            <a:pPr algn="ctr"/>
-            <a:r>
-              <a:rPr sz="1300" b="1">
+            <a:r>
+              <a:rPr sz="1200" b="1">
                 <a:solidFill>
-                  <a:srgbClr val="1A2A4C"/>
+                  <a:srgbClr val="121F3A"/>
                 </a:solidFill>
               </a:rPr>
-              <a:t>SMARTUNE ARCHITECTURE</a:t>
-            </a:r>
-          </a:p>
-        </p:txBody>
-      </p:sp>
-      <p:sp>
-        <p:nvSpPr>
-          <p:cNvPr id="17" name="TextBox 16"/>
-          <p:cNvSpPr txBox="1"/>
-          <p:nvPr/>
-        </p:nvSpPr>
-        <p:spPr>
-          <a:xfrm>
-            <a:off x="8366760" y="3657600"/>
-            <a:ext cx="2926080" cy="292608"/>
-          </a:xfrm>
-          <a:prstGeom prst="rect">
-            <a:avLst/>
-          </a:prstGeom>
-          <a:noFill/>
-        </p:spPr>
-        <p:txBody>
-          <a:bodyPr wrap="none">
-            <a:spAutoFit/>
-          </a:bodyPr>
-          <a:lstStyle/>
-          <a:p>
-            <a:pPr algn="ctr"/>
-            <a:r>
-              <a:rPr sz="950">
-                <a:solidFill>
-                  <a:srgbClr val="5B6982"/>
-                </a:solidFill>
-              </a:rPr>
-              <a:t>Telemetry, policy control, and workload governance in one platform.</a:t>
-            </a:r>
-          </a:p>
-        </p:txBody>
-      </p:sp>
-      <p:sp>
-        <p:nvSpPr>
-          <p:cNvPr id="18" name="TextBox 17"/>
-          <p:cNvSpPr txBox="1"/>
-          <p:nvPr/>
-        </p:nvSpPr>
-        <p:spPr>
-          <a:xfrm>
-            <a:off x="320040" y="3803904"/>
-            <a:ext cx="3657600" cy="256032"/>
-          </a:xfrm>
-          <a:prstGeom prst="rect">
-            <a:avLst/>
-          </a:prstGeom>
-          <a:noFill/>
-        </p:spPr>
-        <p:txBody>
-          <a:bodyPr wrap="none">
-            <a:spAutoFit/>
-          </a:bodyPr>
-          <a:lstStyle/>
-          <a:p>
-            <a:r>
-              <a:rPr sz="1100" b="1">
-                <a:solidFill>
-                  <a:srgbClr val="5B6982"/>
-                </a:solidFill>
-              </a:rPr>
-              <a:t>SMARTUNE VALUE HIGHLIGHTS</a:t>
-            </a:r>
-          </a:p>
-        </p:txBody>
-      </p:sp>
-      <p:sp>
-        <p:nvSpPr>
-          <p:cNvPr id="19" name="Rounded Rectangle 18"/>
+              <a:t>WHY IT MATTERS</a:t>
+            </a:r>
+          </a:p>
+        </p:txBody>
+      </p:sp>
+      <p:sp>
+        <p:nvSpPr>
+          <p:cNvPr id="33" name="Oval 32"/>
           <p:cNvSpPr/>
           <p:nvPr/>
         </p:nvSpPr>
         <p:spPr>
           <a:xfrm>
-            <a:off x="320040" y="4005072"/>
-            <a:ext cx="3017520" cy="1234440"/>
-          </a:xfrm>
-          <a:prstGeom prst="roundRect">
+            <a:off x="7726679" y="4169663"/>
+            <a:ext cx="109728" cy="109728"/>
+          </a:xfrm>
+          <a:prstGeom prst="ellipse">
             <a:avLst/>
           </a:prstGeom>
           <a:solidFill>
-            <a:srgbClr val="FFFFFF"/>
+            <a:srgbClr val="1168BE"/>
           </a:solidFill>
-          <a:ln w="12700">
-            <a:solidFill>
-              <a:srgbClr val="D7E0EC"/>
-            </a:solidFill>
+          <a:ln>
+            <a:noFill/>
           </a:ln>
         </p:spPr>
         <p:style>
@@ -3755,20 +4339,53 @@
       </p:sp>
       <p:sp>
         <p:nvSpPr>
-          <p:cNvPr id="20" name="Rectangle 19"/>
-          <p:cNvSpPr/>
+          <p:cNvPr id="34" name="TextBox 33"/>
+          <p:cNvSpPr txBox="1"/>
           <p:nvPr/>
         </p:nvSpPr>
         <p:spPr>
           <a:xfrm>
-            <a:off x="320040" y="4005072"/>
-            <a:ext cx="73152" cy="1234440"/>
+            <a:off x="7909560" y="4133087"/>
+            <a:ext cx="3611880" cy="256032"/>
           </a:xfrm>
           <a:prstGeom prst="rect">
             <a:avLst/>
           </a:prstGeom>
+          <a:noFill/>
+        </p:spPr>
+        <p:txBody>
+          <a:bodyPr wrap="square">
+            <a:spAutoFit/>
+          </a:bodyPr>
+          <a:lstStyle/>
+          <a:p>
+            <a:r>
+              <a:rPr sz="1000">
+                <a:solidFill>
+                  <a:srgbClr val="4C5C76"/>
+                </a:solidFill>
+              </a:rPr>
+              <a:t>Reduces manual tuning effort across heterogeneous Intel® XPU workloads.</a:t>
+            </a:r>
+          </a:p>
+        </p:txBody>
+      </p:sp>
+      <p:sp>
+        <p:nvSpPr>
+          <p:cNvPr id="35" name="Oval 34"/>
+          <p:cNvSpPr/>
+          <p:nvPr/>
+        </p:nvSpPr>
+        <p:spPr>
+          <a:xfrm>
+            <a:off x="7726679" y="4608576"/>
+            <a:ext cx="109728" cy="109728"/>
+          </a:xfrm>
+          <a:prstGeom prst="ellipse">
+            <a:avLst/>
+          </a:prstGeom>
           <a:solidFill>
-            <a:srgbClr val="106BBF"/>
+            <a:srgbClr val="1FB177"/>
           </a:solidFill>
           <a:ln>
             <a:noFill/>
@@ -3798,14 +4415,14 @@
       </p:sp>
       <p:sp>
         <p:nvSpPr>
-          <p:cNvPr id="21" name="TextBox 20"/>
+          <p:cNvPr id="36" name="TextBox 35"/>
           <p:cNvSpPr txBox="1"/>
           <p:nvPr/>
         </p:nvSpPr>
         <p:spPr>
           <a:xfrm>
-            <a:off x="484632" y="4169663"/>
-            <a:ext cx="411480" cy="256032"/>
+            <a:off x="7909560" y="4572000"/>
+            <a:ext cx="3611880" cy="256032"/>
           </a:xfrm>
           <a:prstGeom prst="rect">
             <a:avLst/>
@@ -3813,109 +4430,41 @@
           <a:noFill/>
         </p:spPr>
         <p:txBody>
-          <a:bodyPr wrap="none">
-            <a:spAutoFit/>
-          </a:bodyPr>
-          <a:lstStyle/>
-          <a:p>
-            <a:r>
-              <a:rPr sz="1800" b="1">
-                <a:solidFill>
-                  <a:srgbClr val="106BBF"/>
-                </a:solidFill>
-              </a:rPr>
-              <a:t>01</a:t>
-            </a:r>
-          </a:p>
-        </p:txBody>
-      </p:sp>
-      <p:sp>
-        <p:nvSpPr>
-          <p:cNvPr id="22" name="TextBox 21"/>
-          <p:cNvSpPr txBox="1"/>
-          <p:nvPr/>
-        </p:nvSpPr>
-        <p:spPr>
-          <a:xfrm>
-            <a:off x="978407" y="4114800"/>
-            <a:ext cx="2148840" cy="329184"/>
-          </a:xfrm>
-          <a:prstGeom prst="rect">
-            <a:avLst/>
-          </a:prstGeom>
-          <a:noFill/>
-        </p:spPr>
-        <p:txBody>
           <a:bodyPr wrap="square">
             <a:spAutoFit/>
           </a:bodyPr>
           <a:lstStyle/>
           <a:p>
             <a:r>
-              <a:rPr sz="1200" b="1">
+              <a:rPr sz="1000">
                 <a:solidFill>
-                  <a:srgbClr val="1A2A4C"/>
+                  <a:srgbClr val="4C5C76"/>
                 </a:solidFill>
               </a:rPr>
-              <a:t>REAL-TIME PRESSURE INSIGHT</a:t>
-            </a:r>
-          </a:p>
-        </p:txBody>
-      </p:sp>
-      <p:sp>
-        <p:nvSpPr>
-          <p:cNvPr id="23" name="TextBox 22"/>
-          <p:cNvSpPr txBox="1"/>
-          <p:nvPr/>
-        </p:nvSpPr>
-        <p:spPr>
-          <a:xfrm>
-            <a:off x="978407" y="4462272"/>
-            <a:ext cx="2057400" cy="530352"/>
-          </a:xfrm>
-          <a:prstGeom prst="rect">
-            <a:avLst/>
-          </a:prstGeom>
-          <a:noFill/>
-        </p:spPr>
-        <p:txBody>
-          <a:bodyPr wrap="square">
-            <a:spAutoFit/>
-          </a:bodyPr>
-          <a:lstStyle/>
-          <a:p>
-            <a:r>
-              <a:rPr sz="950">
-                <a:solidFill>
-                  <a:srgbClr val="5B6982"/>
-                </a:solidFill>
-              </a:rPr>
-              <a:t>Tracks CPU, memory, disk, GPU, and NPU pressure to expose bottlenecks early.</a:t>
-            </a:r>
-          </a:p>
-        </p:txBody>
-      </p:sp>
-      <p:sp>
-        <p:nvSpPr>
-          <p:cNvPr id="24" name="Rounded Rectangle 23"/>
+              <a:t>Improves workload stability during pressure spikes and resource contention.</a:t>
+            </a:r>
+          </a:p>
+        </p:txBody>
+      </p:sp>
+      <p:sp>
+        <p:nvSpPr>
+          <p:cNvPr id="37" name="Oval 36"/>
           <p:cNvSpPr/>
           <p:nvPr/>
         </p:nvSpPr>
         <p:spPr>
           <a:xfrm>
-            <a:off x="3474720" y="4005072"/>
-            <a:ext cx="3017520" cy="1234440"/>
-          </a:xfrm>
-          <a:prstGeom prst="roundRect">
+            <a:off x="7726679" y="5047488"/>
+            <a:ext cx="109728" cy="109728"/>
+          </a:xfrm>
+          <a:prstGeom prst="ellipse">
             <a:avLst/>
           </a:prstGeom>
           <a:solidFill>
-            <a:srgbClr val="FFFFFF"/>
+            <a:srgbClr val="F7AA2E"/>
           </a:solidFill>
-          <a:ln w="12700">
-            <a:solidFill>
-              <a:srgbClr val="D7E0EC"/>
-            </a:solidFill>
+          <a:ln>
+            <a:noFill/>
           </a:ln>
         </p:spPr>
         <p:style>
@@ -3942,20 +4491,53 @@
       </p:sp>
       <p:sp>
         <p:nvSpPr>
-          <p:cNvPr id="25" name="Rectangle 24"/>
-          <p:cNvSpPr/>
+          <p:cNvPr id="38" name="TextBox 37"/>
+          <p:cNvSpPr txBox="1"/>
           <p:nvPr/>
         </p:nvSpPr>
         <p:spPr>
           <a:xfrm>
-            <a:off x="3474720" y="4005072"/>
-            <a:ext cx="73152" cy="1234440"/>
+            <a:off x="7909560" y="5010912"/>
+            <a:ext cx="3611880" cy="256032"/>
           </a:xfrm>
           <a:prstGeom prst="rect">
             <a:avLst/>
           </a:prstGeom>
+          <a:noFill/>
+        </p:spPr>
+        <p:txBody>
+          <a:bodyPr wrap="square">
+            <a:spAutoFit/>
+          </a:bodyPr>
+          <a:lstStyle/>
+          <a:p>
+            <a:r>
+              <a:rPr sz="1000">
+                <a:solidFill>
+                  <a:srgbClr val="4C5C76"/>
+                </a:solidFill>
+              </a:rPr>
+              <a:t>Provides a repeatable path from telemetry insight to production deployment.</a:t>
+            </a:r>
+          </a:p>
+        </p:txBody>
+      </p:sp>
+      <p:sp>
+        <p:nvSpPr>
+          <p:cNvPr id="39" name="Rounded Rectangle 38"/>
+          <p:cNvSpPr/>
+          <p:nvPr/>
+        </p:nvSpPr>
+        <p:spPr>
+          <a:xfrm>
+            <a:off x="7635240" y="5413248"/>
+            <a:ext cx="3977639" cy="420624"/>
+          </a:xfrm>
+          <a:prstGeom prst="roundRect">
+            <a:avLst/>
+          </a:prstGeom>
           <a:solidFill>
-            <a:srgbClr val="26B370"/>
+            <a:srgbClr val="121F3A"/>
           </a:solidFill>
           <a:ln>
             <a:noFill/>
@@ -3980,129 +4562,36 @@
           <a:lstStyle/>
           <a:p>
             <a:pPr algn="ctr"/>
-          </a:p>
-        </p:txBody>
-      </p:sp>
-      <p:sp>
-        <p:nvSpPr>
-          <p:cNvPr id="26" name="TextBox 25"/>
-          <p:cNvSpPr txBox="1"/>
-          <p:nvPr/>
-        </p:nvSpPr>
-        <p:spPr>
-          <a:xfrm>
-            <a:off x="3639312" y="4169663"/>
-            <a:ext cx="411480" cy="256032"/>
-          </a:xfrm>
-          <a:prstGeom prst="rect">
-            <a:avLst/>
-          </a:prstGeom>
-          <a:noFill/>
-        </p:spPr>
-        <p:txBody>
-          <a:bodyPr wrap="none">
-            <a:spAutoFit/>
-          </a:bodyPr>
-          <a:lstStyle/>
-          <a:p>
-            <a:r>
-              <a:rPr sz="1800" b="1">
+            <a:r>
+              <a:rPr sz="1050" b="1">
                 <a:solidFill>
-                  <a:srgbClr val="26B370"/>
+                  <a:srgbClr val="FFFFFF"/>
                 </a:solidFill>
               </a:rPr>
-              <a:t>02</a:t>
-            </a:r>
-          </a:p>
-        </p:txBody>
-      </p:sp>
-      <p:sp>
-        <p:nvSpPr>
-          <p:cNvPr id="27" name="TextBox 26"/>
-          <p:cNvSpPr txBox="1"/>
-          <p:nvPr/>
-        </p:nvSpPr>
-        <p:spPr>
-          <a:xfrm>
-            <a:off x="4133087" y="4114800"/>
-            <a:ext cx="2148840" cy="329184"/>
-          </a:xfrm>
-          <a:prstGeom prst="rect">
-            <a:avLst/>
-          </a:prstGeom>
-          <a:noFill/>
-        </p:spPr>
-        <p:txBody>
-          <a:bodyPr wrap="square">
-            <a:spAutoFit/>
-          </a:bodyPr>
-          <a:lstStyle/>
-          <a:p>
-            <a:r>
-              <a:rPr sz="1200" b="1">
-                <a:solidFill>
-                  <a:srgbClr val="1A2A4C"/>
-                </a:solidFill>
-              </a:rPr>
-              <a:t>AUTOMATED RESOURCE BALANCING</a:t>
-            </a:r>
-          </a:p>
-        </p:txBody>
-      </p:sp>
-      <p:sp>
-        <p:nvSpPr>
-          <p:cNvPr id="28" name="TextBox 27"/>
-          <p:cNvSpPr txBox="1"/>
-          <p:nvPr/>
-        </p:nvSpPr>
-        <p:spPr>
-          <a:xfrm>
-            <a:off x="4133087" y="4462272"/>
-            <a:ext cx="2057400" cy="530352"/>
-          </a:xfrm>
-          <a:prstGeom prst="rect">
-            <a:avLst/>
-          </a:prstGeom>
-          <a:noFill/>
-        </p:spPr>
-        <p:txBody>
-          <a:bodyPr wrap="square">
-            <a:spAutoFit/>
-          </a:bodyPr>
-          <a:lstStyle/>
-          <a:p>
-            <a:r>
-              <a:rPr sz="950">
-                <a:solidFill>
-                  <a:srgbClr val="5B6982"/>
-                </a:solidFill>
-              </a:rPr>
-              <a:t>Applies cgroup-based controls, launch queuing, and keep-alive policies for critical apps.</a:t>
-            </a:r>
-          </a:p>
-        </p:txBody>
-      </p:sp>
-      <p:sp>
-        <p:nvSpPr>
-          <p:cNvPr id="29" name="Rounded Rectangle 28"/>
+              <a:t>SmartTune 1.5 = telemetry + policy control + workload governance</a:t>
+            </a:r>
+          </a:p>
+        </p:txBody>
+      </p:sp>
+      <p:sp>
+        <p:nvSpPr>
+          <p:cNvPr id="40" name="Rounded Rectangle 39"/>
           <p:cNvSpPr/>
           <p:nvPr/>
         </p:nvSpPr>
         <p:spPr>
           <a:xfrm>
-            <a:off x="6629400" y="4005072"/>
-            <a:ext cx="3017520" cy="1234440"/>
+            <a:off x="347472" y="6199632"/>
+            <a:ext cx="11503152" cy="438912"/>
           </a:xfrm>
           <a:prstGeom prst="roundRect">
             <a:avLst/>
           </a:prstGeom>
           <a:solidFill>
-            <a:srgbClr val="FFFFFF"/>
+            <a:srgbClr val="121F3A"/>
           </a:solidFill>
-          <a:ln w="12700">
-            <a:solidFill>
-              <a:srgbClr val="D7E0EC"/>
-            </a:solidFill>
+          <a:ln>
+            <a:noFill/>
           </a:ln>
         </p:spPr>
         <p:style>
@@ -4129,20 +4618,53 @@
       </p:sp>
       <p:sp>
         <p:nvSpPr>
-          <p:cNvPr id="30" name="Rectangle 29"/>
-          <p:cNvSpPr/>
+          <p:cNvPr id="41" name="TextBox 40"/>
+          <p:cNvSpPr txBox="1"/>
           <p:nvPr/>
         </p:nvSpPr>
         <p:spPr>
           <a:xfrm>
-            <a:off x="6629400" y="4005072"/>
-            <a:ext cx="73152" cy="1234440"/>
+            <a:off x="566928" y="6327648"/>
+            <a:ext cx="2011680" cy="164592"/>
           </a:xfrm>
           <a:prstGeom prst="rect">
             <a:avLst/>
           </a:prstGeom>
+          <a:noFill/>
+        </p:spPr>
+        <p:txBody>
+          <a:bodyPr wrap="none">
+            <a:spAutoFit/>
+          </a:bodyPr>
+          <a:lstStyle/>
+          <a:p>
+            <a:r>
+              <a:rPr sz="1100" b="1">
+                <a:solidFill>
+                  <a:srgbClr val="FFFFFF"/>
+                </a:solidFill>
+              </a:rPr>
+              <a:t>PILOT CUSTOMERS</a:t>
+            </a:r>
+          </a:p>
+        </p:txBody>
+      </p:sp>
+      <p:sp>
+        <p:nvSpPr>
+          <p:cNvPr id="42" name="Rounded Rectangle 41"/>
+          <p:cNvSpPr/>
+          <p:nvPr/>
+        </p:nvSpPr>
+        <p:spPr>
+          <a:xfrm>
+            <a:off x="2057400" y="6272784"/>
+            <a:ext cx="1554480" cy="256032"/>
+          </a:xfrm>
+          <a:prstGeom prst="roundRect">
+            <a:avLst/>
+          </a:prstGeom>
           <a:solidFill>
-            <a:srgbClr val="F7AA2D"/>
+            <a:srgbClr val="1168BE"/>
           </a:solidFill>
           <a:ln>
             <a:noFill/>
@@ -4167,124 +4689,33 @@
           <a:lstStyle/>
           <a:p>
             <a:pPr algn="ctr"/>
-          </a:p>
-        </p:txBody>
-      </p:sp>
-      <p:sp>
-        <p:nvSpPr>
-          <p:cNvPr id="31" name="TextBox 30"/>
-          <p:cNvSpPr txBox="1"/>
-          <p:nvPr/>
-        </p:nvSpPr>
-        <p:spPr>
-          <a:xfrm>
-            <a:off x="6793992" y="4169663"/>
-            <a:ext cx="411480" cy="256032"/>
-          </a:xfrm>
-          <a:prstGeom prst="rect">
-            <a:avLst/>
-          </a:prstGeom>
-          <a:noFill/>
-        </p:spPr>
-        <p:txBody>
-          <a:bodyPr wrap="none">
-            <a:spAutoFit/>
-          </a:bodyPr>
-          <a:lstStyle/>
-          <a:p>
-            <a:r>
-              <a:rPr sz="1800" b="1">
+            <a:r>
+              <a:rPr sz="950" b="1">
                 <a:solidFill>
-                  <a:srgbClr val="F7AA2D"/>
+                  <a:srgbClr val="FFFFFF"/>
                 </a:solidFill>
               </a:rPr>
-              <a:t>03</a:t>
-            </a:r>
-          </a:p>
-        </p:txBody>
-      </p:sp>
-      <p:sp>
-        <p:nvSpPr>
-          <p:cNvPr id="32" name="TextBox 31"/>
-          <p:cNvSpPr txBox="1"/>
-          <p:nvPr/>
-        </p:nvSpPr>
-        <p:spPr>
-          <a:xfrm>
-            <a:off x="7287768" y="4114800"/>
-            <a:ext cx="2148840" cy="329184"/>
-          </a:xfrm>
-          <a:prstGeom prst="rect">
-            <a:avLst/>
-          </a:prstGeom>
-          <a:noFill/>
-        </p:spPr>
-        <p:txBody>
-          <a:bodyPr wrap="square">
-            <a:spAutoFit/>
-          </a:bodyPr>
-          <a:lstStyle/>
-          <a:p>
-            <a:r>
-              <a:rPr sz="1200" b="1">
-                <a:solidFill>
-                  <a:srgbClr val="1A2A4C"/>
-                </a:solidFill>
-              </a:rPr>
-              <a:t>FASTER PLATFORM READINESS</a:t>
-            </a:r>
-          </a:p>
-        </p:txBody>
-      </p:sp>
-      <p:sp>
-        <p:nvSpPr>
-          <p:cNvPr id="33" name="TextBox 32"/>
-          <p:cNvSpPr txBox="1"/>
-          <p:nvPr/>
-        </p:nvSpPr>
-        <p:spPr>
-          <a:xfrm>
-            <a:off x="7287768" y="4462272"/>
-            <a:ext cx="2057400" cy="530352"/>
-          </a:xfrm>
-          <a:prstGeom prst="rect">
-            <a:avLst/>
-          </a:prstGeom>
-          <a:noFill/>
-        </p:spPr>
-        <p:txBody>
-          <a:bodyPr wrap="square">
-            <a:spAutoFit/>
-          </a:bodyPr>
-          <a:lstStyle/>
-          <a:p>
-            <a:r>
-              <a:rPr sz="950">
-                <a:solidFill>
-                  <a:srgbClr val="5B6982"/>
-                </a:solidFill>
-              </a:rPr>
-              <a:t>Shortens tuning cycles with a repeatable optimization workflow for Intel® XPU systems.</a:t>
-            </a:r>
-          </a:p>
-        </p:txBody>
-      </p:sp>
-      <p:sp>
-        <p:nvSpPr>
-          <p:cNvPr id="34" name="Rectangle 33"/>
+              <a:t>AsterAI</a:t>
+            </a:r>
+          </a:p>
+        </p:txBody>
+      </p:sp>
+      <p:sp>
+        <p:nvSpPr>
+          <p:cNvPr id="43" name="Rounded Rectangle 42"/>
           <p:cNvSpPr/>
           <p:nvPr/>
         </p:nvSpPr>
         <p:spPr>
           <a:xfrm>
-            <a:off x="320040" y="5486400"/>
-            <a:ext cx="11430000" cy="9144"/>
-          </a:xfrm>
-          <a:prstGeom prst="rect">
+            <a:off x="3840480" y="6272784"/>
+            <a:ext cx="1554480" cy="256032"/>
+          </a:xfrm>
+          <a:prstGeom prst="roundRect">
             <a:avLst/>
           </a:prstGeom>
           <a:solidFill>
-            <a:srgbClr val="D7E0EC"/>
+            <a:srgbClr val="1FB177"/>
           </a:solidFill>
           <a:ln>
             <a:noFill/>
@@ -4309,58 +4740,33 @@
           <a:lstStyle/>
           <a:p>
             <a:pPr algn="ctr"/>
-          </a:p>
-        </p:txBody>
-      </p:sp>
-      <p:sp>
-        <p:nvSpPr>
-          <p:cNvPr id="35" name="TextBox 34"/>
-          <p:cNvSpPr txBox="1"/>
-          <p:nvPr/>
-        </p:nvSpPr>
-        <p:spPr>
-          <a:xfrm>
-            <a:off x="320040" y="5559552"/>
-            <a:ext cx="4206240" cy="237744"/>
-          </a:xfrm>
-          <a:prstGeom prst="rect">
-            <a:avLst/>
-          </a:prstGeom>
-          <a:noFill/>
-        </p:spPr>
-        <p:txBody>
-          <a:bodyPr wrap="none">
-            <a:spAutoFit/>
-          </a:bodyPr>
-          <a:lstStyle/>
-          <a:p>
-            <a:r>
-              <a:rPr sz="1100" b="1">
+            <a:r>
+              <a:rPr sz="950" b="1">
                 <a:solidFill>
-                  <a:srgbClr val="5B6982"/>
+                  <a:srgbClr val="FFFFFF"/>
                 </a:solidFill>
               </a:rPr>
-              <a:t>CUSTOMERS IN PILOT / EARLY ADOPTION</a:t>
-            </a:r>
-          </a:p>
-        </p:txBody>
-      </p:sp>
-      <p:sp>
-        <p:nvSpPr>
-          <p:cNvPr id="36" name="Oval 35"/>
+              <a:t>NovaEdge Systems</a:t>
+            </a:r>
+          </a:p>
+        </p:txBody>
+      </p:sp>
+      <p:sp>
+        <p:nvSpPr>
+          <p:cNvPr id="44" name="Rounded Rectangle 43"/>
           <p:cNvSpPr/>
           <p:nvPr/>
         </p:nvSpPr>
         <p:spPr>
           <a:xfrm>
-            <a:off x="320040" y="5669280"/>
-            <a:ext cx="292608" cy="292608"/>
-          </a:xfrm>
-          <a:prstGeom prst="ellipse">
+            <a:off x="5623560" y="6272784"/>
+            <a:ext cx="1554480" cy="256032"/>
+          </a:xfrm>
+          <a:prstGeom prst="roundRect">
             <a:avLst/>
           </a:prstGeom>
           <a:solidFill>
-            <a:srgbClr val="106BBF"/>
+            <a:srgbClr val="F7AA2E"/>
           </a:solidFill>
           <a:ln>
             <a:noFill/>
@@ -4385,91 +4791,33 @@
           <a:lstStyle/>
           <a:p>
             <a:pPr algn="ctr"/>
-          </a:p>
-        </p:txBody>
-      </p:sp>
-      <p:sp>
-        <p:nvSpPr>
-          <p:cNvPr id="37" name="TextBox 36"/>
-          <p:cNvSpPr txBox="1"/>
-          <p:nvPr/>
-        </p:nvSpPr>
-        <p:spPr>
-          <a:xfrm>
-            <a:off x="704088" y="5632704"/>
-            <a:ext cx="2103120" cy="228600"/>
-          </a:xfrm>
-          <a:prstGeom prst="rect">
-            <a:avLst/>
-          </a:prstGeom>
-          <a:noFill/>
-        </p:spPr>
-        <p:txBody>
-          <a:bodyPr wrap="none">
-            <a:spAutoFit/>
-          </a:bodyPr>
-          <a:lstStyle/>
-          <a:p>
-            <a:r>
-              <a:rPr sz="1150" b="1">
+            <a:r>
+              <a:rPr sz="950" b="1">
                 <a:solidFill>
-                  <a:srgbClr val="1A2A4C"/>
+                  <a:srgbClr val="FFFFFF"/>
                 </a:solidFill>
               </a:rPr>
-              <a:t>AsterAI</a:t>
-            </a:r>
-          </a:p>
-        </p:txBody>
-      </p:sp>
-      <p:sp>
-        <p:nvSpPr>
-          <p:cNvPr id="38" name="TextBox 37"/>
-          <p:cNvSpPr txBox="1"/>
-          <p:nvPr/>
-        </p:nvSpPr>
-        <p:spPr>
-          <a:xfrm>
-            <a:off x="704088" y="5870448"/>
-            <a:ext cx="2240280" cy="310896"/>
-          </a:xfrm>
-          <a:prstGeom prst="rect">
-            <a:avLst/>
-          </a:prstGeom>
-          <a:noFill/>
-        </p:spPr>
-        <p:txBody>
-          <a:bodyPr wrap="square">
-            <a:spAutoFit/>
-          </a:bodyPr>
-          <a:lstStyle/>
-          <a:p>
-            <a:r>
-              <a:rPr sz="880">
-                <a:solidFill>
-                  <a:srgbClr val="5B6982"/>
-                </a:solidFill>
-              </a:rPr>
-              <a:t>Edge AI appliance provider</a:t>
-            </a:r>
-          </a:p>
-        </p:txBody>
-      </p:sp>
-      <p:sp>
-        <p:nvSpPr>
-          <p:cNvPr id="39" name="Oval 38"/>
+              <a:t>BlueMesa Robotics</a:t>
+            </a:r>
+          </a:p>
+        </p:txBody>
+      </p:sp>
+      <p:sp>
+        <p:nvSpPr>
+          <p:cNvPr id="45" name="Rounded Rectangle 44"/>
           <p:cNvSpPr/>
           <p:nvPr/>
         </p:nvSpPr>
         <p:spPr>
           <a:xfrm>
-            <a:off x="3154680" y="5669280"/>
-            <a:ext cx="292608" cy="292608"/>
-          </a:xfrm>
-          <a:prstGeom prst="ellipse">
+            <a:off x="7406640" y="6272784"/>
+            <a:ext cx="1554480" cy="256032"/>
+          </a:xfrm>
+          <a:prstGeom prst="roundRect">
             <a:avLst/>
           </a:prstGeom>
           <a:solidFill>
-            <a:srgbClr val="26B370"/>
+            <a:srgbClr val="549DEA"/>
           </a:solidFill>
           <a:ln>
             <a:noFill/>
@@ -4494,91 +4842,33 @@
           <a:lstStyle/>
           <a:p>
             <a:pPr algn="ctr"/>
-          </a:p>
-        </p:txBody>
-      </p:sp>
-      <p:sp>
-        <p:nvSpPr>
-          <p:cNvPr id="40" name="TextBox 39"/>
-          <p:cNvSpPr txBox="1"/>
-          <p:nvPr/>
-        </p:nvSpPr>
-        <p:spPr>
-          <a:xfrm>
-            <a:off x="3538728" y="5632704"/>
-            <a:ext cx="2103120" cy="228600"/>
-          </a:xfrm>
-          <a:prstGeom prst="rect">
-            <a:avLst/>
-          </a:prstGeom>
-          <a:noFill/>
-        </p:spPr>
-        <p:txBody>
-          <a:bodyPr wrap="none">
-            <a:spAutoFit/>
-          </a:bodyPr>
-          <a:lstStyle/>
-          <a:p>
-            <a:r>
-              <a:rPr sz="1150" b="1">
+            <a:r>
+              <a:rPr sz="950" b="1">
                 <a:solidFill>
-                  <a:srgbClr val="1A2A4C"/>
+                  <a:srgbClr val="FFFFFF"/>
                 </a:solidFill>
               </a:rPr>
-              <a:t>NovaEdge Systems</a:t>
-            </a:r>
-          </a:p>
-        </p:txBody>
-      </p:sp>
-      <p:sp>
-        <p:nvSpPr>
-          <p:cNvPr id="41" name="TextBox 40"/>
-          <p:cNvSpPr txBox="1"/>
-          <p:nvPr/>
-        </p:nvSpPr>
-        <p:spPr>
-          <a:xfrm>
-            <a:off x="3538728" y="5870448"/>
-            <a:ext cx="2240280" cy="310896"/>
-          </a:xfrm>
-          <a:prstGeom prst="rect">
-            <a:avLst/>
-          </a:prstGeom>
-          <a:noFill/>
-        </p:spPr>
-        <p:txBody>
-          <a:bodyPr wrap="square">
-            <a:spAutoFit/>
-          </a:bodyPr>
-          <a:lstStyle/>
-          <a:p>
-            <a:r>
-              <a:rPr sz="880">
-                <a:solidFill>
-                  <a:srgbClr val="5B6982"/>
-                </a:solidFill>
-              </a:rPr>
-              <a:t>Industrial compute platform team</a:t>
-            </a:r>
-          </a:p>
-        </p:txBody>
-      </p:sp>
-      <p:sp>
-        <p:nvSpPr>
-          <p:cNvPr id="42" name="Oval 41"/>
+              <a:t>VertexVision</a:t>
+            </a:r>
+          </a:p>
+        </p:txBody>
+      </p:sp>
+      <p:sp>
+        <p:nvSpPr>
+          <p:cNvPr id="46" name="Rounded Rectangle 45"/>
           <p:cNvSpPr/>
           <p:nvPr/>
         </p:nvSpPr>
         <p:spPr>
           <a:xfrm>
-            <a:off x="6080760" y="5669280"/>
-            <a:ext cx="292608" cy="292608"/>
-          </a:xfrm>
-          <a:prstGeom prst="ellipse">
+            <a:off x="9189720" y="6272784"/>
+            <a:ext cx="1554480" cy="256032"/>
+          </a:xfrm>
+          <a:prstGeom prst="roundRect">
             <a:avLst/>
           </a:prstGeom>
           <a:solidFill>
-            <a:srgbClr val="F7AA2D"/>
+            <a:srgbClr val="1FB177"/>
           </a:solidFill>
           <a:ln>
             <a:noFill/>
@@ -4603,19 +4893,27 @@
           <a:lstStyle/>
           <a:p>
             <a:pPr algn="ctr"/>
-          </a:p>
-        </p:txBody>
-      </p:sp>
-      <p:sp>
-        <p:nvSpPr>
-          <p:cNvPr id="43" name="TextBox 42"/>
+            <a:r>
+              <a:rPr sz="950" b="1">
+                <a:solidFill>
+                  <a:srgbClr val="FFFFFF"/>
+                </a:solidFill>
+              </a:rPr>
+              <a:t>Orion Compute</a:t>
+            </a:r>
+          </a:p>
+        </p:txBody>
+      </p:sp>
+      <p:sp>
+        <p:nvSpPr>
+          <p:cNvPr id="47" name="TextBox 46"/>
           <p:cNvSpPr txBox="1"/>
           <p:nvPr/>
         </p:nvSpPr>
         <p:spPr>
           <a:xfrm>
-            <a:off x="6464808" y="5632704"/>
-            <a:ext cx="2103120" cy="228600"/>
+            <a:off x="10241280" y="6327648"/>
+            <a:ext cx="1325880" cy="146304"/>
           </a:xfrm>
           <a:prstGeom prst="rect">
             <a:avLst/>
@@ -4628,189 +4926,14 @@
           </a:bodyPr>
           <a:lstStyle/>
           <a:p>
-            <a:r>
-              <a:rPr sz="1150" b="1">
+            <a:pPr algn="r"/>
+            <a:r>
+              <a:rPr sz="900" i="1">
                 <a:solidFill>
-                  <a:srgbClr val="1A2A4C"/>
+                  <a:srgbClr val="D1DAE8"/>
                 </a:solidFill>
               </a:rPr>
-              <a:t>BlueMesa Robotics</a:t>
-            </a:r>
-          </a:p>
-        </p:txBody>
-      </p:sp>
-      <p:sp>
-        <p:nvSpPr>
-          <p:cNvPr id="44" name="TextBox 43"/>
-          <p:cNvSpPr txBox="1"/>
-          <p:nvPr/>
-        </p:nvSpPr>
-        <p:spPr>
-          <a:xfrm>
-            <a:off x="6464808" y="5870448"/>
-            <a:ext cx="2240280" cy="310896"/>
-          </a:xfrm>
-          <a:prstGeom prst="rect">
-            <a:avLst/>
-          </a:prstGeom>
-          <a:noFill/>
-        </p:spPr>
-        <p:txBody>
-          <a:bodyPr wrap="square">
-            <a:spAutoFit/>
-          </a:bodyPr>
-          <a:lstStyle/>
-          <a:p>
-            <a:r>
-              <a:rPr sz="880">
-                <a:solidFill>
-                  <a:srgbClr val="5B6982"/>
-                </a:solidFill>
-              </a:rPr>
-              <a:t>Autonomous robotics workloads</a:t>
-            </a:r>
-          </a:p>
-        </p:txBody>
-      </p:sp>
-      <p:sp>
-        <p:nvSpPr>
-          <p:cNvPr id="45" name="Oval 44"/>
-          <p:cNvSpPr/>
-          <p:nvPr/>
-        </p:nvSpPr>
-        <p:spPr>
-          <a:xfrm>
-            <a:off x="8915400" y="5669280"/>
-            <a:ext cx="292608" cy="292608"/>
-          </a:xfrm>
-          <a:prstGeom prst="ellipse">
-            <a:avLst/>
-          </a:prstGeom>
-          <a:solidFill>
-            <a:srgbClr val="106BBF"/>
-          </a:solidFill>
-          <a:ln>
-            <a:noFill/>
-          </a:ln>
-        </p:spPr>
-        <p:style>
-          <a:lnRef idx="1">
-            <a:schemeClr val="accent1"/>
-          </a:lnRef>
-          <a:fillRef idx="3">
-            <a:schemeClr val="accent1"/>
-          </a:fillRef>
-          <a:effectRef idx="2">
-            <a:schemeClr val="accent1"/>
-          </a:effectRef>
-          <a:fontRef idx="minor">
-            <a:schemeClr val="lt1"/>
-          </a:fontRef>
-        </p:style>
-        <p:txBody>
-          <a:bodyPr rtlCol="0" anchor="ctr"/>
-          <a:lstStyle/>
-          <a:p>
-            <a:pPr algn="ctr"/>
-          </a:p>
-        </p:txBody>
-      </p:sp>
-      <p:sp>
-        <p:nvSpPr>
-          <p:cNvPr id="46" name="TextBox 45"/>
-          <p:cNvSpPr txBox="1"/>
-          <p:nvPr/>
-        </p:nvSpPr>
-        <p:spPr>
-          <a:xfrm>
-            <a:off x="9299448" y="5632704"/>
-            <a:ext cx="2103120" cy="228600"/>
-          </a:xfrm>
-          <a:prstGeom prst="rect">
-            <a:avLst/>
-          </a:prstGeom>
-          <a:noFill/>
-        </p:spPr>
-        <p:txBody>
-          <a:bodyPr wrap="none">
-            <a:spAutoFit/>
-          </a:bodyPr>
-          <a:lstStyle/>
-          <a:p>
-            <a:r>
-              <a:rPr sz="1150" b="1">
-                <a:solidFill>
-                  <a:srgbClr val="1A2A4C"/>
-                </a:solidFill>
-              </a:rPr>
-              <a:t>VertexVision</a:t>
-            </a:r>
-          </a:p>
-        </p:txBody>
-      </p:sp>
-      <p:sp>
-        <p:nvSpPr>
-          <p:cNvPr id="47" name="TextBox 46"/>
-          <p:cNvSpPr txBox="1"/>
-          <p:nvPr/>
-        </p:nvSpPr>
-        <p:spPr>
-          <a:xfrm>
-            <a:off x="9299448" y="5870448"/>
-            <a:ext cx="2240280" cy="310896"/>
-          </a:xfrm>
-          <a:prstGeom prst="rect">
-            <a:avLst/>
-          </a:prstGeom>
-          <a:noFill/>
-        </p:spPr>
-        <p:txBody>
-          <a:bodyPr wrap="square">
-            <a:spAutoFit/>
-          </a:bodyPr>
-          <a:lstStyle/>
-          <a:p>
-            <a:r>
-              <a:rPr sz="880">
-                <a:solidFill>
-                  <a:srgbClr val="5B6982"/>
-                </a:solidFill>
-              </a:rPr>
-              <a:t>Computer vision deployment partner</a:t>
-            </a:r>
-          </a:p>
-        </p:txBody>
-      </p:sp>
-      <p:sp>
-        <p:nvSpPr>
-          <p:cNvPr id="48" name="TextBox 47"/>
-          <p:cNvSpPr txBox="1"/>
-          <p:nvPr/>
-        </p:nvSpPr>
-        <p:spPr>
-          <a:xfrm>
-            <a:off x="9189720" y="6400800"/>
-            <a:ext cx="2560320" cy="164592"/>
-          </a:xfrm>
-          <a:prstGeom prst="rect">
-            <a:avLst/>
-          </a:prstGeom>
-          <a:noFill/>
-        </p:spPr>
-        <p:txBody>
-          <a:bodyPr wrap="none">
-            <a:spAutoFit/>
-          </a:bodyPr>
-          <a:lstStyle/>
-          <a:p>
-            <a:pPr algn="r"/>
-            <a:r>
-              <a:rPr sz="750">
-                <a:solidFill>
-                  <a:srgbClr val="5B6982"/>
-                </a:solidFill>
-              </a:rPr>
-              <a:t>Customer names are placeholders and can be edited.</a:t>
+              <a:t>editable</a:t>
             </a:r>
           </a:p>
         </p:txBody>

</xml_diff>

<commit_message>
Refresh SmartTune slide for executive style
</commit_message>
<xml_diff>
--- a/docs/presentations/smartune_q3_milestone_slide.pptx
+++ b/docs/presentations/smartune_q3_milestone_slide.pptx
@@ -3133,20 +3133,53 @@
       </p:sp>
       <p:sp>
         <p:nvSpPr>
-          <p:cNvPr id="3" name="Rectangle 2"/>
+          <p:cNvPr id="3" name="TextBox 2"/>
+          <p:cNvSpPr txBox="1"/>
+          <p:nvPr/>
+        </p:nvSpPr>
+        <p:spPr>
+          <a:xfrm>
+            <a:off x="502920" y="164592"/>
+            <a:ext cx="4389120" cy="201168"/>
+          </a:xfrm>
+          <a:prstGeom prst="rect">
+            <a:avLst/>
+          </a:prstGeom>
+          <a:noFill/>
+        </p:spPr>
+        <p:txBody>
+          <a:bodyPr wrap="none">
+            <a:spAutoFit/>
+          </a:bodyPr>
+          <a:lstStyle/>
+          <a:p>
+            <a:r>
+              <a:rPr sz="1100" b="1">
+                <a:solidFill>
+                  <a:srgbClr val="1269BF"/>
+                </a:solidFill>
+              </a:rPr>
+              <a:t>INTEL® EES PLATFORM / SMARTUNE 1.5</a:t>
+            </a:r>
+          </a:p>
+        </p:txBody>
+      </p:sp>
+      <p:sp>
+        <p:nvSpPr>
+          <p:cNvPr id="4" name="Rounded Rectangle 3"/>
           <p:cNvSpPr/>
           <p:nvPr/>
         </p:nvSpPr>
         <p:spPr>
           <a:xfrm>
-            <a:off x="0" y="0"/>
-            <a:ext cx="12191695" cy="1325880"/>
-          </a:xfrm>
-          <a:prstGeom prst="rect">
+            <a:off x="10058400" y="109728"/>
+            <a:ext cx="1737360" cy="347472"/>
+          </a:xfrm>
+          <a:prstGeom prst="roundRect">
             <a:avLst/>
           </a:prstGeom>
           <a:solidFill>
-            <a:srgbClr val="121F3A"/>
+            <a:srgbClr val="162543"/>
           </a:solidFill>
           <a:ln>
             <a:noFill/>
@@ -3171,19 +3204,27 @@
           <a:lstStyle/>
           <a:p>
             <a:pPr algn="ctr"/>
-          </a:p>
-        </p:txBody>
-      </p:sp>
-      <p:sp>
-        <p:nvSpPr>
-          <p:cNvPr id="4" name="TextBox 3"/>
+            <a:r>
+              <a:rPr sz="1050" b="1">
+                <a:solidFill>
+                  <a:srgbClr val="FFFFFF"/>
+                </a:solidFill>
+              </a:rPr>
+              <a:t>EXECUTIVE VIEW</a:t>
+            </a:r>
+          </a:p>
+        </p:txBody>
+      </p:sp>
+      <p:sp>
+        <p:nvSpPr>
+          <p:cNvPr id="5" name="TextBox 4"/>
           <p:cNvSpPr txBox="1"/>
           <p:nvPr/>
         </p:nvSpPr>
         <p:spPr>
           <a:xfrm>
-            <a:off x="411480" y="182880"/>
-            <a:ext cx="4114800" cy="182880"/>
+            <a:off x="502920" y="530352"/>
+            <a:ext cx="2926080" cy="365760"/>
           </a:xfrm>
           <a:prstGeom prst="rect">
             <a:avLst/>
@@ -3197,26 +3238,26 @@
           <a:lstStyle/>
           <a:p>
             <a:r>
-              <a:rPr sz="1100" b="1">
-                <a:solidFill>
-                  <a:srgbClr val="549DEA"/>
+              <a:rPr sz="2700" b="1">
+                <a:solidFill>
+                  <a:srgbClr val="162543"/>
                 </a:solidFill>
               </a:rPr>
-              <a:t>INTEL® EES PLATFORM  /  SMARTUNE 1.5</a:t>
-            </a:r>
-          </a:p>
-        </p:txBody>
-      </p:sp>
-      <p:sp>
-        <p:nvSpPr>
-          <p:cNvPr id="5" name="TextBox 4"/>
+              <a:t>SmarTune 1.5</a:t>
+            </a:r>
+          </a:p>
+        </p:txBody>
+      </p:sp>
+      <p:sp>
+        <p:nvSpPr>
+          <p:cNvPr id="6" name="TextBox 5"/>
           <p:cNvSpPr txBox="1"/>
           <p:nvPr/>
         </p:nvSpPr>
         <p:spPr>
           <a:xfrm>
-            <a:off x="411480" y="411480"/>
-            <a:ext cx="2286000" cy="502920"/>
+            <a:off x="502920" y="1024128"/>
+            <a:ext cx="5120640" cy="365760"/>
           </a:xfrm>
           <a:prstGeom prst="rect">
             <a:avLst/>
@@ -3230,26 +3271,26 @@
           <a:lstStyle/>
           <a:p>
             <a:r>
-              <a:rPr sz="2600" b="1">
-                <a:solidFill>
-                  <a:srgbClr val="FFFFFF"/>
+              <a:rPr sz="2800" b="1">
+                <a:solidFill>
+                  <a:srgbClr val="1269BF"/>
                 </a:solidFill>
               </a:rPr>
-              <a:t>SmartTune 1.5</a:t>
-            </a:r>
-          </a:p>
-        </p:txBody>
-      </p:sp>
-      <p:sp>
-        <p:nvSpPr>
-          <p:cNvPr id="6" name="TextBox 5"/>
+              <a:t>BUSINESS VALUE MILESTONE</a:t>
+            </a:r>
+          </a:p>
+        </p:txBody>
+      </p:sp>
+      <p:sp>
+        <p:nvSpPr>
+          <p:cNvPr id="7" name="TextBox 6"/>
           <p:cNvSpPr txBox="1"/>
           <p:nvPr/>
         </p:nvSpPr>
         <p:spPr>
           <a:xfrm>
-            <a:off x="2697480" y="411480"/>
-            <a:ext cx="6583680" cy="502920"/>
+            <a:off x="530352" y="1627632"/>
+            <a:ext cx="3017520" cy="365760"/>
           </a:xfrm>
           <a:prstGeom prst="rect">
             <a:avLst/>
@@ -3263,45 +3304,12 @@
           <a:lstStyle/>
           <a:p>
             <a:r>
-              <a:rPr sz="2600" b="1">
-                <a:solidFill>
-                  <a:srgbClr val="549DEA"/>
+              <a:rPr sz="1400" b="1">
+                <a:solidFill>
+                  <a:srgbClr val="6A7891"/>
                 </a:solidFill>
               </a:rPr>
-              <a:t>AI WORKLOAD OPTIMIZATION HUB</a:t>
-            </a:r>
-          </a:p>
-        </p:txBody>
-      </p:sp>
-      <p:sp>
-        <p:nvSpPr>
-          <p:cNvPr id="7" name="TextBox 6"/>
-          <p:cNvSpPr txBox="1"/>
-          <p:nvPr/>
-        </p:nvSpPr>
-        <p:spPr>
-          <a:xfrm>
-            <a:off x="411480" y="896112"/>
-            <a:ext cx="7863840" cy="228600"/>
-          </a:xfrm>
-          <a:prstGeom prst="rect">
-            <a:avLst/>
-          </a:prstGeom>
-          <a:noFill/>
-        </p:spPr>
-        <p:txBody>
-          <a:bodyPr wrap="none">
-            <a:spAutoFit/>
-          </a:bodyPr>
-          <a:lstStyle/>
-          <a:p>
-            <a:r>
-              <a:rPr sz="1150">
-                <a:solidFill>
-                  <a:srgbClr val="D0D8E7"/>
-                </a:solidFill>
-              </a:rPr>
-              <a:t>A new layout focused on how SmartTune observes, optimizes, and protects Intel® XPU workloads in pilot deployments.</a:t>
+              <a:t>READY FOR PILOT DEPLOYMENT</a:t>
             </a:r>
           </a:p>
         </p:txBody>
@@ -3314,17 +3322,19 @@
         </p:nvSpPr>
         <p:spPr>
           <a:xfrm>
-            <a:off x="10104120" y="228600"/>
-            <a:ext cx="1691640" cy="384048"/>
+            <a:off x="7635240" y="713232"/>
+            <a:ext cx="4069080" cy="1920240"/>
           </a:xfrm>
           <a:prstGeom prst="roundRect">
             <a:avLst/>
           </a:prstGeom>
           <a:solidFill>
-            <a:srgbClr val="1168BE"/>
+            <a:srgbClr val="FFFFFF"/>
           </a:solidFill>
           <a:ln>
-            <a:noFill/>
+            <a:solidFill>
+              <a:srgbClr val="DBE2EC"/>
+            </a:solidFill>
           </a:ln>
         </p:spPr>
         <p:style>
@@ -3346,33 +3356,58 @@
           <a:lstStyle/>
           <a:p>
             <a:pPr algn="ctr"/>
-            <a:r>
-              <a:rPr sz="1200" b="1">
-                <a:solidFill>
-                  <a:srgbClr val="FFFFFF"/>
+          </a:p>
+        </p:txBody>
+      </p:sp>
+      <p:sp>
+        <p:nvSpPr>
+          <p:cNvPr id="9" name="TextBox 8"/>
+          <p:cNvSpPr txBox="1"/>
+          <p:nvPr/>
+        </p:nvSpPr>
+        <p:spPr>
+          <a:xfrm>
+            <a:off x="7909560" y="914400"/>
+            <a:ext cx="2560320" cy="201168"/>
+          </a:xfrm>
+          <a:prstGeom prst="rect">
+            <a:avLst/>
+          </a:prstGeom>
+          <a:noFill/>
+        </p:spPr>
+        <p:txBody>
+          <a:bodyPr wrap="none">
+            <a:spAutoFit/>
+          </a:bodyPr>
+          <a:lstStyle/>
+          <a:p>
+            <a:r>
+              <a:rPr sz="1100" b="1">
+                <a:solidFill>
+                  <a:srgbClr val="1269BF"/>
                 </a:solidFill>
               </a:rPr>
-              <a:t>Q3'26  PILOT</a:t>
-            </a:r>
-          </a:p>
-        </p:txBody>
-      </p:sp>
-      <p:sp>
-        <p:nvSpPr>
-          <p:cNvPr id="9" name="Rounded Rectangle 8"/>
+              <a:t>EXECUTIVE SUMMARY</a:t>
+            </a:r>
+          </a:p>
+        </p:txBody>
+      </p:sp>
+      <p:sp>
+        <p:nvSpPr>
+          <p:cNvPr id="10" name="Oval 9"/>
           <p:cNvSpPr/>
           <p:nvPr/>
         </p:nvSpPr>
         <p:spPr>
           <a:xfrm>
-            <a:off x="9829800" y="731520"/>
-            <a:ext cx="1965960" cy="384048"/>
-          </a:xfrm>
-          <a:prstGeom prst="roundRect">
+            <a:off x="7936992" y="1234440"/>
+            <a:ext cx="91440" cy="91440"/>
+          </a:xfrm>
+          <a:prstGeom prst="ellipse">
             <a:avLst/>
           </a:prstGeom>
           <a:solidFill>
-            <a:srgbClr val="223252"/>
+            <a:srgbClr val="1269BF"/>
           </a:solidFill>
           <a:ln>
             <a:noFill/>
@@ -3397,38 +3432,61 @@
           <a:lstStyle/>
           <a:p>
             <a:pPr algn="ctr"/>
-            <a:r>
-              <a:rPr sz="1050" b="1">
-                <a:solidFill>
-                  <a:srgbClr val="FFFFFF"/>
+          </a:p>
+        </p:txBody>
+      </p:sp>
+      <p:sp>
+        <p:nvSpPr>
+          <p:cNvPr id="11" name="TextBox 10"/>
+          <p:cNvSpPr txBox="1"/>
+          <p:nvPr/>
+        </p:nvSpPr>
+        <p:spPr>
+          <a:xfrm>
+            <a:off x="8119872" y="1188720"/>
+            <a:ext cx="3154680" cy="274320"/>
+          </a:xfrm>
+          <a:prstGeom prst="rect">
+            <a:avLst/>
+          </a:prstGeom>
+          <a:noFill/>
+        </p:spPr>
+        <p:txBody>
+          <a:bodyPr wrap="square">
+            <a:spAutoFit/>
+          </a:bodyPr>
+          <a:lstStyle/>
+          <a:p>
+            <a:r>
+              <a:rPr sz="1000">
+                <a:solidFill>
+                  <a:srgbClr val="525F78"/>
                 </a:solidFill>
               </a:rPr>
-              <a:t>Editable customer list</a:t>
-            </a:r>
-          </a:p>
-        </p:txBody>
-      </p:sp>
-      <p:sp>
-        <p:nvSpPr>
-          <p:cNvPr id="10" name="Rounded Rectangle 9"/>
+              <a:t>SmartTune centralizes telemetry, policy control, and workload governance.</a:t>
+            </a:r>
+          </a:p>
+        </p:txBody>
+      </p:sp>
+      <p:sp>
+        <p:nvSpPr>
+          <p:cNvPr id="12" name="Oval 11"/>
           <p:cNvSpPr/>
           <p:nvPr/>
         </p:nvSpPr>
         <p:spPr>
           <a:xfrm>
-            <a:off x="347472" y="1572768"/>
-            <a:ext cx="6858000" cy="4434840"/>
-          </a:xfrm>
-          <a:prstGeom prst="roundRect">
+            <a:off x="7936992" y="1618488"/>
+            <a:ext cx="91440" cy="91440"/>
+          </a:xfrm>
+          <a:prstGeom prst="ellipse">
             <a:avLst/>
           </a:prstGeom>
           <a:solidFill>
-            <a:srgbClr val="FFFFFF"/>
+            <a:srgbClr val="1EB074"/>
           </a:solidFill>
           <a:ln>
-            <a:solidFill>
-              <a:srgbClr val="D5DDE8"/>
-            </a:solidFill>
+            <a:noFill/>
           </a:ln>
         </p:spPr>
         <p:style>
@@ -3455,47 +3513,14 @@
       </p:sp>
       <p:sp>
         <p:nvSpPr>
-          <p:cNvPr id="11" name="TextBox 10"/>
+          <p:cNvPr id="13" name="TextBox 12"/>
           <p:cNvSpPr txBox="1"/>
           <p:nvPr/>
         </p:nvSpPr>
         <p:spPr>
           <a:xfrm>
-            <a:off x="594360" y="1792224"/>
-            <a:ext cx="3474720" cy="201168"/>
-          </a:xfrm>
-          <a:prstGeom prst="rect">
-            <a:avLst/>
-          </a:prstGeom>
-          <a:noFill/>
-        </p:spPr>
-        <p:txBody>
-          <a:bodyPr wrap="none">
-            <a:spAutoFit/>
-          </a:bodyPr>
-          <a:lstStyle/>
-          <a:p>
-            <a:r>
-              <a:rPr sz="1200" b="1">
-                <a:solidFill>
-                  <a:srgbClr val="1168BE"/>
-                </a:solidFill>
-              </a:rPr>
-              <a:t>WHAT THE MIDDLE SECTION SHOWS</a:t>
-            </a:r>
-          </a:p>
-        </p:txBody>
-      </p:sp>
-      <p:sp>
-        <p:nvSpPr>
-          <p:cNvPr id="12" name="TextBox 11"/>
-          <p:cNvSpPr txBox="1"/>
-          <p:nvPr/>
-        </p:nvSpPr>
-        <p:spPr>
-          <a:xfrm>
-            <a:off x="594360" y="1993392"/>
-            <a:ext cx="6126480" cy="402336"/>
+            <a:off x="8119872" y="1572768"/>
+            <a:ext cx="3154680" cy="274320"/>
           </a:xfrm>
           <a:prstGeom prst="rect">
             <a:avLst/>
@@ -3509,45 +3534,12 @@
           <a:lstStyle/>
           <a:p>
             <a:r>
-              <a:rPr sz="1900" b="1">
-                <a:solidFill>
-                  <a:srgbClr val="121F3A"/>
+              <a:rPr sz="1000">
+                <a:solidFill>
+                  <a:srgbClr val="525F78"/>
                 </a:solidFill>
               </a:rPr>
-              <a:t>A hub-and-spoke workflow that explains SmartTune’s role in the platform.</a:t>
-            </a:r>
-          </a:p>
-        </p:txBody>
-      </p:sp>
-      <p:sp>
-        <p:nvSpPr>
-          <p:cNvPr id="13" name="TextBox 12"/>
-          <p:cNvSpPr txBox="1"/>
-          <p:nvPr/>
-        </p:nvSpPr>
-        <p:spPr>
-          <a:xfrm>
-            <a:off x="594360" y="2377440"/>
-            <a:ext cx="6126480" cy="457200"/>
-          </a:xfrm>
-          <a:prstGeom prst="rect">
-            <a:avLst/>
-          </a:prstGeom>
-          <a:noFill/>
-        </p:spPr>
-        <p:txBody>
-          <a:bodyPr wrap="square">
-            <a:spAutoFit/>
-          </a:bodyPr>
-          <a:lstStyle/>
-          <a:p>
-            <a:r>
-              <a:rPr sz="1050">
-                <a:solidFill>
-                  <a:srgbClr val="4C5C76"/>
-                </a:solidFill>
-              </a:rPr>
-              <a:t>It highlights the core optimization loop: sense system pressure, balance resources automatically, and protect critical applications so teams can reach production readiness faster.</a:t>
+              <a:t>It reduces tuning effort and protects critical AI / graphics workloads under pressure.</a:t>
             </a:r>
           </a:p>
         </p:txBody>
@@ -3560,14 +3552,14 @@
         </p:nvSpPr>
         <p:spPr>
           <a:xfrm>
-            <a:off x="2514600" y="3063240"/>
-            <a:ext cx="2194560" cy="1325880"/>
+            <a:off x="7936992" y="2002536"/>
+            <a:ext cx="91440" cy="91440"/>
           </a:xfrm>
           <a:prstGeom prst="ellipse">
             <a:avLst/>
           </a:prstGeom>
           <a:solidFill>
-            <a:srgbClr val="121F3A"/>
+            <a:srgbClr val="F2A42A"/>
           </a:solidFill>
           <a:ln>
             <a:noFill/>
@@ -3603,8 +3595,127 @@
         </p:nvSpPr>
         <p:spPr>
           <a:xfrm>
-            <a:off x="2743200" y="3410712"/>
-            <a:ext cx="1737360" cy="502920"/>
+            <a:off x="8119872" y="1956816"/>
+            <a:ext cx="3154680" cy="274320"/>
+          </a:xfrm>
+          <a:prstGeom prst="rect">
+            <a:avLst/>
+          </a:prstGeom>
+          <a:noFill/>
+        </p:spPr>
+        <p:txBody>
+          <a:bodyPr wrap="square">
+            <a:spAutoFit/>
+          </a:bodyPr>
+          <a:lstStyle/>
+          <a:p>
+            <a:r>
+              <a:rPr sz="1000">
+                <a:solidFill>
+                  <a:srgbClr val="525F78"/>
+                </a:solidFill>
+              </a:rPr>
+              <a:t>It provides a repeatable optimization foundation for Intel® XPU platform adoption.</a:t>
+            </a:r>
+          </a:p>
+        </p:txBody>
+      </p:sp>
+      <p:sp>
+        <p:nvSpPr>
+          <p:cNvPr id="16" name="Rectangle 15"/>
+          <p:cNvSpPr/>
+          <p:nvPr/>
+        </p:nvSpPr>
+        <p:spPr>
+          <a:xfrm>
+            <a:off x="502920" y="2240280"/>
+            <a:ext cx="82296" cy="1417320"/>
+          </a:xfrm>
+          <a:prstGeom prst="rect">
+            <a:avLst/>
+          </a:prstGeom>
+          <a:solidFill>
+            <a:srgbClr val="F2A42A"/>
+          </a:solidFill>
+          <a:ln>
+            <a:noFill/>
+          </a:ln>
+        </p:spPr>
+        <p:style>
+          <a:lnRef idx="1">
+            <a:schemeClr val="accent1"/>
+          </a:lnRef>
+          <a:fillRef idx="3">
+            <a:schemeClr val="accent1"/>
+          </a:fillRef>
+          <a:effectRef idx="2">
+            <a:schemeClr val="accent1"/>
+          </a:effectRef>
+          <a:fontRef idx="minor">
+            <a:schemeClr val="lt1"/>
+          </a:fontRef>
+        </p:style>
+        <p:txBody>
+          <a:bodyPr rtlCol="0" anchor="ctr"/>
+          <a:lstStyle/>
+          <a:p>
+            <a:pPr algn="ctr"/>
+          </a:p>
+        </p:txBody>
+      </p:sp>
+      <p:sp>
+        <p:nvSpPr>
+          <p:cNvPr id="17" name="Rounded Rectangle 16"/>
+          <p:cNvSpPr/>
+          <p:nvPr/>
+        </p:nvSpPr>
+        <p:spPr>
+          <a:xfrm>
+            <a:off x="594360" y="2240280"/>
+            <a:ext cx="6675120" cy="1417320"/>
+          </a:xfrm>
+          <a:prstGeom prst="roundRect">
+            <a:avLst/>
+          </a:prstGeom>
+          <a:solidFill>
+            <a:srgbClr val="162543"/>
+          </a:solidFill>
+          <a:ln>
+            <a:noFill/>
+          </a:ln>
+        </p:spPr>
+        <p:style>
+          <a:lnRef idx="1">
+            <a:schemeClr val="accent1"/>
+          </a:lnRef>
+          <a:fillRef idx="3">
+            <a:schemeClr val="accent1"/>
+          </a:fillRef>
+          <a:effectRef idx="2">
+            <a:schemeClr val="accent1"/>
+          </a:effectRef>
+          <a:fontRef idx="minor">
+            <a:schemeClr val="lt1"/>
+          </a:fontRef>
+        </p:style>
+        <p:txBody>
+          <a:bodyPr rtlCol="0" anchor="ctr"/>
+          <a:lstStyle/>
+          <a:p>
+            <a:pPr algn="ctr"/>
+          </a:p>
+        </p:txBody>
+      </p:sp>
+      <p:sp>
+        <p:nvSpPr>
+          <p:cNvPr id="18" name="TextBox 17"/>
+          <p:cNvSpPr txBox="1"/>
+          <p:nvPr/>
+        </p:nvSpPr>
+        <p:spPr>
+          <a:xfrm>
+            <a:off x="804672" y="2450592"/>
+            <a:ext cx="3291840" cy="201168"/>
           </a:xfrm>
           <a:prstGeom prst="rect">
             <a:avLst/>
@@ -3617,31 +3728,103 @@
           </a:bodyPr>
           <a:lstStyle/>
           <a:p>
-            <a:pPr algn="ctr"/>
+            <a:r>
+              <a:rPr sz="1200" b="1">
+                <a:solidFill>
+                  <a:srgbClr val="1EB074"/>
+                </a:solidFill>
+              </a:rPr>
+              <a:t>BUSINESS IMPACT / CORE PLATFORM ROLE</a:t>
+            </a:r>
+          </a:p>
+        </p:txBody>
+      </p:sp>
+      <p:sp>
+        <p:nvSpPr>
+          <p:cNvPr id="19" name="TextBox 18"/>
+          <p:cNvSpPr txBox="1"/>
+          <p:nvPr/>
+        </p:nvSpPr>
+        <p:spPr>
+          <a:xfrm>
+            <a:off x="804672" y="2743200"/>
+            <a:ext cx="6126480" cy="493776"/>
+          </a:xfrm>
+          <a:prstGeom prst="rect">
+            <a:avLst/>
+          </a:prstGeom>
+          <a:noFill/>
+        </p:spPr>
+        <p:txBody>
+          <a:bodyPr wrap="square">
+            <a:spAutoFit/>
+          </a:bodyPr>
+          <a:lstStyle/>
+          <a:p>
             <a:r>
               <a:rPr sz="1800" b="1">
                 <a:solidFill>
                   <a:srgbClr val="FFFFFF"/>
                 </a:solidFill>
               </a:rPr>
-              <a:t>SMARTUNE
-OPTIMIZATION HUB</a:t>
-            </a:r>
-          </a:p>
-        </p:txBody>
-      </p:sp>
-      <p:sp>
-        <p:nvSpPr>
-          <p:cNvPr id="16" name="Rounded Rectangle 15"/>
+              <a:t>SmartTune is the optimization control layer for Intel® XPU systems — </a:t>
+            </a:r>
+            <a:r>
+              <a:rPr sz="1800">
+                <a:solidFill>
+                  <a:srgbClr val="FFFFFF"/>
+                </a:solidFill>
+              </a:rPr>
+              <a:t>turning system telemetry into resource-balancing actions that improve workload stability, reduce manual tuning, and accelerate production readiness.</a:t>
+            </a:r>
+          </a:p>
+        </p:txBody>
+      </p:sp>
+      <p:sp>
+        <p:nvSpPr>
+          <p:cNvPr id="20" name="TextBox 19"/>
+          <p:cNvSpPr txBox="1"/>
+          <p:nvPr/>
+        </p:nvSpPr>
+        <p:spPr>
+          <a:xfrm>
+            <a:off x="804672" y="3310128"/>
+            <a:ext cx="6126480" cy="201168"/>
+          </a:xfrm>
+          <a:prstGeom prst="rect">
+            <a:avLst/>
+          </a:prstGeom>
+          <a:noFill/>
+        </p:spPr>
+        <p:txBody>
+          <a:bodyPr wrap="none">
+            <a:spAutoFit/>
+          </a:bodyPr>
+          <a:lstStyle/>
+          <a:p>
+            <a:r>
+              <a:rPr sz="950">
+                <a:solidFill>
+                  <a:srgbClr val="CDD6E5"/>
+                </a:solidFill>
+              </a:rPr>
+              <a:t>Middle-section emphasis: what SmartTune is, and why it matters to business outcomes.</a:t>
+            </a:r>
+          </a:p>
+        </p:txBody>
+      </p:sp>
+      <p:sp>
+        <p:nvSpPr>
+          <p:cNvPr id="21" name="Oval 20"/>
           <p:cNvSpPr/>
           <p:nvPr/>
         </p:nvSpPr>
         <p:spPr>
           <a:xfrm>
-            <a:off x="822960" y="3200400"/>
-            <a:ext cx="2148840" cy="914400"/>
-          </a:xfrm>
-          <a:prstGeom prst="roundRect">
+            <a:off x="7406640" y="2011680"/>
+            <a:ext cx="4480560" cy="2057400"/>
+          </a:xfrm>
+          <a:prstGeom prst="ellipse">
             <a:avLst/>
           </a:prstGeom>
           <a:solidFill>
@@ -3673,573 +3856,9 @@
           </a:p>
         </p:txBody>
       </p:sp>
-      <p:sp>
-        <p:nvSpPr>
-          <p:cNvPr id="17" name="Rounded Rectangle 16"/>
-          <p:cNvSpPr/>
-          <p:nvPr/>
-        </p:nvSpPr>
-        <p:spPr>
-          <a:xfrm>
-            <a:off x="932688" y="3291840"/>
-            <a:ext cx="822960" cy="201168"/>
-          </a:xfrm>
-          <a:prstGeom prst="roundRect">
-            <a:avLst/>
-          </a:prstGeom>
-          <a:solidFill>
-            <a:srgbClr val="1168BE"/>
-          </a:solidFill>
-          <a:ln>
-            <a:noFill/>
-          </a:ln>
-        </p:spPr>
-        <p:style>
-          <a:lnRef idx="1">
-            <a:schemeClr val="accent1"/>
-          </a:lnRef>
-          <a:fillRef idx="3">
-            <a:schemeClr val="accent1"/>
-          </a:fillRef>
-          <a:effectRef idx="2">
-            <a:schemeClr val="accent1"/>
-          </a:effectRef>
-          <a:fontRef idx="minor">
-            <a:schemeClr val="lt1"/>
-          </a:fontRef>
-        </p:style>
-        <p:txBody>
-          <a:bodyPr rtlCol="0" anchor="ctr"/>
-          <a:lstStyle/>
-          <a:p>
-            <a:pPr algn="ctr"/>
-            <a:r>
-              <a:rPr sz="900" b="1">
-                <a:solidFill>
-                  <a:srgbClr val="FFFFFF"/>
-                </a:solidFill>
-              </a:rPr>
-              <a:t>01  OBSERVE</a:t>
-            </a:r>
-          </a:p>
-        </p:txBody>
-      </p:sp>
-      <p:sp>
-        <p:nvSpPr>
-          <p:cNvPr id="18" name="TextBox 17"/>
-          <p:cNvSpPr txBox="1"/>
-          <p:nvPr/>
-        </p:nvSpPr>
-        <p:spPr>
-          <a:xfrm>
-            <a:off x="950976" y="3566160"/>
-            <a:ext cx="1874519" cy="438912"/>
-          </a:xfrm>
-          <a:prstGeom prst="rect">
-            <a:avLst/>
-          </a:prstGeom>
-          <a:noFill/>
-        </p:spPr>
-        <p:txBody>
-          <a:bodyPr wrap="square">
-            <a:spAutoFit/>
-          </a:bodyPr>
-          <a:lstStyle/>
-          <a:p>
-            <a:r>
-              <a:rPr sz="950">
-                <a:solidFill>
-                  <a:srgbClr val="121F3A"/>
-                </a:solidFill>
-              </a:rPr>
-              <a:t>Collects CPU, memory, disk, GPU, and NPU telemetry to detect bottlenecks in real time.</a:t>
-            </a:r>
-          </a:p>
-        </p:txBody>
-      </p:sp>
-      <p:sp>
-        <p:nvSpPr>
-          <p:cNvPr id="19" name="Rounded Rectangle 18"/>
-          <p:cNvSpPr/>
-          <p:nvPr/>
-        </p:nvSpPr>
-        <p:spPr>
-          <a:xfrm>
-            <a:off x="4800600" y="2743200"/>
-            <a:ext cx="2148840" cy="914400"/>
-          </a:xfrm>
-          <a:prstGeom prst="roundRect">
-            <a:avLst/>
-          </a:prstGeom>
-          <a:solidFill>
-            <a:srgbClr val="E8EEF7"/>
-          </a:solidFill>
-          <a:ln>
-            <a:noFill/>
-          </a:ln>
-        </p:spPr>
-        <p:style>
-          <a:lnRef idx="1">
-            <a:schemeClr val="accent1"/>
-          </a:lnRef>
-          <a:fillRef idx="3">
-            <a:schemeClr val="accent1"/>
-          </a:fillRef>
-          <a:effectRef idx="2">
-            <a:schemeClr val="accent1"/>
-          </a:effectRef>
-          <a:fontRef idx="minor">
-            <a:schemeClr val="lt1"/>
-          </a:fontRef>
-        </p:style>
-        <p:txBody>
-          <a:bodyPr rtlCol="0" anchor="ctr"/>
-          <a:lstStyle/>
-          <a:p>
-            <a:pPr algn="ctr"/>
-          </a:p>
-        </p:txBody>
-      </p:sp>
-      <p:sp>
-        <p:nvSpPr>
-          <p:cNvPr id="20" name="Rounded Rectangle 19"/>
-          <p:cNvSpPr/>
-          <p:nvPr/>
-        </p:nvSpPr>
-        <p:spPr>
-          <a:xfrm>
-            <a:off x="4910328" y="2834640"/>
-            <a:ext cx="822960" cy="201168"/>
-          </a:xfrm>
-          <a:prstGeom prst="roundRect">
-            <a:avLst/>
-          </a:prstGeom>
-          <a:solidFill>
-            <a:srgbClr val="1FB177"/>
-          </a:solidFill>
-          <a:ln>
-            <a:noFill/>
-          </a:ln>
-        </p:spPr>
-        <p:style>
-          <a:lnRef idx="1">
-            <a:schemeClr val="accent1"/>
-          </a:lnRef>
-          <a:fillRef idx="3">
-            <a:schemeClr val="accent1"/>
-          </a:fillRef>
-          <a:effectRef idx="2">
-            <a:schemeClr val="accent1"/>
-          </a:effectRef>
-          <a:fontRef idx="minor">
-            <a:schemeClr val="lt1"/>
-          </a:fontRef>
-        </p:style>
-        <p:txBody>
-          <a:bodyPr rtlCol="0" anchor="ctr"/>
-          <a:lstStyle/>
-          <a:p>
-            <a:pPr algn="ctr"/>
-            <a:r>
-              <a:rPr sz="900" b="1">
-                <a:solidFill>
-                  <a:srgbClr val="FFFFFF"/>
-                </a:solidFill>
-              </a:rPr>
-              <a:t>02  OPTIMIZE</a:t>
-            </a:r>
-          </a:p>
-        </p:txBody>
-      </p:sp>
-      <p:sp>
-        <p:nvSpPr>
-          <p:cNvPr id="21" name="TextBox 20"/>
-          <p:cNvSpPr txBox="1"/>
-          <p:nvPr/>
-        </p:nvSpPr>
-        <p:spPr>
-          <a:xfrm>
-            <a:off x="4928616" y="3108960"/>
-            <a:ext cx="1874519" cy="438912"/>
-          </a:xfrm>
-          <a:prstGeom prst="rect">
-            <a:avLst/>
-          </a:prstGeom>
-          <a:noFill/>
-        </p:spPr>
-        <p:txBody>
-          <a:bodyPr wrap="square">
-            <a:spAutoFit/>
-          </a:bodyPr>
-          <a:lstStyle/>
-          <a:p>
-            <a:r>
-              <a:rPr sz="950">
-                <a:solidFill>
-                  <a:srgbClr val="121F3A"/>
-                </a:solidFill>
-              </a:rPr>
-              <a:t>Applies policy-based balancing, launch queuing, and cgroup controls to keep workloads efficient.</a:t>
-            </a:r>
-          </a:p>
-        </p:txBody>
-      </p:sp>
-      <p:sp>
-        <p:nvSpPr>
-          <p:cNvPr id="22" name="Rounded Rectangle 21"/>
-          <p:cNvSpPr/>
-          <p:nvPr/>
-        </p:nvSpPr>
-        <p:spPr>
-          <a:xfrm>
-            <a:off x="1965960" y="4663440"/>
-            <a:ext cx="2148840" cy="914400"/>
-          </a:xfrm>
-          <a:prstGeom prst="roundRect">
-            <a:avLst/>
-          </a:prstGeom>
-          <a:solidFill>
-            <a:srgbClr val="E8EEF7"/>
-          </a:solidFill>
-          <a:ln>
-            <a:noFill/>
-          </a:ln>
-        </p:spPr>
-        <p:style>
-          <a:lnRef idx="1">
-            <a:schemeClr val="accent1"/>
-          </a:lnRef>
-          <a:fillRef idx="3">
-            <a:schemeClr val="accent1"/>
-          </a:fillRef>
-          <a:effectRef idx="2">
-            <a:schemeClr val="accent1"/>
-          </a:effectRef>
-          <a:fontRef idx="minor">
-            <a:schemeClr val="lt1"/>
-          </a:fontRef>
-        </p:style>
-        <p:txBody>
-          <a:bodyPr rtlCol="0" anchor="ctr"/>
-          <a:lstStyle/>
-          <a:p>
-            <a:pPr algn="ctr"/>
-          </a:p>
-        </p:txBody>
-      </p:sp>
-      <p:sp>
-        <p:nvSpPr>
-          <p:cNvPr id="23" name="Rounded Rectangle 22"/>
-          <p:cNvSpPr/>
-          <p:nvPr/>
-        </p:nvSpPr>
-        <p:spPr>
-          <a:xfrm>
-            <a:off x="2075688" y="4754879"/>
-            <a:ext cx="822960" cy="201168"/>
-          </a:xfrm>
-          <a:prstGeom prst="roundRect">
-            <a:avLst/>
-          </a:prstGeom>
-          <a:solidFill>
-            <a:srgbClr val="F7AA2E"/>
-          </a:solidFill>
-          <a:ln>
-            <a:noFill/>
-          </a:ln>
-        </p:spPr>
-        <p:style>
-          <a:lnRef idx="1">
-            <a:schemeClr val="accent1"/>
-          </a:lnRef>
-          <a:fillRef idx="3">
-            <a:schemeClr val="accent1"/>
-          </a:fillRef>
-          <a:effectRef idx="2">
-            <a:schemeClr val="accent1"/>
-          </a:effectRef>
-          <a:fontRef idx="minor">
-            <a:schemeClr val="lt1"/>
-          </a:fontRef>
-        </p:style>
-        <p:txBody>
-          <a:bodyPr rtlCol="0" anchor="ctr"/>
-          <a:lstStyle/>
-          <a:p>
-            <a:pPr algn="ctr"/>
-            <a:r>
-              <a:rPr sz="900" b="1">
-                <a:solidFill>
-                  <a:srgbClr val="FFFFFF"/>
-                </a:solidFill>
-              </a:rPr>
-              <a:t>03  PROTECT</a:t>
-            </a:r>
-          </a:p>
-        </p:txBody>
-      </p:sp>
-      <p:sp>
-        <p:nvSpPr>
-          <p:cNvPr id="24" name="TextBox 23"/>
-          <p:cNvSpPr txBox="1"/>
-          <p:nvPr/>
-        </p:nvSpPr>
-        <p:spPr>
-          <a:xfrm>
-            <a:off x="2093976" y="5029200"/>
-            <a:ext cx="1874519" cy="438912"/>
-          </a:xfrm>
-          <a:prstGeom prst="rect">
-            <a:avLst/>
-          </a:prstGeom>
-          <a:noFill/>
-        </p:spPr>
-        <p:txBody>
-          <a:bodyPr wrap="square">
-            <a:spAutoFit/>
-          </a:bodyPr>
-          <a:lstStyle/>
-          <a:p>
-            <a:r>
-              <a:rPr sz="950">
-                <a:solidFill>
-                  <a:srgbClr val="121F3A"/>
-                </a:solidFill>
-              </a:rPr>
-              <a:t>Preserves responsiveness for critical applications with keep-alive and priority-aware recovery.</a:t>
-            </a:r>
-          </a:p>
-        </p:txBody>
-      </p:sp>
-      <p:cxnSp>
-        <p:nvCxnSpPr>
-          <p:cNvPr id="25" name="Connector 24"/>
-          <p:cNvCxnSpPr/>
-          <p:nvPr/>
-        </p:nvCxnSpPr>
-        <p:spPr>
-          <a:xfrm>
-            <a:off x="2514600" y="3703320"/>
-            <a:ext cx="411480" cy="0"/>
-          </a:xfrm>
-          <a:prstGeom prst="line">
-            <a:avLst/>
-          </a:prstGeom>
-          <a:ln w="28575">
-            <a:solidFill>
-              <a:srgbClr val="1168BE"/>
-            </a:solidFill>
-          </a:ln>
-        </p:spPr>
-        <p:style>
-          <a:lnRef idx="2">
-            <a:schemeClr val="accent1"/>
-          </a:lnRef>
-          <a:fillRef idx="0">
-            <a:schemeClr val="accent1"/>
-          </a:fillRef>
-          <a:effectRef idx="1">
-            <a:schemeClr val="accent1"/>
-          </a:effectRef>
-          <a:fontRef idx="minor">
-            <a:schemeClr val="tx1"/>
-          </a:fontRef>
-        </p:style>
-      </p:cxnSp>
-      <p:cxnSp>
-        <p:nvCxnSpPr>
-          <p:cNvPr id="26" name="Connector 25"/>
-          <p:cNvCxnSpPr/>
-          <p:nvPr/>
-        </p:nvCxnSpPr>
-        <p:spPr>
-          <a:xfrm flipV="1">
-            <a:off x="4709160" y="3429000"/>
-            <a:ext cx="91440" cy="228600"/>
-          </a:xfrm>
-          <a:prstGeom prst="line">
-            <a:avLst/>
-          </a:prstGeom>
-          <a:ln w="28575">
-            <a:solidFill>
-              <a:srgbClr val="1FB177"/>
-            </a:solidFill>
-          </a:ln>
-        </p:spPr>
-        <p:style>
-          <a:lnRef idx="2">
-            <a:schemeClr val="accent1"/>
-          </a:lnRef>
-          <a:fillRef idx="0">
-            <a:schemeClr val="accent1"/>
-          </a:fillRef>
-          <a:effectRef idx="1">
-            <a:schemeClr val="accent1"/>
-          </a:effectRef>
-          <a:fontRef idx="minor">
-            <a:schemeClr val="tx1"/>
-          </a:fontRef>
-        </p:style>
-      </p:cxnSp>
-      <p:cxnSp>
-        <p:nvCxnSpPr>
-          <p:cNvPr id="27" name="Connector 26"/>
-          <p:cNvCxnSpPr/>
-          <p:nvPr/>
-        </p:nvCxnSpPr>
-        <p:spPr>
-          <a:xfrm flipH="1">
-            <a:off x="3291840" y="4389120"/>
-            <a:ext cx="320040" cy="274320"/>
-          </a:xfrm>
-          <a:prstGeom prst="line">
-            <a:avLst/>
-          </a:prstGeom>
-          <a:ln w="28575">
-            <a:solidFill>
-              <a:srgbClr val="F7AA2E"/>
-            </a:solidFill>
-          </a:ln>
-        </p:spPr>
-        <p:style>
-          <a:lnRef idx="2">
-            <a:schemeClr val="accent1"/>
-          </a:lnRef>
-          <a:fillRef idx="0">
-            <a:schemeClr val="accent1"/>
-          </a:fillRef>
-          <a:effectRef idx="1">
-            <a:schemeClr val="accent1"/>
-          </a:effectRef>
-          <a:fontRef idx="minor">
-            <a:schemeClr val="tx1"/>
-          </a:fontRef>
-        </p:style>
-      </p:cxnSp>
-      <p:sp>
-        <p:nvSpPr>
-          <p:cNvPr id="28" name="Rounded Rectangle 27"/>
-          <p:cNvSpPr/>
-          <p:nvPr/>
-        </p:nvSpPr>
-        <p:spPr>
-          <a:xfrm>
-            <a:off x="7388352" y="1572768"/>
-            <a:ext cx="4462272" cy="4434840"/>
-          </a:xfrm>
-          <a:prstGeom prst="roundRect">
-            <a:avLst/>
-          </a:prstGeom>
-          <a:solidFill>
-            <a:srgbClr val="FFFFFF"/>
-          </a:solidFill>
-          <a:ln>
-            <a:solidFill>
-              <a:srgbClr val="D5DDE8"/>
-            </a:solidFill>
-          </a:ln>
-        </p:spPr>
-        <p:style>
-          <a:lnRef idx="1">
-            <a:schemeClr val="accent1"/>
-          </a:lnRef>
-          <a:fillRef idx="3">
-            <a:schemeClr val="accent1"/>
-          </a:fillRef>
-          <a:effectRef idx="2">
-            <a:schemeClr val="accent1"/>
-          </a:effectRef>
-          <a:fontRef idx="minor">
-            <a:schemeClr val="lt1"/>
-          </a:fontRef>
-        </p:style>
-        <p:txBody>
-          <a:bodyPr rtlCol="0" anchor="ctr"/>
-          <a:lstStyle/>
-          <a:p>
-            <a:pPr algn="ctr"/>
-          </a:p>
-        </p:txBody>
-      </p:sp>
-      <p:sp>
-        <p:nvSpPr>
-          <p:cNvPr id="29" name="TextBox 28"/>
-          <p:cNvSpPr txBox="1"/>
-          <p:nvPr/>
-        </p:nvSpPr>
-        <p:spPr>
-          <a:xfrm>
-            <a:off x="7635240" y="1792224"/>
-            <a:ext cx="2926080" cy="201168"/>
-          </a:xfrm>
-          <a:prstGeom prst="rect">
-            <a:avLst/>
-          </a:prstGeom>
-          <a:noFill/>
-        </p:spPr>
-        <p:txBody>
-          <a:bodyPr wrap="none">
-            <a:spAutoFit/>
-          </a:bodyPr>
-          <a:lstStyle/>
-          <a:p>
-            <a:r>
-              <a:rPr sz="1200" b="1">
-                <a:solidFill>
-                  <a:srgbClr val="1168BE"/>
-                </a:solidFill>
-              </a:rPr>
-              <a:t>PLATFORM SNAPSHOT</a:t>
-            </a:r>
-          </a:p>
-        </p:txBody>
-      </p:sp>
-      <p:sp>
-        <p:nvSpPr>
-          <p:cNvPr id="30" name="Rounded Rectangle 29"/>
-          <p:cNvSpPr/>
-          <p:nvPr/>
-        </p:nvSpPr>
-        <p:spPr>
-          <a:xfrm>
-            <a:off x="7635240" y="2029968"/>
-            <a:ext cx="3977639" cy="1645920"/>
-          </a:xfrm>
-          <a:prstGeom prst="roundRect">
-            <a:avLst/>
-          </a:prstGeom>
-          <a:solidFill>
-            <a:srgbClr val="E8EEF7"/>
-          </a:solidFill>
-          <a:ln>
-            <a:noFill/>
-          </a:ln>
-        </p:spPr>
-        <p:style>
-          <a:lnRef idx="1">
-            <a:schemeClr val="accent1"/>
-          </a:lnRef>
-          <a:fillRef idx="3">
-            <a:schemeClr val="accent1"/>
-          </a:fillRef>
-          <a:effectRef idx="2">
-            <a:schemeClr val="accent1"/>
-          </a:effectRef>
-          <a:fontRef idx="minor">
-            <a:schemeClr val="lt1"/>
-          </a:fontRef>
-        </p:style>
-        <p:txBody>
-          <a:bodyPr rtlCol="0" anchor="ctr"/>
-          <a:lstStyle/>
-          <a:p>
-            <a:pPr algn="ctr"/>
-          </a:p>
-        </p:txBody>
-      </p:sp>
       <p:pic>
         <p:nvPicPr>
-          <p:cNvPr id="31" name="Picture 30" descr="architecture_15.png"/>
+          <p:cNvPr id="22" name="Picture 21" descr="architecture_15.png"/>
           <p:cNvPicPr>
             <a:picLocks noChangeAspect="1"/>
           </p:cNvPicPr>
@@ -4253,8 +3872,8 @@
         </p:blipFill>
         <p:spPr>
           <a:xfrm>
-            <a:off x="7818120" y="2212848"/>
-            <a:ext cx="3611880" cy="1503731"/>
+            <a:off x="7909560" y="2331720"/>
+            <a:ext cx="3474720" cy="1446628"/>
           </a:xfrm>
           <a:prstGeom prst="rect">
             <a:avLst/>
@@ -4263,14 +3882,14 @@
       </p:pic>
       <p:sp>
         <p:nvSpPr>
-          <p:cNvPr id="32" name="TextBox 31"/>
+          <p:cNvPr id="23" name="TextBox 22"/>
           <p:cNvSpPr txBox="1"/>
           <p:nvPr/>
         </p:nvSpPr>
         <p:spPr>
           <a:xfrm>
-            <a:off x="7699248" y="3822191"/>
-            <a:ext cx="3657600" cy="237744"/>
+            <a:off x="8229600" y="4041648"/>
+            <a:ext cx="3017520" cy="201168"/>
           </a:xfrm>
           <a:prstGeom prst="rect">
             <a:avLst/>
@@ -4283,36 +3902,106 @@
           </a:bodyPr>
           <a:lstStyle/>
           <a:p>
-            <a:r>
-              <a:rPr sz="1200" b="1">
-                <a:solidFill>
-                  <a:srgbClr val="121F3A"/>
+            <a:pPr algn="ctr"/>
+            <a:r>
+              <a:rPr sz="1150" b="1">
+                <a:solidFill>
+                  <a:srgbClr val="162543"/>
                 </a:solidFill>
               </a:rPr>
-              <a:t>WHY IT MATTERS</a:t>
-            </a:r>
-          </a:p>
-        </p:txBody>
-      </p:sp>
-      <p:sp>
-        <p:nvSpPr>
-          <p:cNvPr id="33" name="Oval 32"/>
+              <a:t>SMARTUNE PLATFORM ARCHITECTURE</a:t>
+            </a:r>
+          </a:p>
+        </p:txBody>
+      </p:sp>
+      <p:sp>
+        <p:nvSpPr>
+          <p:cNvPr id="24" name="TextBox 23"/>
+          <p:cNvSpPr txBox="1"/>
+          <p:nvPr/>
+        </p:nvSpPr>
+        <p:spPr>
+          <a:xfrm>
+            <a:off x="7955279" y="4261104"/>
+            <a:ext cx="3657600" cy="219456"/>
+          </a:xfrm>
+          <a:prstGeom prst="rect">
+            <a:avLst/>
+          </a:prstGeom>
+          <a:noFill/>
+        </p:spPr>
+        <p:txBody>
+          <a:bodyPr wrap="none">
+            <a:spAutoFit/>
+          </a:bodyPr>
+          <a:lstStyle/>
+          <a:p>
+            <a:pPr algn="ctr"/>
+            <a:r>
+              <a:rPr sz="900">
+                <a:solidFill>
+                  <a:srgbClr val="6A7891"/>
+                </a:solidFill>
+              </a:rPr>
+              <a:t>Unified telemetry, control, and governance across heterogeneous Intel® XPU workloads.</a:t>
+            </a:r>
+          </a:p>
+        </p:txBody>
+      </p:sp>
+      <p:sp>
+        <p:nvSpPr>
+          <p:cNvPr id="25" name="TextBox 24"/>
+          <p:cNvSpPr txBox="1"/>
+          <p:nvPr/>
+        </p:nvSpPr>
+        <p:spPr>
+          <a:xfrm>
+            <a:off x="502920" y="4498848"/>
+            <a:ext cx="2743200" cy="201168"/>
+          </a:xfrm>
+          <a:prstGeom prst="rect">
+            <a:avLst/>
+          </a:prstGeom>
+          <a:noFill/>
+        </p:spPr>
+        <p:txBody>
+          <a:bodyPr wrap="none">
+            <a:spAutoFit/>
+          </a:bodyPr>
+          <a:lstStyle/>
+          <a:p>
+            <a:r>
+              <a:rPr sz="1100" b="1">
+                <a:solidFill>
+                  <a:srgbClr val="6A7891"/>
+                </a:solidFill>
+              </a:rPr>
+              <a:t>EXECUTIVE VALUE HIGHLIGHTS</a:t>
+            </a:r>
+          </a:p>
+        </p:txBody>
+      </p:sp>
+      <p:sp>
+        <p:nvSpPr>
+          <p:cNvPr id="26" name="Rounded Rectangle 25"/>
           <p:cNvSpPr/>
           <p:nvPr/>
         </p:nvSpPr>
         <p:spPr>
           <a:xfrm>
-            <a:off x="7726679" y="4169663"/>
-            <a:ext cx="109728" cy="109728"/>
-          </a:xfrm>
-          <a:prstGeom prst="ellipse">
+            <a:off x="502920" y="4736592"/>
+            <a:ext cx="2560320" cy="1234440"/>
+          </a:xfrm>
+          <a:prstGeom prst="roundRect">
             <a:avLst/>
           </a:prstGeom>
           <a:solidFill>
-            <a:srgbClr val="1168BE"/>
+            <a:srgbClr val="FFFFFF"/>
           </a:solidFill>
           <a:ln>
-            <a:noFill/>
+            <a:solidFill>
+              <a:srgbClr val="DBE2EC"/>
+            </a:solidFill>
           </a:ln>
         </p:spPr>
         <p:style>
@@ -4339,53 +4028,20 @@
       </p:sp>
       <p:sp>
         <p:nvSpPr>
-          <p:cNvPr id="34" name="TextBox 33"/>
-          <p:cNvSpPr txBox="1"/>
-          <p:nvPr/>
-        </p:nvSpPr>
-        <p:spPr>
-          <a:xfrm>
-            <a:off x="7909560" y="4133087"/>
-            <a:ext cx="3611880" cy="256032"/>
-          </a:xfrm>
-          <a:prstGeom prst="rect">
-            <a:avLst/>
-          </a:prstGeom>
-          <a:noFill/>
-        </p:spPr>
-        <p:txBody>
-          <a:bodyPr wrap="square">
-            <a:spAutoFit/>
-          </a:bodyPr>
-          <a:lstStyle/>
-          <a:p>
-            <a:r>
-              <a:rPr sz="1000">
-                <a:solidFill>
-                  <a:srgbClr val="4C5C76"/>
-                </a:solidFill>
-              </a:rPr>
-              <a:t>Reduces manual tuning effort across heterogeneous Intel® XPU workloads.</a:t>
-            </a:r>
-          </a:p>
-        </p:txBody>
-      </p:sp>
-      <p:sp>
-        <p:nvSpPr>
-          <p:cNvPr id="35" name="Oval 34"/>
+          <p:cNvPr id="27" name="Rectangle 26"/>
           <p:cNvSpPr/>
           <p:nvPr/>
         </p:nvSpPr>
         <p:spPr>
           <a:xfrm>
-            <a:off x="7726679" y="4608576"/>
-            <a:ext cx="109728" cy="109728"/>
-          </a:xfrm>
-          <a:prstGeom prst="ellipse">
+            <a:off x="502920" y="4736592"/>
+            <a:ext cx="73152" cy="1234440"/>
+          </a:xfrm>
+          <a:prstGeom prst="rect">
             <a:avLst/>
           </a:prstGeom>
           <a:solidFill>
-            <a:srgbClr val="1FB177"/>
+            <a:srgbClr val="1269BF"/>
           </a:solidFill>
           <a:ln>
             <a:noFill/>
@@ -4415,14 +4071,47 @@
       </p:sp>
       <p:sp>
         <p:nvSpPr>
-          <p:cNvPr id="36" name="TextBox 35"/>
+          <p:cNvPr id="28" name="TextBox 27"/>
           <p:cNvSpPr txBox="1"/>
           <p:nvPr/>
         </p:nvSpPr>
         <p:spPr>
           <a:xfrm>
-            <a:off x="7909560" y="4572000"/>
-            <a:ext cx="3611880" cy="256032"/>
+            <a:off x="667512" y="4901184"/>
+            <a:ext cx="530352" cy="256032"/>
+          </a:xfrm>
+          <a:prstGeom prst="rect">
+            <a:avLst/>
+          </a:prstGeom>
+          <a:noFill/>
+        </p:spPr>
+        <p:txBody>
+          <a:bodyPr wrap="none">
+            <a:spAutoFit/>
+          </a:bodyPr>
+          <a:lstStyle/>
+          <a:p>
+            <a:r>
+              <a:rPr sz="1800" b="1">
+                <a:solidFill>
+                  <a:srgbClr val="1269BF"/>
+                </a:solidFill>
+              </a:rPr>
+              <a:t>01</a:t>
+            </a:r>
+          </a:p>
+        </p:txBody>
+      </p:sp>
+      <p:sp>
+        <p:nvSpPr>
+          <p:cNvPr id="29" name="TextBox 28"/>
+          <p:cNvSpPr txBox="1"/>
+          <p:nvPr/>
+        </p:nvSpPr>
+        <p:spPr>
+          <a:xfrm>
+            <a:off x="1234440" y="4846320"/>
+            <a:ext cx="1600200" cy="256032"/>
           </a:xfrm>
           <a:prstGeom prst="rect">
             <a:avLst/>
@@ -4436,35 +4125,70 @@
           <a:lstStyle/>
           <a:p>
             <a:r>
-              <a:rPr sz="1000">
-                <a:solidFill>
-                  <a:srgbClr val="4C5C76"/>
+              <a:rPr sz="1150" b="1">
+                <a:solidFill>
+                  <a:srgbClr val="162543"/>
                 </a:solidFill>
               </a:rPr>
-              <a:t>Improves workload stability during pressure spikes and resource contention.</a:t>
-            </a:r>
-          </a:p>
-        </p:txBody>
-      </p:sp>
-      <p:sp>
-        <p:nvSpPr>
-          <p:cNvPr id="37" name="Oval 36"/>
+              <a:t>Operational visibility</a:t>
+            </a:r>
+          </a:p>
+        </p:txBody>
+      </p:sp>
+      <p:sp>
+        <p:nvSpPr>
+          <p:cNvPr id="30" name="TextBox 29"/>
+          <p:cNvSpPr txBox="1"/>
+          <p:nvPr/>
+        </p:nvSpPr>
+        <p:spPr>
+          <a:xfrm>
+            <a:off x="1234440" y="5193792"/>
+            <a:ext cx="1600200" cy="493776"/>
+          </a:xfrm>
+          <a:prstGeom prst="rect">
+            <a:avLst/>
+          </a:prstGeom>
+          <a:noFill/>
+        </p:spPr>
+        <p:txBody>
+          <a:bodyPr wrap="square">
+            <a:spAutoFit/>
+          </a:bodyPr>
+          <a:lstStyle/>
+          <a:p>
+            <a:r>
+              <a:rPr sz="880">
+                <a:solidFill>
+                  <a:srgbClr val="525F78"/>
+                </a:solidFill>
+              </a:rPr>
+              <a:t>Tracks CPU, memory, disk, GPU, and NPU pressure in one optimization workflow.</a:t>
+            </a:r>
+          </a:p>
+        </p:txBody>
+      </p:sp>
+      <p:sp>
+        <p:nvSpPr>
+          <p:cNvPr id="31" name="Rounded Rectangle 30"/>
           <p:cNvSpPr/>
           <p:nvPr/>
         </p:nvSpPr>
         <p:spPr>
           <a:xfrm>
-            <a:off x="7726679" y="5047488"/>
-            <a:ext cx="109728" cy="109728"/>
-          </a:xfrm>
-          <a:prstGeom prst="ellipse">
+            <a:off x="3383280" y="4736592"/>
+            <a:ext cx="2560320" cy="1234440"/>
+          </a:xfrm>
+          <a:prstGeom prst="roundRect">
             <a:avLst/>
           </a:prstGeom>
           <a:solidFill>
-            <a:srgbClr val="F7AA2E"/>
+            <a:srgbClr val="FFFFFF"/>
           </a:solidFill>
           <a:ln>
-            <a:noFill/>
+            <a:solidFill>
+              <a:srgbClr val="DBE2EC"/>
+            </a:solidFill>
           </a:ln>
         </p:spPr>
         <p:style>
@@ -4491,53 +4215,20 @@
       </p:sp>
       <p:sp>
         <p:nvSpPr>
-          <p:cNvPr id="38" name="TextBox 37"/>
-          <p:cNvSpPr txBox="1"/>
-          <p:nvPr/>
-        </p:nvSpPr>
-        <p:spPr>
-          <a:xfrm>
-            <a:off x="7909560" y="5010912"/>
-            <a:ext cx="3611880" cy="256032"/>
-          </a:xfrm>
-          <a:prstGeom prst="rect">
-            <a:avLst/>
-          </a:prstGeom>
-          <a:noFill/>
-        </p:spPr>
-        <p:txBody>
-          <a:bodyPr wrap="square">
-            <a:spAutoFit/>
-          </a:bodyPr>
-          <a:lstStyle/>
-          <a:p>
-            <a:r>
-              <a:rPr sz="1000">
-                <a:solidFill>
-                  <a:srgbClr val="4C5C76"/>
-                </a:solidFill>
-              </a:rPr>
-              <a:t>Provides a repeatable path from telemetry insight to production deployment.</a:t>
-            </a:r>
-          </a:p>
-        </p:txBody>
-      </p:sp>
-      <p:sp>
-        <p:nvSpPr>
-          <p:cNvPr id="39" name="Rounded Rectangle 38"/>
+          <p:cNvPr id="32" name="Rectangle 31"/>
           <p:cNvSpPr/>
           <p:nvPr/>
         </p:nvSpPr>
         <p:spPr>
           <a:xfrm>
-            <a:off x="7635240" y="5413248"/>
-            <a:ext cx="3977639" cy="420624"/>
-          </a:xfrm>
-          <a:prstGeom prst="roundRect">
+            <a:off x="3383280" y="4736592"/>
+            <a:ext cx="73152" cy="1234440"/>
+          </a:xfrm>
+          <a:prstGeom prst="rect">
             <a:avLst/>
           </a:prstGeom>
           <a:solidFill>
-            <a:srgbClr val="121F3A"/>
+            <a:srgbClr val="1EB074"/>
           </a:solidFill>
           <a:ln>
             <a:noFill/>
@@ -4562,36 +4253,129 @@
           <a:lstStyle/>
           <a:p>
             <a:pPr algn="ctr"/>
-            <a:r>
-              <a:rPr sz="1050" b="1">
-                <a:solidFill>
-                  <a:srgbClr val="FFFFFF"/>
+          </a:p>
+        </p:txBody>
+      </p:sp>
+      <p:sp>
+        <p:nvSpPr>
+          <p:cNvPr id="33" name="TextBox 32"/>
+          <p:cNvSpPr txBox="1"/>
+          <p:nvPr/>
+        </p:nvSpPr>
+        <p:spPr>
+          <a:xfrm>
+            <a:off x="3547872" y="4901184"/>
+            <a:ext cx="530352" cy="256032"/>
+          </a:xfrm>
+          <a:prstGeom prst="rect">
+            <a:avLst/>
+          </a:prstGeom>
+          <a:noFill/>
+        </p:spPr>
+        <p:txBody>
+          <a:bodyPr wrap="none">
+            <a:spAutoFit/>
+          </a:bodyPr>
+          <a:lstStyle/>
+          <a:p>
+            <a:r>
+              <a:rPr sz="1800" b="1">
+                <a:solidFill>
+                  <a:srgbClr val="1EB074"/>
                 </a:solidFill>
               </a:rPr>
-              <a:t>SmartTune 1.5 = telemetry + policy control + workload governance</a:t>
-            </a:r>
-          </a:p>
-        </p:txBody>
-      </p:sp>
-      <p:sp>
-        <p:nvSpPr>
-          <p:cNvPr id="40" name="Rounded Rectangle 39"/>
+              <a:t>02</a:t>
+            </a:r>
+          </a:p>
+        </p:txBody>
+      </p:sp>
+      <p:sp>
+        <p:nvSpPr>
+          <p:cNvPr id="34" name="TextBox 33"/>
+          <p:cNvSpPr txBox="1"/>
+          <p:nvPr/>
+        </p:nvSpPr>
+        <p:spPr>
+          <a:xfrm>
+            <a:off x="4114800" y="4846320"/>
+            <a:ext cx="1600200" cy="256032"/>
+          </a:xfrm>
+          <a:prstGeom prst="rect">
+            <a:avLst/>
+          </a:prstGeom>
+          <a:noFill/>
+        </p:spPr>
+        <p:txBody>
+          <a:bodyPr wrap="square">
+            <a:spAutoFit/>
+          </a:bodyPr>
+          <a:lstStyle/>
+          <a:p>
+            <a:r>
+              <a:rPr sz="1150" b="1">
+                <a:solidFill>
+                  <a:srgbClr val="162543"/>
+                </a:solidFill>
+              </a:rPr>
+              <a:t>Automated control</a:t>
+            </a:r>
+          </a:p>
+        </p:txBody>
+      </p:sp>
+      <p:sp>
+        <p:nvSpPr>
+          <p:cNvPr id="35" name="TextBox 34"/>
+          <p:cNvSpPr txBox="1"/>
+          <p:nvPr/>
+        </p:nvSpPr>
+        <p:spPr>
+          <a:xfrm>
+            <a:off x="4114800" y="5193792"/>
+            <a:ext cx="1600200" cy="493776"/>
+          </a:xfrm>
+          <a:prstGeom prst="rect">
+            <a:avLst/>
+          </a:prstGeom>
+          <a:noFill/>
+        </p:spPr>
+        <p:txBody>
+          <a:bodyPr wrap="square">
+            <a:spAutoFit/>
+          </a:bodyPr>
+          <a:lstStyle/>
+          <a:p>
+            <a:r>
+              <a:rPr sz="880">
+                <a:solidFill>
+                  <a:srgbClr val="525F78"/>
+                </a:solidFill>
+              </a:rPr>
+              <a:t>Balances resources with cgroup-based limits, launch management, and protection policies.</a:t>
+            </a:r>
+          </a:p>
+        </p:txBody>
+      </p:sp>
+      <p:sp>
+        <p:nvSpPr>
+          <p:cNvPr id="36" name="Rounded Rectangle 35"/>
           <p:cNvSpPr/>
           <p:nvPr/>
         </p:nvSpPr>
         <p:spPr>
           <a:xfrm>
-            <a:off x="347472" y="6199632"/>
-            <a:ext cx="11503152" cy="438912"/>
+            <a:off x="6263640" y="4736592"/>
+            <a:ext cx="2560320" cy="1234440"/>
           </a:xfrm>
           <a:prstGeom prst="roundRect">
             <a:avLst/>
           </a:prstGeom>
           <a:solidFill>
-            <a:srgbClr val="121F3A"/>
+            <a:srgbClr val="FFFFFF"/>
           </a:solidFill>
           <a:ln>
-            <a:noFill/>
+            <a:solidFill>
+              <a:srgbClr val="DBE2EC"/>
+            </a:solidFill>
           </a:ln>
         </p:spPr>
         <p:style>
@@ -4618,53 +4402,20 @@
       </p:sp>
       <p:sp>
         <p:nvSpPr>
-          <p:cNvPr id="41" name="TextBox 40"/>
-          <p:cNvSpPr txBox="1"/>
-          <p:nvPr/>
-        </p:nvSpPr>
-        <p:spPr>
-          <a:xfrm>
-            <a:off x="566928" y="6327648"/>
-            <a:ext cx="2011680" cy="164592"/>
-          </a:xfrm>
-          <a:prstGeom prst="rect">
-            <a:avLst/>
-          </a:prstGeom>
-          <a:noFill/>
-        </p:spPr>
-        <p:txBody>
-          <a:bodyPr wrap="none">
-            <a:spAutoFit/>
-          </a:bodyPr>
-          <a:lstStyle/>
-          <a:p>
-            <a:r>
-              <a:rPr sz="1100" b="1">
-                <a:solidFill>
-                  <a:srgbClr val="FFFFFF"/>
-                </a:solidFill>
-              </a:rPr>
-              <a:t>PILOT CUSTOMERS</a:t>
-            </a:r>
-          </a:p>
-        </p:txBody>
-      </p:sp>
-      <p:sp>
-        <p:nvSpPr>
-          <p:cNvPr id="42" name="Rounded Rectangle 41"/>
+          <p:cNvPr id="37" name="Rectangle 36"/>
           <p:cNvSpPr/>
           <p:nvPr/>
         </p:nvSpPr>
         <p:spPr>
           <a:xfrm>
-            <a:off x="2057400" y="6272784"/>
-            <a:ext cx="1554480" cy="256032"/>
-          </a:xfrm>
-          <a:prstGeom prst="roundRect">
+            <a:off x="6263640" y="4736592"/>
+            <a:ext cx="73152" cy="1234440"/>
+          </a:xfrm>
+          <a:prstGeom prst="rect">
             <a:avLst/>
           </a:prstGeom>
           <a:solidFill>
-            <a:srgbClr val="1168BE"/>
+            <a:srgbClr val="F2A42A"/>
           </a:solidFill>
           <a:ln>
             <a:noFill/>
@@ -4689,36 +4440,129 @@
           <a:lstStyle/>
           <a:p>
             <a:pPr algn="ctr"/>
-            <a:r>
-              <a:rPr sz="950" b="1">
-                <a:solidFill>
-                  <a:srgbClr val="FFFFFF"/>
+          </a:p>
+        </p:txBody>
+      </p:sp>
+      <p:sp>
+        <p:nvSpPr>
+          <p:cNvPr id="38" name="TextBox 37"/>
+          <p:cNvSpPr txBox="1"/>
+          <p:nvPr/>
+        </p:nvSpPr>
+        <p:spPr>
+          <a:xfrm>
+            <a:off x="6428231" y="4901184"/>
+            <a:ext cx="530352" cy="256032"/>
+          </a:xfrm>
+          <a:prstGeom prst="rect">
+            <a:avLst/>
+          </a:prstGeom>
+          <a:noFill/>
+        </p:spPr>
+        <p:txBody>
+          <a:bodyPr wrap="none">
+            <a:spAutoFit/>
+          </a:bodyPr>
+          <a:lstStyle/>
+          <a:p>
+            <a:r>
+              <a:rPr sz="1800" b="1">
+                <a:solidFill>
+                  <a:srgbClr val="F2A42A"/>
                 </a:solidFill>
               </a:rPr>
-              <a:t>AsterAI</a:t>
-            </a:r>
-          </a:p>
-        </p:txBody>
-      </p:sp>
-      <p:sp>
-        <p:nvSpPr>
-          <p:cNvPr id="43" name="Rounded Rectangle 42"/>
+              <a:t>03</a:t>
+            </a:r>
+          </a:p>
+        </p:txBody>
+      </p:sp>
+      <p:sp>
+        <p:nvSpPr>
+          <p:cNvPr id="39" name="TextBox 38"/>
+          <p:cNvSpPr txBox="1"/>
+          <p:nvPr/>
+        </p:nvSpPr>
+        <p:spPr>
+          <a:xfrm>
+            <a:off x="6995159" y="4846320"/>
+            <a:ext cx="1600200" cy="256032"/>
+          </a:xfrm>
+          <a:prstGeom prst="rect">
+            <a:avLst/>
+          </a:prstGeom>
+          <a:noFill/>
+        </p:spPr>
+        <p:txBody>
+          <a:bodyPr wrap="square">
+            <a:spAutoFit/>
+          </a:bodyPr>
+          <a:lstStyle/>
+          <a:p>
+            <a:r>
+              <a:rPr sz="1150" b="1">
+                <a:solidFill>
+                  <a:srgbClr val="162543"/>
+                </a:solidFill>
+              </a:rPr>
+              <a:t>Faster enablement</a:t>
+            </a:r>
+          </a:p>
+        </p:txBody>
+      </p:sp>
+      <p:sp>
+        <p:nvSpPr>
+          <p:cNvPr id="40" name="TextBox 39"/>
+          <p:cNvSpPr txBox="1"/>
+          <p:nvPr/>
+        </p:nvSpPr>
+        <p:spPr>
+          <a:xfrm>
+            <a:off x="6995159" y="5193792"/>
+            <a:ext cx="1600200" cy="493776"/>
+          </a:xfrm>
+          <a:prstGeom prst="rect">
+            <a:avLst/>
+          </a:prstGeom>
+          <a:noFill/>
+        </p:spPr>
+        <p:txBody>
+          <a:bodyPr wrap="square">
+            <a:spAutoFit/>
+          </a:bodyPr>
+          <a:lstStyle/>
+          <a:p>
+            <a:r>
+              <a:rPr sz="880">
+                <a:solidFill>
+                  <a:srgbClr val="525F78"/>
+                </a:solidFill>
+              </a:rPr>
+              <a:t>Shortens platform tuning cycles and supports more predictable pilot deployment outcomes.</a:t>
+            </a:r>
+          </a:p>
+        </p:txBody>
+      </p:sp>
+      <p:sp>
+        <p:nvSpPr>
+          <p:cNvPr id="41" name="Rounded Rectangle 40"/>
           <p:cNvSpPr/>
           <p:nvPr/>
         </p:nvSpPr>
         <p:spPr>
           <a:xfrm>
-            <a:off x="3840480" y="6272784"/>
-            <a:ext cx="1554480" cy="256032"/>
+            <a:off x="9144000" y="4736592"/>
+            <a:ext cx="2560320" cy="1234440"/>
           </a:xfrm>
           <a:prstGeom prst="roundRect">
             <a:avLst/>
           </a:prstGeom>
           <a:solidFill>
-            <a:srgbClr val="1FB177"/>
+            <a:srgbClr val="FFFFFF"/>
           </a:solidFill>
           <a:ln>
-            <a:noFill/>
+            <a:solidFill>
+              <a:srgbClr val="DBE2EC"/>
+            </a:solidFill>
           </a:ln>
         </p:spPr>
         <p:style>
@@ -4740,33 +4584,25 @@
           <a:lstStyle/>
           <a:p>
             <a:pPr algn="ctr"/>
-            <a:r>
-              <a:rPr sz="950" b="1">
-                <a:solidFill>
-                  <a:srgbClr val="FFFFFF"/>
-                </a:solidFill>
-              </a:rPr>
-              <a:t>NovaEdge Systems</a:t>
-            </a:r>
-          </a:p>
-        </p:txBody>
-      </p:sp>
-      <p:sp>
-        <p:nvSpPr>
-          <p:cNvPr id="44" name="Rounded Rectangle 43"/>
+          </a:p>
+        </p:txBody>
+      </p:sp>
+      <p:sp>
+        <p:nvSpPr>
+          <p:cNvPr id="42" name="Rectangle 41"/>
           <p:cNvSpPr/>
           <p:nvPr/>
         </p:nvSpPr>
         <p:spPr>
           <a:xfrm>
-            <a:off x="5623560" y="6272784"/>
-            <a:ext cx="1554480" cy="256032"/>
-          </a:xfrm>
-          <a:prstGeom prst="roundRect">
+            <a:off x="9144000" y="4736592"/>
+            <a:ext cx="73152" cy="1234440"/>
+          </a:xfrm>
+          <a:prstGeom prst="rect">
             <a:avLst/>
           </a:prstGeom>
           <a:solidFill>
-            <a:srgbClr val="F7AA2E"/>
+            <a:srgbClr val="1269BF"/>
           </a:solidFill>
           <a:ln>
             <a:noFill/>
@@ -4791,33 +4627,124 @@
           <a:lstStyle/>
           <a:p>
             <a:pPr algn="ctr"/>
-            <a:r>
-              <a:rPr sz="950" b="1">
-                <a:solidFill>
-                  <a:srgbClr val="FFFFFF"/>
+          </a:p>
+        </p:txBody>
+      </p:sp>
+      <p:sp>
+        <p:nvSpPr>
+          <p:cNvPr id="43" name="TextBox 42"/>
+          <p:cNvSpPr txBox="1"/>
+          <p:nvPr/>
+        </p:nvSpPr>
+        <p:spPr>
+          <a:xfrm>
+            <a:off x="9308592" y="4901184"/>
+            <a:ext cx="530352" cy="256032"/>
+          </a:xfrm>
+          <a:prstGeom prst="rect">
+            <a:avLst/>
+          </a:prstGeom>
+          <a:noFill/>
+        </p:spPr>
+        <p:txBody>
+          <a:bodyPr wrap="none">
+            <a:spAutoFit/>
+          </a:bodyPr>
+          <a:lstStyle/>
+          <a:p>
+            <a:r>
+              <a:rPr sz="2200" b="1">
+                <a:solidFill>
+                  <a:srgbClr val="1269BF"/>
                 </a:solidFill>
               </a:rPr>
-              <a:t>BlueMesa Robotics</a:t>
-            </a:r>
-          </a:p>
-        </p:txBody>
-      </p:sp>
-      <p:sp>
-        <p:nvSpPr>
-          <p:cNvPr id="45" name="Rounded Rectangle 44"/>
+              <a:t>1.5</a:t>
+            </a:r>
+          </a:p>
+        </p:txBody>
+      </p:sp>
+      <p:sp>
+        <p:nvSpPr>
+          <p:cNvPr id="44" name="TextBox 43"/>
+          <p:cNvSpPr txBox="1"/>
+          <p:nvPr/>
+        </p:nvSpPr>
+        <p:spPr>
+          <a:xfrm>
+            <a:off x="9875520" y="4846320"/>
+            <a:ext cx="1600200" cy="256032"/>
+          </a:xfrm>
+          <a:prstGeom prst="rect">
+            <a:avLst/>
+          </a:prstGeom>
+          <a:noFill/>
+        </p:spPr>
+        <p:txBody>
+          <a:bodyPr wrap="square">
+            <a:spAutoFit/>
+          </a:bodyPr>
+          <a:lstStyle/>
+          <a:p>
+            <a:r>
+              <a:rPr sz="1150" b="1">
+                <a:solidFill>
+                  <a:srgbClr val="162543"/>
+                </a:solidFill>
+              </a:rPr>
+              <a:t>Pilot momentum</a:t>
+            </a:r>
+          </a:p>
+        </p:txBody>
+      </p:sp>
+      <p:sp>
+        <p:nvSpPr>
+          <p:cNvPr id="45" name="TextBox 44"/>
+          <p:cNvSpPr txBox="1"/>
+          <p:nvPr/>
+        </p:nvSpPr>
+        <p:spPr>
+          <a:xfrm>
+            <a:off x="9875520" y="5193792"/>
+            <a:ext cx="1600200" cy="493776"/>
+          </a:xfrm>
+          <a:prstGeom prst="rect">
+            <a:avLst/>
+          </a:prstGeom>
+          <a:noFill/>
+        </p:spPr>
+        <p:txBody>
+          <a:bodyPr wrap="square">
+            <a:spAutoFit/>
+          </a:bodyPr>
+          <a:lstStyle/>
+          <a:p>
+            <a:r>
+              <a:rPr sz="880">
+                <a:solidFill>
+                  <a:srgbClr val="525F78"/>
+                </a:solidFill>
+              </a:rPr>
+              <a:t>Current pilot-customer placeholders are ready to be replaced with real account names.</a:t>
+            </a:r>
+          </a:p>
+        </p:txBody>
+      </p:sp>
+      <p:sp>
+        <p:nvSpPr>
+          <p:cNvPr id="46" name="Rectangle 45"/>
           <p:cNvSpPr/>
           <p:nvPr/>
         </p:nvSpPr>
         <p:spPr>
           <a:xfrm>
-            <a:off x="7406640" y="6272784"/>
-            <a:ext cx="1554480" cy="256032"/>
-          </a:xfrm>
-          <a:prstGeom prst="roundRect">
+            <a:off x="502920" y="6199632"/>
+            <a:ext cx="11201400" cy="9144"/>
+          </a:xfrm>
+          <a:prstGeom prst="rect">
             <a:avLst/>
           </a:prstGeom>
           <a:solidFill>
-            <a:srgbClr val="549DEA"/>
+            <a:srgbClr val="DBE2EC"/>
           </a:solidFill>
           <a:ln>
             <a:noFill/>
@@ -4842,33 +4769,58 @@
           <a:lstStyle/>
           <a:p>
             <a:pPr algn="ctr"/>
-            <a:r>
-              <a:rPr sz="950" b="1">
-                <a:solidFill>
-                  <a:srgbClr val="FFFFFF"/>
+          </a:p>
+        </p:txBody>
+      </p:sp>
+      <p:sp>
+        <p:nvSpPr>
+          <p:cNvPr id="47" name="TextBox 46"/>
+          <p:cNvSpPr txBox="1"/>
+          <p:nvPr/>
+        </p:nvSpPr>
+        <p:spPr>
+          <a:xfrm>
+            <a:off x="502920" y="6309360"/>
+            <a:ext cx="3200400" cy="201168"/>
+          </a:xfrm>
+          <a:prstGeom prst="rect">
+            <a:avLst/>
+          </a:prstGeom>
+          <a:noFill/>
+        </p:spPr>
+        <p:txBody>
+          <a:bodyPr wrap="none">
+            <a:spAutoFit/>
+          </a:bodyPr>
+          <a:lstStyle/>
+          <a:p>
+            <a:r>
+              <a:rPr sz="1100" b="1">
+                <a:solidFill>
+                  <a:srgbClr val="6A7891"/>
                 </a:solidFill>
               </a:rPr>
-              <a:t>VertexVision</a:t>
-            </a:r>
-          </a:p>
-        </p:txBody>
-      </p:sp>
-      <p:sp>
-        <p:nvSpPr>
-          <p:cNvPr id="46" name="Rounded Rectangle 45"/>
+              <a:t>CUSTOMERS IN PILOT / EARLY ADOPTION</a:t>
+            </a:r>
+          </a:p>
+        </p:txBody>
+      </p:sp>
+      <p:sp>
+        <p:nvSpPr>
+          <p:cNvPr id="48" name="Rounded Rectangle 47"/>
           <p:cNvSpPr/>
           <p:nvPr/>
         </p:nvSpPr>
         <p:spPr>
           <a:xfrm>
-            <a:off x="9189720" y="6272784"/>
-            <a:ext cx="1554480" cy="256032"/>
+            <a:off x="502920" y="6492240"/>
+            <a:ext cx="1965960" cy="256032"/>
           </a:xfrm>
           <a:prstGeom prst="roundRect">
             <a:avLst/>
           </a:prstGeom>
           <a:solidFill>
-            <a:srgbClr val="1FB177"/>
+            <a:srgbClr val="162543"/>
           </a:solidFill>
           <a:ln>
             <a:noFill/>
@@ -4894,46 +4846,216 @@
           <a:p>
             <a:pPr algn="ctr"/>
             <a:r>
-              <a:rPr sz="950" b="1">
+              <a:rPr sz="980" b="1">
+                <a:solidFill>
+                  <a:srgbClr val="FFFFFF"/>
+                </a:solidFill>
+              </a:rPr>
+              <a:t>AsterAI</a:t>
+            </a:r>
+          </a:p>
+        </p:txBody>
+      </p:sp>
+      <p:sp>
+        <p:nvSpPr>
+          <p:cNvPr id="49" name="Rounded Rectangle 48"/>
+          <p:cNvSpPr/>
+          <p:nvPr/>
+        </p:nvSpPr>
+        <p:spPr>
+          <a:xfrm>
+            <a:off x="2743200" y="6492240"/>
+            <a:ext cx="1965960" cy="256032"/>
+          </a:xfrm>
+          <a:prstGeom prst="roundRect">
+            <a:avLst/>
+          </a:prstGeom>
+          <a:solidFill>
+            <a:srgbClr val="1269BF"/>
+          </a:solidFill>
+          <a:ln>
+            <a:noFill/>
+          </a:ln>
+        </p:spPr>
+        <p:style>
+          <a:lnRef idx="1">
+            <a:schemeClr val="accent1"/>
+          </a:lnRef>
+          <a:fillRef idx="3">
+            <a:schemeClr val="accent1"/>
+          </a:fillRef>
+          <a:effectRef idx="2">
+            <a:schemeClr val="accent1"/>
+          </a:effectRef>
+          <a:fontRef idx="minor">
+            <a:schemeClr val="lt1"/>
+          </a:fontRef>
+        </p:style>
+        <p:txBody>
+          <a:bodyPr rtlCol="0" anchor="ctr"/>
+          <a:lstStyle/>
+          <a:p>
+            <a:pPr algn="ctr"/>
+            <a:r>
+              <a:rPr sz="980" b="1">
+                <a:solidFill>
+                  <a:srgbClr val="FFFFFF"/>
+                </a:solidFill>
+              </a:rPr>
+              <a:t>NovaEdge Systems</a:t>
+            </a:r>
+          </a:p>
+        </p:txBody>
+      </p:sp>
+      <p:sp>
+        <p:nvSpPr>
+          <p:cNvPr id="50" name="Rounded Rectangle 49"/>
+          <p:cNvSpPr/>
+          <p:nvPr/>
+        </p:nvSpPr>
+        <p:spPr>
+          <a:xfrm>
+            <a:off x="4983480" y="6492240"/>
+            <a:ext cx="1965960" cy="256032"/>
+          </a:xfrm>
+          <a:prstGeom prst="roundRect">
+            <a:avLst/>
+          </a:prstGeom>
+          <a:solidFill>
+            <a:srgbClr val="1EB074"/>
+          </a:solidFill>
+          <a:ln>
+            <a:noFill/>
+          </a:ln>
+        </p:spPr>
+        <p:style>
+          <a:lnRef idx="1">
+            <a:schemeClr val="accent1"/>
+          </a:lnRef>
+          <a:fillRef idx="3">
+            <a:schemeClr val="accent1"/>
+          </a:fillRef>
+          <a:effectRef idx="2">
+            <a:schemeClr val="accent1"/>
+          </a:effectRef>
+          <a:fontRef idx="minor">
+            <a:schemeClr val="lt1"/>
+          </a:fontRef>
+        </p:style>
+        <p:txBody>
+          <a:bodyPr rtlCol="0" anchor="ctr"/>
+          <a:lstStyle/>
+          <a:p>
+            <a:pPr algn="ctr"/>
+            <a:r>
+              <a:rPr sz="980" b="1">
+                <a:solidFill>
+                  <a:srgbClr val="FFFFFF"/>
+                </a:solidFill>
+              </a:rPr>
+              <a:t>BlueMesa Robotics</a:t>
+            </a:r>
+          </a:p>
+        </p:txBody>
+      </p:sp>
+      <p:sp>
+        <p:nvSpPr>
+          <p:cNvPr id="51" name="Rounded Rectangle 50"/>
+          <p:cNvSpPr/>
+          <p:nvPr/>
+        </p:nvSpPr>
+        <p:spPr>
+          <a:xfrm>
+            <a:off x="7223760" y="6492240"/>
+            <a:ext cx="1965960" cy="256032"/>
+          </a:xfrm>
+          <a:prstGeom prst="roundRect">
+            <a:avLst/>
+          </a:prstGeom>
+          <a:solidFill>
+            <a:srgbClr val="F2A42A"/>
+          </a:solidFill>
+          <a:ln>
+            <a:noFill/>
+          </a:ln>
+        </p:spPr>
+        <p:style>
+          <a:lnRef idx="1">
+            <a:schemeClr val="accent1"/>
+          </a:lnRef>
+          <a:fillRef idx="3">
+            <a:schemeClr val="accent1"/>
+          </a:fillRef>
+          <a:effectRef idx="2">
+            <a:schemeClr val="accent1"/>
+          </a:effectRef>
+          <a:fontRef idx="minor">
+            <a:schemeClr val="lt1"/>
+          </a:fontRef>
+        </p:style>
+        <p:txBody>
+          <a:bodyPr rtlCol="0" anchor="ctr"/>
+          <a:lstStyle/>
+          <a:p>
+            <a:pPr algn="ctr"/>
+            <a:r>
+              <a:rPr sz="980" b="1">
+                <a:solidFill>
+                  <a:srgbClr val="FFFFFF"/>
+                </a:solidFill>
+              </a:rPr>
+              <a:t>VertexVision</a:t>
+            </a:r>
+          </a:p>
+        </p:txBody>
+      </p:sp>
+      <p:sp>
+        <p:nvSpPr>
+          <p:cNvPr id="52" name="Rounded Rectangle 51"/>
+          <p:cNvSpPr/>
+          <p:nvPr/>
+        </p:nvSpPr>
+        <p:spPr>
+          <a:xfrm>
+            <a:off x="9464040" y="6492240"/>
+            <a:ext cx="1965960" cy="256032"/>
+          </a:xfrm>
+          <a:prstGeom prst="roundRect">
+            <a:avLst/>
+          </a:prstGeom>
+          <a:solidFill>
+            <a:srgbClr val="162543"/>
+          </a:solidFill>
+          <a:ln>
+            <a:noFill/>
+          </a:ln>
+        </p:spPr>
+        <p:style>
+          <a:lnRef idx="1">
+            <a:schemeClr val="accent1"/>
+          </a:lnRef>
+          <a:fillRef idx="3">
+            <a:schemeClr val="accent1"/>
+          </a:fillRef>
+          <a:effectRef idx="2">
+            <a:schemeClr val="accent1"/>
+          </a:effectRef>
+          <a:fontRef idx="minor">
+            <a:schemeClr val="lt1"/>
+          </a:fontRef>
+        </p:style>
+        <p:txBody>
+          <a:bodyPr rtlCol="0" anchor="ctr"/>
+          <a:lstStyle/>
+          <a:p>
+            <a:pPr algn="ctr"/>
+            <a:r>
+              <a:rPr sz="980" b="1">
                 <a:solidFill>
                   <a:srgbClr val="FFFFFF"/>
                 </a:solidFill>
               </a:rPr>
               <a:t>Orion Compute</a:t>
-            </a:r>
-          </a:p>
-        </p:txBody>
-      </p:sp>
-      <p:sp>
-        <p:nvSpPr>
-          <p:cNvPr id="47" name="TextBox 46"/>
-          <p:cNvSpPr txBox="1"/>
-          <p:nvPr/>
-        </p:nvSpPr>
-        <p:spPr>
-          <a:xfrm>
-            <a:off x="10241280" y="6327648"/>
-            <a:ext cx="1325880" cy="146304"/>
-          </a:xfrm>
-          <a:prstGeom prst="rect">
-            <a:avLst/>
-          </a:prstGeom>
-          <a:noFill/>
-        </p:spPr>
-        <p:txBody>
-          <a:bodyPr wrap="none">
-            <a:spAutoFit/>
-          </a:bodyPr>
-          <a:lstStyle/>
-          <a:p>
-            <a:pPr algn="r"/>
-            <a:r>
-              <a:rPr sz="900" i="1">
-                <a:solidFill>
-                  <a:srgbClr val="D1DAE8"/>
-                </a:solidFill>
-              </a:rPr>
-              <a:t>editable</a:t>
             </a:r>
           </a:p>
         </p:txBody>

</xml_diff>

<commit_message>
Restyle SmartTune slide as quarterly report
</commit_message>
<xml_diff>
--- a/docs/presentations/smartune_q3_milestone_slide.pptx
+++ b/docs/presentations/smartune_q3_milestone_slide.pptx
@@ -3103,7 +3103,7 @@
             <a:avLst/>
           </a:prstGeom>
           <a:solidFill>
-            <a:srgbClr val="F5F7FB"/>
+            <a:srgbClr val="F4F7FC"/>
           </a:solidFill>
           <a:ln>
             <a:noFill/>
@@ -3139,8 +3139,8 @@
         </p:nvSpPr>
         <p:spPr>
           <a:xfrm>
-            <a:off x="502920" y="164592"/>
-            <a:ext cx="4389120" cy="201168"/>
+            <a:off x="320040" y="146304"/>
+            <a:ext cx="3840480" cy="219456"/>
           </a:xfrm>
           <a:prstGeom prst="rect">
             <a:avLst/>
@@ -3154,9 +3154,9 @@
           <a:lstStyle/>
           <a:p>
             <a:r>
-              <a:rPr sz="1100" b="1">
-                <a:solidFill>
-                  <a:srgbClr val="1269BF"/>
+              <a:rPr sz="1200" b="1">
+                <a:solidFill>
+                  <a:srgbClr val="146BC1"/>
                 </a:solidFill>
               </a:rPr>
               <a:t>INTEL® EES PLATFORM / SMARTUNE 1.5</a:t>
@@ -3172,14 +3172,14 @@
         </p:nvSpPr>
         <p:spPr>
           <a:xfrm>
-            <a:off x="10058400" y="109728"/>
-            <a:ext cx="1737360" cy="347472"/>
+            <a:off x="10012680" y="109728"/>
+            <a:ext cx="1828800" cy="347472"/>
           </a:xfrm>
           <a:prstGeom prst="roundRect">
             <a:avLst/>
           </a:prstGeom>
           <a:solidFill>
-            <a:srgbClr val="162543"/>
+            <a:srgbClr val="192747"/>
           </a:solidFill>
           <a:ln>
             <a:noFill/>
@@ -3205,12 +3205,12 @@
           <a:p>
             <a:pPr algn="ctr"/>
             <a:r>
-              <a:rPr sz="1050" b="1">
+              <a:rPr sz="1100" b="1">
                 <a:solidFill>
                   <a:srgbClr val="FFFFFF"/>
                 </a:solidFill>
               </a:rPr>
-              <a:t>EXECUTIVE VIEW</a:t>
+              <a:t>Q3'26  •  PILOT</a:t>
             </a:r>
           </a:p>
         </p:txBody>
@@ -3223,8 +3223,8 @@
         </p:nvSpPr>
         <p:spPr>
           <a:xfrm>
-            <a:off x="502920" y="530352"/>
-            <a:ext cx="2926080" cy="365760"/>
+            <a:off x="320040" y="566928"/>
+            <a:ext cx="2926080" cy="457200"/>
           </a:xfrm>
           <a:prstGeom prst="rect">
             <a:avLst/>
@@ -3240,7 +3240,7 @@
             <a:r>
               <a:rPr sz="2700" b="1">
                 <a:solidFill>
-                  <a:srgbClr val="162543"/>
+                  <a:srgbClr val="192747"/>
                 </a:solidFill>
               </a:rPr>
               <a:t>SmarTune 1.5</a:t>
@@ -3250,91 +3250,23 @@
       </p:sp>
       <p:sp>
         <p:nvSpPr>
-          <p:cNvPr id="6" name="TextBox 5"/>
-          <p:cNvSpPr txBox="1"/>
-          <p:nvPr/>
-        </p:nvSpPr>
-        <p:spPr>
-          <a:xfrm>
-            <a:off x="502920" y="1024128"/>
-            <a:ext cx="5120640" cy="365760"/>
-          </a:xfrm>
-          <a:prstGeom prst="rect">
-            <a:avLst/>
-          </a:prstGeom>
-          <a:noFill/>
-        </p:spPr>
-        <p:txBody>
-          <a:bodyPr wrap="none">
-            <a:spAutoFit/>
-          </a:bodyPr>
-          <a:lstStyle/>
-          <a:p>
-            <a:r>
-              <a:rPr sz="2800" b="1">
-                <a:solidFill>
-                  <a:srgbClr val="1269BF"/>
-                </a:solidFill>
-              </a:rPr>
-              <a:t>BUSINESS VALUE MILESTONE</a:t>
-            </a:r>
-          </a:p>
-        </p:txBody>
-      </p:sp>
-      <p:sp>
-        <p:nvSpPr>
-          <p:cNvPr id="7" name="TextBox 6"/>
-          <p:cNvSpPr txBox="1"/>
-          <p:nvPr/>
-        </p:nvSpPr>
-        <p:spPr>
-          <a:xfrm>
-            <a:off x="530352" y="1627632"/>
-            <a:ext cx="3017520" cy="365760"/>
-          </a:xfrm>
-          <a:prstGeom prst="rect">
-            <a:avLst/>
-          </a:prstGeom>
-          <a:noFill/>
-        </p:spPr>
-        <p:txBody>
-          <a:bodyPr wrap="none">
-            <a:spAutoFit/>
-          </a:bodyPr>
-          <a:lstStyle/>
-          <a:p>
-            <a:r>
-              <a:rPr sz="1400" b="1">
-                <a:solidFill>
-                  <a:srgbClr val="6A7891"/>
-                </a:solidFill>
-              </a:rPr>
-              <a:t>READY FOR PILOT DEPLOYMENT</a:t>
-            </a:r>
-          </a:p>
-        </p:txBody>
-      </p:sp>
-      <p:sp>
-        <p:nvSpPr>
-          <p:cNvPr id="8" name="Rounded Rectangle 7"/>
+          <p:cNvPr id="6" name="Rectangle 5"/>
           <p:cNvSpPr/>
           <p:nvPr/>
         </p:nvSpPr>
         <p:spPr>
           <a:xfrm>
-            <a:off x="7635240" y="713232"/>
-            <a:ext cx="4069080" cy="1920240"/>
-          </a:xfrm>
-          <a:prstGeom prst="roundRect">
+            <a:off x="329184" y="813816"/>
+            <a:ext cx="987552" cy="36576"/>
+          </a:xfrm>
+          <a:prstGeom prst="rect">
             <a:avLst/>
           </a:prstGeom>
           <a:solidFill>
-            <a:srgbClr val="FFFFFF"/>
+            <a:srgbClr val="192747"/>
           </a:solidFill>
           <a:ln>
-            <a:solidFill>
-              <a:srgbClr val="DBE2EC"/>
-            </a:solidFill>
+            <a:noFill/>
           </a:ln>
         </p:spPr>
         <p:style>
@@ -3361,14 +3293,14 @@
       </p:sp>
       <p:sp>
         <p:nvSpPr>
-          <p:cNvPr id="9" name="TextBox 8"/>
+          <p:cNvPr id="7" name="TextBox 6"/>
           <p:cNvSpPr txBox="1"/>
           <p:nvPr/>
         </p:nvSpPr>
         <p:spPr>
           <a:xfrm>
-            <a:off x="7909560" y="914400"/>
-            <a:ext cx="2560320" cy="201168"/>
+            <a:off x="320040" y="1078992"/>
+            <a:ext cx="5303520" cy="548640"/>
           </a:xfrm>
           <a:prstGeom prst="rect">
             <a:avLst/>
@@ -3382,32 +3314,80 @@
           <a:lstStyle/>
           <a:p>
             <a:r>
-              <a:rPr sz="1100" b="1">
-                <a:solidFill>
-                  <a:srgbClr val="1269BF"/>
+              <a:rPr sz="3100" b="1">
+                <a:solidFill>
+                  <a:srgbClr val="146BC1"/>
                 </a:solidFill>
               </a:rPr>
-              <a:t>EXECUTIVE SUMMARY</a:t>
-            </a:r>
-          </a:p>
-        </p:txBody>
-      </p:sp>
-      <p:sp>
-        <p:nvSpPr>
-          <p:cNvPr id="10" name="Oval 9"/>
+              <a:t>QUARTERLY BUSINESS</a:t>
+            </a:r>
+          </a:p>
+          <a:p>
+            <a:pPr>
+              <a:spcBef>
+                <a:spcPts val="0"/>
+              </a:spcBef>
+            </a:pPr>
+            <a:r>
+              <a:rPr sz="3100" b="1">
+                <a:solidFill>
+                  <a:srgbClr val="146BC1"/>
+                </a:solidFill>
+              </a:rPr>
+              <a:t>MILESTONE</a:t>
+            </a:r>
+          </a:p>
+        </p:txBody>
+      </p:sp>
+      <p:sp>
+        <p:nvSpPr>
+          <p:cNvPr id="8" name="TextBox 7"/>
+          <p:cNvSpPr txBox="1"/>
+          <p:nvPr/>
+        </p:nvSpPr>
+        <p:spPr>
+          <a:xfrm>
+            <a:off x="320040" y="1828800"/>
+            <a:ext cx="2560320" cy="228600"/>
+          </a:xfrm>
+          <a:prstGeom prst="rect">
+            <a:avLst/>
+          </a:prstGeom>
+          <a:noFill/>
+        </p:spPr>
+        <p:txBody>
+          <a:bodyPr wrap="none">
+            <a:spAutoFit/>
+          </a:bodyPr>
+          <a:lstStyle/>
+          <a:p>
+            <a:r>
+              <a:rPr sz="1400" b="1">
+                <a:solidFill>
+                  <a:srgbClr val="61708C"/>
+                </a:solidFill>
+              </a:rPr>
+              <a:t>ACHIEVED IN Q3 2026</a:t>
+            </a:r>
+          </a:p>
+        </p:txBody>
+      </p:sp>
+      <p:sp>
+        <p:nvSpPr>
+          <p:cNvPr id="9" name="Oval 8"/>
           <p:cNvSpPr/>
           <p:nvPr/>
         </p:nvSpPr>
         <p:spPr>
           <a:xfrm>
-            <a:off x="7936992" y="1234440"/>
-            <a:ext cx="91440" cy="91440"/>
+            <a:off x="7543800" y="566928"/>
+            <a:ext cx="3913632" cy="3063240"/>
           </a:xfrm>
           <a:prstGeom prst="ellipse">
             <a:avLst/>
           </a:prstGeom>
           <a:solidFill>
-            <a:srgbClr val="1269BF"/>
+            <a:srgbClr val="E4EBF6"/>
           </a:solidFill>
           <a:ln>
             <a:noFill/>
@@ -3435,6 +3415,30 @@
           </a:p>
         </p:txBody>
       </p:sp>
+      <p:pic>
+        <p:nvPicPr>
+          <p:cNvPr id="10" name="Picture 9" descr="architecture_15.png"/>
+          <p:cNvPicPr>
+            <a:picLocks noChangeAspect="1"/>
+          </p:cNvPicPr>
+          <p:nvPr/>
+        </p:nvPicPr>
+        <p:blipFill>
+          <a:blip r:embed="rId2"/>
+          <a:stretch>
+            <a:fillRect/>
+          </a:stretch>
+        </p:blipFill>
+        <p:spPr>
+          <a:xfrm>
+            <a:off x="8046720" y="914400"/>
+            <a:ext cx="2999232" cy="1248668"/>
+          </a:xfrm>
+          <a:prstGeom prst="rect">
+            <a:avLst/>
+          </a:prstGeom>
+        </p:spPr>
+      </p:pic>
       <p:sp>
         <p:nvSpPr>
           <p:cNvPr id="11" name="TextBox 10"/>
@@ -3443,8 +3447,8 @@
         </p:nvSpPr>
         <p:spPr>
           <a:xfrm>
-            <a:off x="8119872" y="1188720"/>
-            <a:ext cx="3154680" cy="274320"/>
+            <a:off x="8302752" y="3355848"/>
+            <a:ext cx="2651760" cy="228600"/>
           </a:xfrm>
           <a:prstGeom prst="rect">
             <a:avLst/>
@@ -3452,38 +3456,73 @@
           <a:noFill/>
         </p:spPr>
         <p:txBody>
-          <a:bodyPr wrap="square">
+          <a:bodyPr wrap="none">
             <a:spAutoFit/>
           </a:bodyPr>
           <a:lstStyle/>
           <a:p>
-            <a:r>
-              <a:rPr sz="1000">
-                <a:solidFill>
-                  <a:srgbClr val="525F78"/>
+            <a:pPr algn="ctr"/>
+            <a:r>
+              <a:rPr sz="1700" b="1">
+                <a:solidFill>
+                  <a:srgbClr val="192747"/>
                 </a:solidFill>
               </a:rPr>
-              <a:t>SmartTune centralizes telemetry, policy control, and workload governance.</a:t>
-            </a:r>
-          </a:p>
-        </p:txBody>
-      </p:sp>
-      <p:sp>
-        <p:nvSpPr>
-          <p:cNvPr id="12" name="Oval 11"/>
+              <a:t>SMARTUNE</a:t>
+            </a:r>
+          </a:p>
+        </p:txBody>
+      </p:sp>
+      <p:sp>
+        <p:nvSpPr>
+          <p:cNvPr id="12" name="TextBox 11"/>
+          <p:cNvSpPr txBox="1"/>
+          <p:nvPr/>
+        </p:nvSpPr>
+        <p:spPr>
+          <a:xfrm>
+            <a:off x="8046720" y="3611880"/>
+            <a:ext cx="3200400" cy="237744"/>
+          </a:xfrm>
+          <a:prstGeom prst="rect">
+            <a:avLst/>
+          </a:prstGeom>
+          <a:noFill/>
+        </p:spPr>
+        <p:txBody>
+          <a:bodyPr wrap="none">
+            <a:spAutoFit/>
+          </a:bodyPr>
+          <a:lstStyle/>
+          <a:p>
+            <a:pPr algn="ctr"/>
+            <a:r>
+              <a:rPr sz="960">
+                <a:solidFill>
+                  <a:srgbClr val="61708C"/>
+                </a:solidFill>
+              </a:rPr>
+              <a:t>Optimization intelligence for Intel® XPU platforms.</a:t>
+            </a:r>
+          </a:p>
+        </p:txBody>
+      </p:sp>
+      <p:sp>
+        <p:nvSpPr>
+          <p:cNvPr id="13" name="Rectangle 12"/>
           <p:cNvSpPr/>
           <p:nvPr/>
         </p:nvSpPr>
         <p:spPr>
           <a:xfrm>
-            <a:off x="7936992" y="1618488"/>
-            <a:ext cx="91440" cy="91440"/>
-          </a:xfrm>
-          <a:prstGeom prst="ellipse">
+            <a:off x="320040" y="2322576"/>
+            <a:ext cx="82296" cy="1335024"/>
+          </a:xfrm>
+          <a:prstGeom prst="rect">
             <a:avLst/>
           </a:prstGeom>
           <a:solidFill>
-            <a:srgbClr val="1EB074"/>
+            <a:srgbClr val="F5A82A"/>
           </a:solidFill>
           <a:ln>
             <a:noFill/>
@@ -3513,53 +3552,20 @@
       </p:sp>
       <p:sp>
         <p:nvSpPr>
-          <p:cNvPr id="13" name="TextBox 12"/>
-          <p:cNvSpPr txBox="1"/>
-          <p:nvPr/>
-        </p:nvSpPr>
-        <p:spPr>
-          <a:xfrm>
-            <a:off x="8119872" y="1572768"/>
-            <a:ext cx="3154680" cy="274320"/>
-          </a:xfrm>
-          <a:prstGeom prst="rect">
-            <a:avLst/>
-          </a:prstGeom>
-          <a:noFill/>
-        </p:spPr>
-        <p:txBody>
-          <a:bodyPr wrap="square">
-            <a:spAutoFit/>
-          </a:bodyPr>
-          <a:lstStyle/>
-          <a:p>
-            <a:r>
-              <a:rPr sz="1000">
-                <a:solidFill>
-                  <a:srgbClr val="525F78"/>
-                </a:solidFill>
-              </a:rPr>
-              <a:t>It reduces tuning effort and protects critical AI / graphics workloads under pressure.</a:t>
-            </a:r>
-          </a:p>
-        </p:txBody>
-      </p:sp>
-      <p:sp>
-        <p:nvSpPr>
-          <p:cNvPr id="14" name="Oval 13"/>
+          <p:cNvPr id="14" name="Rounded Rectangle 13"/>
           <p:cNvSpPr/>
           <p:nvPr/>
         </p:nvSpPr>
         <p:spPr>
           <a:xfrm>
-            <a:off x="7936992" y="2002536"/>
-            <a:ext cx="91440" cy="91440"/>
-          </a:xfrm>
-          <a:prstGeom prst="ellipse">
+            <a:off x="411480" y="2322576"/>
+            <a:ext cx="6931152" cy="1335024"/>
+          </a:xfrm>
+          <a:prstGeom prst="roundRect">
             <a:avLst/>
           </a:prstGeom>
           <a:solidFill>
-            <a:srgbClr val="F2A42A"/>
+            <a:srgbClr val="192747"/>
           </a:solidFill>
           <a:ln>
             <a:noFill/>
@@ -3595,8 +3601,41 @@
         </p:nvSpPr>
         <p:spPr>
           <a:xfrm>
-            <a:off x="8119872" y="1956816"/>
-            <a:ext cx="3154680" cy="274320"/>
+            <a:off x="612648" y="2523744"/>
+            <a:ext cx="3200400" cy="201168"/>
+          </a:xfrm>
+          <a:prstGeom prst="rect">
+            <a:avLst/>
+          </a:prstGeom>
+          <a:noFill/>
+        </p:spPr>
+        <p:txBody>
+          <a:bodyPr wrap="none">
+            <a:spAutoFit/>
+          </a:bodyPr>
+          <a:lstStyle/>
+          <a:p>
+            <a:r>
+              <a:rPr sz="1200" b="1">
+                <a:solidFill>
+                  <a:srgbClr val="1FB074"/>
+                </a:solidFill>
+              </a:rPr>
+              <a:t>BUSINESS IMPACT  /  CORE OPTIMIZATION LAYER</a:t>
+            </a:r>
+          </a:p>
+        </p:txBody>
+      </p:sp>
+      <p:sp>
+        <p:nvSpPr>
+          <p:cNvPr id="16" name="TextBox 15"/>
+          <p:cNvSpPr txBox="1"/>
+          <p:nvPr/>
+        </p:nvSpPr>
+        <p:spPr>
+          <a:xfrm>
+            <a:off x="612648" y="2834640"/>
+            <a:ext cx="6309360" cy="457200"/>
           </a:xfrm>
           <a:prstGeom prst="rect">
             <a:avLst/>
@@ -3610,35 +3649,111 @@
           <a:lstStyle/>
           <a:p>
             <a:r>
-              <a:rPr sz="1000">
-                <a:solidFill>
-                  <a:srgbClr val="525F78"/>
+              <a:rPr sz="1800" b="1">
+                <a:solidFill>
+                  <a:srgbClr val="FFFFFF"/>
                 </a:solidFill>
               </a:rPr>
-              <a:t>It provides a repeatable optimization foundation for Intel® XPU platform adoption.</a:t>
-            </a:r>
-          </a:p>
-        </p:txBody>
-      </p:sp>
-      <p:sp>
-        <p:nvSpPr>
-          <p:cNvPr id="16" name="Rectangle 15"/>
+              <a:t>SmartTune is the central control layer for Intel® XPU workload optimization — </a:t>
+            </a:r>
+            <a:r>
+              <a:rPr sz="1800">
+                <a:solidFill>
+                  <a:srgbClr val="FFFFFF"/>
+                </a:solidFill>
+              </a:rPr>
+              <a:t>converting system telemetry into balancing actions that improve stability, reduce manual tuning effort, and accelerate pilot deployment readiness.</a:t>
+            </a:r>
+          </a:p>
+        </p:txBody>
+      </p:sp>
+      <p:sp>
+        <p:nvSpPr>
+          <p:cNvPr id="17" name="TextBox 16"/>
+          <p:cNvSpPr txBox="1"/>
+          <p:nvPr/>
+        </p:nvSpPr>
+        <p:spPr>
+          <a:xfrm>
+            <a:off x="612648" y="3364992"/>
+            <a:ext cx="6217920" cy="164592"/>
+          </a:xfrm>
+          <a:prstGeom prst="rect">
+            <a:avLst/>
+          </a:prstGeom>
+          <a:noFill/>
+        </p:spPr>
+        <p:txBody>
+          <a:bodyPr wrap="none">
+            <a:spAutoFit/>
+          </a:bodyPr>
+          <a:lstStyle/>
+          <a:p>
+            <a:r>
+              <a:rPr sz="930">
+                <a:solidFill>
+                  <a:srgbClr val="CED6E5"/>
+                </a:solidFill>
+              </a:rPr>
+              <a:t>Middle-section emphasis: what SmartTune is, what it does, and why it matters to business outcomes.</a:t>
+            </a:r>
+          </a:p>
+        </p:txBody>
+      </p:sp>
+      <p:sp>
+        <p:nvSpPr>
+          <p:cNvPr id="18" name="TextBox 17"/>
+          <p:cNvSpPr txBox="1"/>
+          <p:nvPr/>
+        </p:nvSpPr>
+        <p:spPr>
+          <a:xfrm>
+            <a:off x="320040" y="3794760"/>
+            <a:ext cx="2743200" cy="201168"/>
+          </a:xfrm>
+          <a:prstGeom prst="rect">
+            <a:avLst/>
+          </a:prstGeom>
+          <a:noFill/>
+        </p:spPr>
+        <p:txBody>
+          <a:bodyPr wrap="none">
+            <a:spAutoFit/>
+          </a:bodyPr>
+          <a:lstStyle/>
+          <a:p>
+            <a:r>
+              <a:rPr sz="1100" b="1">
+                <a:solidFill>
+                  <a:srgbClr val="61708C"/>
+                </a:solidFill>
+              </a:rPr>
+              <a:t>EXECUTIVE VALUE SNAPSHOT</a:t>
+            </a:r>
+          </a:p>
+        </p:txBody>
+      </p:sp>
+      <p:sp>
+        <p:nvSpPr>
+          <p:cNvPr id="19" name="Rounded Rectangle 18"/>
           <p:cNvSpPr/>
           <p:nvPr/>
         </p:nvSpPr>
         <p:spPr>
           <a:xfrm>
-            <a:off x="502920" y="2240280"/>
-            <a:ext cx="82296" cy="1417320"/>
-          </a:xfrm>
-          <a:prstGeom prst="rect">
+            <a:off x="320040" y="3995928"/>
+            <a:ext cx="2953512" cy="1243584"/>
+          </a:xfrm>
+          <a:prstGeom prst="roundRect">
             <a:avLst/>
           </a:prstGeom>
           <a:solidFill>
-            <a:srgbClr val="F2A42A"/>
+            <a:srgbClr val="FFFFFF"/>
           </a:solidFill>
           <a:ln>
-            <a:noFill/>
+            <a:solidFill>
+              <a:srgbClr val="D6DFEB"/>
+            </a:solidFill>
           </a:ln>
         </p:spPr>
         <p:style>
@@ -3665,20 +3780,20 @@
       </p:sp>
       <p:sp>
         <p:nvSpPr>
-          <p:cNvPr id="17" name="Rounded Rectangle 16"/>
+          <p:cNvPr id="20" name="Rectangle 19"/>
           <p:cNvSpPr/>
           <p:nvPr/>
         </p:nvSpPr>
         <p:spPr>
           <a:xfrm>
-            <a:off x="594360" y="2240280"/>
-            <a:ext cx="6675120" cy="1417320"/>
-          </a:xfrm>
-          <a:prstGeom prst="roundRect">
+            <a:off x="320040" y="3995928"/>
+            <a:ext cx="73152" cy="1243584"/>
+          </a:xfrm>
+          <a:prstGeom prst="rect">
             <a:avLst/>
           </a:prstGeom>
           <a:solidFill>
-            <a:srgbClr val="162543"/>
+            <a:srgbClr val="146BC1"/>
           </a:solidFill>
           <a:ln>
             <a:noFill/>
@@ -3708,14 +3823,14 @@
       </p:sp>
       <p:sp>
         <p:nvSpPr>
-          <p:cNvPr id="18" name="TextBox 17"/>
+          <p:cNvPr id="21" name="TextBox 20"/>
           <p:cNvSpPr txBox="1"/>
           <p:nvPr/>
         </p:nvSpPr>
         <p:spPr>
           <a:xfrm>
-            <a:off x="804672" y="2450592"/>
-            <a:ext cx="3291840" cy="201168"/>
+            <a:off x="521207" y="4187952"/>
+            <a:ext cx="822960" cy="274320"/>
           </a:xfrm>
           <a:prstGeom prst="rect">
             <a:avLst/>
@@ -3729,26 +3844,26 @@
           <a:lstStyle/>
           <a:p>
             <a:r>
-              <a:rPr sz="1200" b="1">
-                <a:solidFill>
-                  <a:srgbClr val="1EB074"/>
+              <a:rPr sz="1900" b="1">
+                <a:solidFill>
+                  <a:srgbClr val="146BC1"/>
                 </a:solidFill>
               </a:rPr>
-              <a:t>BUSINESS IMPACT / CORE PLATFORM ROLE</a:t>
-            </a:r>
-          </a:p>
-        </p:txBody>
-      </p:sp>
-      <p:sp>
-        <p:nvSpPr>
-          <p:cNvPr id="19" name="TextBox 18"/>
+              <a:t>360°</a:t>
+            </a:r>
+          </a:p>
+        </p:txBody>
+      </p:sp>
+      <p:sp>
+        <p:nvSpPr>
+          <p:cNvPr id="22" name="TextBox 21"/>
           <p:cNvSpPr txBox="1"/>
           <p:nvPr/>
         </p:nvSpPr>
         <p:spPr>
           <a:xfrm>
-            <a:off x="804672" y="2743200"/>
-            <a:ext cx="6126480" cy="493776"/>
+            <a:off x="1399031" y="4142232"/>
+            <a:ext cx="1600200" cy="256032"/>
           </a:xfrm>
           <a:prstGeom prst="rect">
             <a:avLst/>
@@ -3762,34 +3877,26 @@
           <a:lstStyle/>
           <a:p>
             <a:r>
-              <a:rPr sz="1800" b="1">
-                <a:solidFill>
-                  <a:srgbClr val="FFFFFF"/>
+              <a:rPr sz="1200" b="1">
+                <a:solidFill>
+                  <a:srgbClr val="192747"/>
                 </a:solidFill>
               </a:rPr>
-              <a:t>SmartTune is the optimization control layer for Intel® XPU systems — </a:t>
-            </a:r>
-            <a:r>
-              <a:rPr sz="1800">
-                <a:solidFill>
-                  <a:srgbClr val="FFFFFF"/>
-                </a:solidFill>
-              </a:rPr>
-              <a:t>turning system telemetry into resource-balancing actions that improve workload stability, reduce manual tuning, and accelerate production readiness.</a:t>
-            </a:r>
-          </a:p>
-        </p:txBody>
-      </p:sp>
-      <p:sp>
-        <p:nvSpPr>
-          <p:cNvPr id="20" name="TextBox 19"/>
+              <a:t>PLATFORM VISIBILITY</a:t>
+            </a:r>
+          </a:p>
+        </p:txBody>
+      </p:sp>
+      <p:sp>
+        <p:nvSpPr>
+          <p:cNvPr id="23" name="TextBox 22"/>
           <p:cNvSpPr txBox="1"/>
           <p:nvPr/>
         </p:nvSpPr>
         <p:spPr>
           <a:xfrm>
-            <a:off x="804672" y="3310128"/>
-            <a:ext cx="6126480" cy="201168"/>
+            <a:off x="1399031" y="4498848"/>
+            <a:ext cx="1664208" cy="420624"/>
           </a:xfrm>
           <a:prstGeom prst="rect">
             <a:avLst/>
@@ -3797,41 +3904,43 @@
           <a:noFill/>
         </p:spPr>
         <p:txBody>
-          <a:bodyPr wrap="none">
+          <a:bodyPr wrap="square">
             <a:spAutoFit/>
           </a:bodyPr>
           <a:lstStyle/>
           <a:p>
             <a:r>
-              <a:rPr sz="950">
-                <a:solidFill>
-                  <a:srgbClr val="CDD6E5"/>
+              <a:rPr sz="890">
+                <a:solidFill>
+                  <a:srgbClr val="54607A"/>
                 </a:solidFill>
               </a:rPr>
-              <a:t>Middle-section emphasis: what SmartTune is, and why it matters to business outcomes.</a:t>
-            </a:r>
-          </a:p>
-        </p:txBody>
-      </p:sp>
-      <p:sp>
-        <p:nvSpPr>
-          <p:cNvPr id="21" name="Oval 20"/>
+              <a:t>Unified monitoring across CPU, memory, disk, GPU, and NPU telemetry.</a:t>
+            </a:r>
+          </a:p>
+        </p:txBody>
+      </p:sp>
+      <p:sp>
+        <p:nvSpPr>
+          <p:cNvPr id="24" name="Rounded Rectangle 23"/>
           <p:cNvSpPr/>
           <p:nvPr/>
         </p:nvSpPr>
         <p:spPr>
           <a:xfrm>
-            <a:off x="7406640" y="2011680"/>
-            <a:ext cx="4480560" cy="2057400"/>
-          </a:xfrm>
-          <a:prstGeom prst="ellipse">
+            <a:off x="3401568" y="3995928"/>
+            <a:ext cx="2953512" cy="1243584"/>
+          </a:xfrm>
+          <a:prstGeom prst="roundRect">
             <a:avLst/>
           </a:prstGeom>
           <a:solidFill>
-            <a:srgbClr val="E8EEF7"/>
+            <a:srgbClr val="FFFFFF"/>
           </a:solidFill>
           <a:ln>
-            <a:noFill/>
+            <a:solidFill>
+              <a:srgbClr val="D6DFEB"/>
+            </a:solidFill>
           </a:ln>
         </p:spPr>
         <p:style>
@@ -3856,152 +3965,25 @@
           </a:p>
         </p:txBody>
       </p:sp>
-      <p:pic>
-        <p:nvPicPr>
-          <p:cNvPr id="22" name="Picture 21" descr="architecture_15.png"/>
-          <p:cNvPicPr>
-            <a:picLocks noChangeAspect="1"/>
-          </p:cNvPicPr>
-          <p:nvPr/>
-        </p:nvPicPr>
-        <p:blipFill>
-          <a:blip r:embed="rId2"/>
-          <a:stretch>
-            <a:fillRect/>
-          </a:stretch>
-        </p:blipFill>
-        <p:spPr>
-          <a:xfrm>
-            <a:off x="7909560" y="2331720"/>
-            <a:ext cx="3474720" cy="1446628"/>
-          </a:xfrm>
-          <a:prstGeom prst="rect">
-            <a:avLst/>
-          </a:prstGeom>
-        </p:spPr>
-      </p:pic>
-      <p:sp>
-        <p:nvSpPr>
-          <p:cNvPr id="23" name="TextBox 22"/>
-          <p:cNvSpPr txBox="1"/>
-          <p:nvPr/>
-        </p:nvSpPr>
-        <p:spPr>
-          <a:xfrm>
-            <a:off x="8229600" y="4041648"/>
-            <a:ext cx="3017520" cy="201168"/>
-          </a:xfrm>
-          <a:prstGeom prst="rect">
-            <a:avLst/>
-          </a:prstGeom>
-          <a:noFill/>
-        </p:spPr>
-        <p:txBody>
-          <a:bodyPr wrap="none">
-            <a:spAutoFit/>
-          </a:bodyPr>
-          <a:lstStyle/>
-          <a:p>
-            <a:pPr algn="ctr"/>
-            <a:r>
-              <a:rPr sz="1150" b="1">
-                <a:solidFill>
-                  <a:srgbClr val="162543"/>
-                </a:solidFill>
-              </a:rPr>
-              <a:t>SMARTUNE PLATFORM ARCHITECTURE</a:t>
-            </a:r>
-          </a:p>
-        </p:txBody>
-      </p:sp>
-      <p:sp>
-        <p:nvSpPr>
-          <p:cNvPr id="24" name="TextBox 23"/>
-          <p:cNvSpPr txBox="1"/>
-          <p:nvPr/>
-        </p:nvSpPr>
-        <p:spPr>
-          <a:xfrm>
-            <a:off x="7955279" y="4261104"/>
-            <a:ext cx="3657600" cy="219456"/>
-          </a:xfrm>
-          <a:prstGeom prst="rect">
-            <a:avLst/>
-          </a:prstGeom>
-          <a:noFill/>
-        </p:spPr>
-        <p:txBody>
-          <a:bodyPr wrap="none">
-            <a:spAutoFit/>
-          </a:bodyPr>
-          <a:lstStyle/>
-          <a:p>
-            <a:pPr algn="ctr"/>
-            <a:r>
-              <a:rPr sz="900">
-                <a:solidFill>
-                  <a:srgbClr val="6A7891"/>
-                </a:solidFill>
-              </a:rPr>
-              <a:t>Unified telemetry, control, and governance across heterogeneous Intel® XPU workloads.</a:t>
-            </a:r>
-          </a:p>
-        </p:txBody>
-      </p:sp>
-      <p:sp>
-        <p:nvSpPr>
-          <p:cNvPr id="25" name="TextBox 24"/>
-          <p:cNvSpPr txBox="1"/>
-          <p:nvPr/>
-        </p:nvSpPr>
-        <p:spPr>
-          <a:xfrm>
-            <a:off x="502920" y="4498848"/>
-            <a:ext cx="2743200" cy="201168"/>
-          </a:xfrm>
-          <a:prstGeom prst="rect">
-            <a:avLst/>
-          </a:prstGeom>
-          <a:noFill/>
-        </p:spPr>
-        <p:txBody>
-          <a:bodyPr wrap="none">
-            <a:spAutoFit/>
-          </a:bodyPr>
-          <a:lstStyle/>
-          <a:p>
-            <a:r>
-              <a:rPr sz="1100" b="1">
-                <a:solidFill>
-                  <a:srgbClr val="6A7891"/>
-                </a:solidFill>
-              </a:rPr>
-              <a:t>EXECUTIVE VALUE HIGHLIGHTS</a:t>
-            </a:r>
-          </a:p>
-        </p:txBody>
-      </p:sp>
-      <p:sp>
-        <p:nvSpPr>
-          <p:cNvPr id="26" name="Rounded Rectangle 25"/>
+      <p:sp>
+        <p:nvSpPr>
+          <p:cNvPr id="25" name="Rectangle 24"/>
           <p:cNvSpPr/>
           <p:nvPr/>
         </p:nvSpPr>
         <p:spPr>
           <a:xfrm>
-            <a:off x="502920" y="4736592"/>
-            <a:ext cx="2560320" cy="1234440"/>
-          </a:xfrm>
-          <a:prstGeom prst="roundRect">
+            <a:off x="3401568" y="3995928"/>
+            <a:ext cx="73152" cy="1243584"/>
+          </a:xfrm>
+          <a:prstGeom prst="rect">
             <a:avLst/>
           </a:prstGeom>
           <a:solidFill>
-            <a:srgbClr val="FFFFFF"/>
+            <a:srgbClr val="1FB074"/>
           </a:solidFill>
           <a:ln>
-            <a:solidFill>
-              <a:srgbClr val="DBE2EC"/>
-            </a:solidFill>
+            <a:noFill/>
           </a:ln>
         </p:spPr>
         <p:style>
@@ -4028,23 +4010,124 @@
       </p:sp>
       <p:sp>
         <p:nvSpPr>
-          <p:cNvPr id="27" name="Rectangle 26"/>
+          <p:cNvPr id="26" name="TextBox 25"/>
+          <p:cNvSpPr txBox="1"/>
+          <p:nvPr/>
+        </p:nvSpPr>
+        <p:spPr>
+          <a:xfrm>
+            <a:off x="3602736" y="4187952"/>
+            <a:ext cx="822960" cy="274320"/>
+          </a:xfrm>
+          <a:prstGeom prst="rect">
+            <a:avLst/>
+          </a:prstGeom>
+          <a:noFill/>
+        </p:spPr>
+        <p:txBody>
+          <a:bodyPr wrap="none">
+            <a:spAutoFit/>
+          </a:bodyPr>
+          <a:lstStyle/>
+          <a:p>
+            <a:r>
+              <a:rPr sz="1900" b="1">
+                <a:solidFill>
+                  <a:srgbClr val="1FB074"/>
+                </a:solidFill>
+              </a:rPr>
+              <a:t>AUTO</a:t>
+            </a:r>
+          </a:p>
+        </p:txBody>
+      </p:sp>
+      <p:sp>
+        <p:nvSpPr>
+          <p:cNvPr id="27" name="TextBox 26"/>
+          <p:cNvSpPr txBox="1"/>
+          <p:nvPr/>
+        </p:nvSpPr>
+        <p:spPr>
+          <a:xfrm>
+            <a:off x="4480560" y="4142232"/>
+            <a:ext cx="1600200" cy="256032"/>
+          </a:xfrm>
+          <a:prstGeom prst="rect">
+            <a:avLst/>
+          </a:prstGeom>
+          <a:noFill/>
+        </p:spPr>
+        <p:txBody>
+          <a:bodyPr wrap="square">
+            <a:spAutoFit/>
+          </a:bodyPr>
+          <a:lstStyle/>
+          <a:p>
+            <a:r>
+              <a:rPr sz="1200" b="1">
+                <a:solidFill>
+                  <a:srgbClr val="192747"/>
+                </a:solidFill>
+              </a:rPr>
+              <a:t>RESOURCE BALANCING</a:t>
+            </a:r>
+          </a:p>
+        </p:txBody>
+      </p:sp>
+      <p:sp>
+        <p:nvSpPr>
+          <p:cNvPr id="28" name="TextBox 27"/>
+          <p:cNvSpPr txBox="1"/>
+          <p:nvPr/>
+        </p:nvSpPr>
+        <p:spPr>
+          <a:xfrm>
+            <a:off x="4480560" y="4498848"/>
+            <a:ext cx="1664208" cy="420624"/>
+          </a:xfrm>
+          <a:prstGeom prst="rect">
+            <a:avLst/>
+          </a:prstGeom>
+          <a:noFill/>
+        </p:spPr>
+        <p:txBody>
+          <a:bodyPr wrap="square">
+            <a:spAutoFit/>
+          </a:bodyPr>
+          <a:lstStyle/>
+          <a:p>
+            <a:r>
+              <a:rPr sz="890">
+                <a:solidFill>
+                  <a:srgbClr val="54607A"/>
+                </a:solidFill>
+              </a:rPr>
+              <a:t>Policy-based control with cgroups, queuing, and workload protection.</a:t>
+            </a:r>
+          </a:p>
+        </p:txBody>
+      </p:sp>
+      <p:sp>
+        <p:nvSpPr>
+          <p:cNvPr id="29" name="Rounded Rectangle 28"/>
           <p:cNvSpPr/>
           <p:nvPr/>
         </p:nvSpPr>
         <p:spPr>
           <a:xfrm>
-            <a:off x="502920" y="4736592"/>
-            <a:ext cx="73152" cy="1234440"/>
-          </a:xfrm>
-          <a:prstGeom prst="rect">
+            <a:off x="6483096" y="3995928"/>
+            <a:ext cx="2953512" cy="1243584"/>
+          </a:xfrm>
+          <a:prstGeom prst="roundRect">
             <a:avLst/>
           </a:prstGeom>
           <a:solidFill>
-            <a:srgbClr val="1269BF"/>
+            <a:srgbClr val="FFFFFF"/>
           </a:solidFill>
           <a:ln>
-            <a:noFill/>
+            <a:solidFill>
+              <a:srgbClr val="D6DFEB"/>
+            </a:solidFill>
           </a:ln>
         </p:spPr>
         <p:style>
@@ -4071,124 +4154,23 @@
       </p:sp>
       <p:sp>
         <p:nvSpPr>
-          <p:cNvPr id="28" name="TextBox 27"/>
-          <p:cNvSpPr txBox="1"/>
-          <p:nvPr/>
-        </p:nvSpPr>
-        <p:spPr>
-          <a:xfrm>
-            <a:off x="667512" y="4901184"/>
-            <a:ext cx="530352" cy="256032"/>
-          </a:xfrm>
-          <a:prstGeom prst="rect">
-            <a:avLst/>
-          </a:prstGeom>
-          <a:noFill/>
-        </p:spPr>
-        <p:txBody>
-          <a:bodyPr wrap="none">
-            <a:spAutoFit/>
-          </a:bodyPr>
-          <a:lstStyle/>
-          <a:p>
-            <a:r>
-              <a:rPr sz="1800" b="1">
-                <a:solidFill>
-                  <a:srgbClr val="1269BF"/>
-                </a:solidFill>
-              </a:rPr>
-              <a:t>01</a:t>
-            </a:r>
-          </a:p>
-        </p:txBody>
-      </p:sp>
-      <p:sp>
-        <p:nvSpPr>
-          <p:cNvPr id="29" name="TextBox 28"/>
-          <p:cNvSpPr txBox="1"/>
-          <p:nvPr/>
-        </p:nvSpPr>
-        <p:spPr>
-          <a:xfrm>
-            <a:off x="1234440" y="4846320"/>
-            <a:ext cx="1600200" cy="256032"/>
-          </a:xfrm>
-          <a:prstGeom prst="rect">
-            <a:avLst/>
-          </a:prstGeom>
-          <a:noFill/>
-        </p:spPr>
-        <p:txBody>
-          <a:bodyPr wrap="square">
-            <a:spAutoFit/>
-          </a:bodyPr>
-          <a:lstStyle/>
-          <a:p>
-            <a:r>
-              <a:rPr sz="1150" b="1">
-                <a:solidFill>
-                  <a:srgbClr val="162543"/>
-                </a:solidFill>
-              </a:rPr>
-              <a:t>Operational visibility</a:t>
-            </a:r>
-          </a:p>
-        </p:txBody>
-      </p:sp>
-      <p:sp>
-        <p:nvSpPr>
-          <p:cNvPr id="30" name="TextBox 29"/>
-          <p:cNvSpPr txBox="1"/>
-          <p:nvPr/>
-        </p:nvSpPr>
-        <p:spPr>
-          <a:xfrm>
-            <a:off x="1234440" y="5193792"/>
-            <a:ext cx="1600200" cy="493776"/>
-          </a:xfrm>
-          <a:prstGeom prst="rect">
-            <a:avLst/>
-          </a:prstGeom>
-          <a:noFill/>
-        </p:spPr>
-        <p:txBody>
-          <a:bodyPr wrap="square">
-            <a:spAutoFit/>
-          </a:bodyPr>
-          <a:lstStyle/>
-          <a:p>
-            <a:r>
-              <a:rPr sz="880">
-                <a:solidFill>
-                  <a:srgbClr val="525F78"/>
-                </a:solidFill>
-              </a:rPr>
-              <a:t>Tracks CPU, memory, disk, GPU, and NPU pressure in one optimization workflow.</a:t>
-            </a:r>
-          </a:p>
-        </p:txBody>
-      </p:sp>
-      <p:sp>
-        <p:nvSpPr>
-          <p:cNvPr id="31" name="Rounded Rectangle 30"/>
+          <p:cNvPr id="30" name="Rectangle 29"/>
           <p:cNvSpPr/>
           <p:nvPr/>
         </p:nvSpPr>
         <p:spPr>
           <a:xfrm>
-            <a:off x="3383280" y="4736592"/>
-            <a:ext cx="2560320" cy="1234440"/>
-          </a:xfrm>
-          <a:prstGeom prst="roundRect">
+            <a:off x="6483096" y="3995928"/>
+            <a:ext cx="73152" cy="1243584"/>
+          </a:xfrm>
+          <a:prstGeom prst="rect">
             <a:avLst/>
           </a:prstGeom>
           <a:solidFill>
-            <a:srgbClr val="FFFFFF"/>
+            <a:srgbClr val="F5A82A"/>
           </a:solidFill>
           <a:ln>
-            <a:solidFill>
-              <a:srgbClr val="DBE2EC"/>
-            </a:solidFill>
+            <a:noFill/>
           </a:ln>
         </p:spPr>
         <p:style>
@@ -4215,20 +4197,119 @@
       </p:sp>
       <p:sp>
         <p:nvSpPr>
-          <p:cNvPr id="32" name="Rectangle 31"/>
+          <p:cNvPr id="31" name="TextBox 30"/>
+          <p:cNvSpPr txBox="1"/>
+          <p:nvPr/>
+        </p:nvSpPr>
+        <p:spPr>
+          <a:xfrm>
+            <a:off x="6684264" y="4187952"/>
+            <a:ext cx="822960" cy="274320"/>
+          </a:xfrm>
+          <a:prstGeom prst="rect">
+            <a:avLst/>
+          </a:prstGeom>
+          <a:noFill/>
+        </p:spPr>
+        <p:txBody>
+          <a:bodyPr wrap="none">
+            <a:spAutoFit/>
+          </a:bodyPr>
+          <a:lstStyle/>
+          <a:p>
+            <a:r>
+              <a:rPr sz="1900" b="1">
+                <a:solidFill>
+                  <a:srgbClr val="F5A82A"/>
+                </a:solidFill>
+              </a:rPr>
+              <a:t>FAST</a:t>
+            </a:r>
+          </a:p>
+        </p:txBody>
+      </p:sp>
+      <p:sp>
+        <p:nvSpPr>
+          <p:cNvPr id="32" name="TextBox 31"/>
+          <p:cNvSpPr txBox="1"/>
+          <p:nvPr/>
+        </p:nvSpPr>
+        <p:spPr>
+          <a:xfrm>
+            <a:off x="7562088" y="4142232"/>
+            <a:ext cx="1600200" cy="256032"/>
+          </a:xfrm>
+          <a:prstGeom prst="rect">
+            <a:avLst/>
+          </a:prstGeom>
+          <a:noFill/>
+        </p:spPr>
+        <p:txBody>
+          <a:bodyPr wrap="square">
+            <a:spAutoFit/>
+          </a:bodyPr>
+          <a:lstStyle/>
+          <a:p>
+            <a:r>
+              <a:rPr sz="1200" b="1">
+                <a:solidFill>
+                  <a:srgbClr val="192747"/>
+                </a:solidFill>
+              </a:rPr>
+              <a:t>DEPLOYMENT READINESS</a:t>
+            </a:r>
+          </a:p>
+        </p:txBody>
+      </p:sp>
+      <p:sp>
+        <p:nvSpPr>
+          <p:cNvPr id="33" name="TextBox 32"/>
+          <p:cNvSpPr txBox="1"/>
+          <p:nvPr/>
+        </p:nvSpPr>
+        <p:spPr>
+          <a:xfrm>
+            <a:off x="7562088" y="4498848"/>
+            <a:ext cx="1664208" cy="420624"/>
+          </a:xfrm>
+          <a:prstGeom prst="rect">
+            <a:avLst/>
+          </a:prstGeom>
+          <a:noFill/>
+        </p:spPr>
+        <p:txBody>
+          <a:bodyPr wrap="square">
+            <a:spAutoFit/>
+          </a:bodyPr>
+          <a:lstStyle/>
+          <a:p>
+            <a:r>
+              <a:rPr sz="890">
+                <a:solidFill>
+                  <a:srgbClr val="54607A"/>
+                </a:solidFill>
+              </a:rPr>
+              <a:t>Shorter tuning cycles and more repeatable pilot rollout decisions.</a:t>
+            </a:r>
+          </a:p>
+        </p:txBody>
+      </p:sp>
+      <p:sp>
+        <p:nvSpPr>
+          <p:cNvPr id="34" name="Rounded Rectangle 33"/>
           <p:cNvSpPr/>
           <p:nvPr/>
         </p:nvSpPr>
         <p:spPr>
           <a:xfrm>
-            <a:off x="3383280" y="4736592"/>
-            <a:ext cx="73152" cy="1234440"/>
-          </a:xfrm>
-          <a:prstGeom prst="rect">
+            <a:off x="9564624" y="3995928"/>
+            <a:ext cx="2258568" cy="1243584"/>
+          </a:xfrm>
+          <a:prstGeom prst="roundRect">
             <a:avLst/>
           </a:prstGeom>
           <a:solidFill>
-            <a:srgbClr val="1EB074"/>
+            <a:srgbClr val="146BC1"/>
           </a:solidFill>
           <a:ln>
             <a:noFill/>
@@ -4258,14 +4339,14 @@
       </p:sp>
       <p:sp>
         <p:nvSpPr>
-          <p:cNvPr id="33" name="TextBox 32"/>
+          <p:cNvPr id="35" name="TextBox 34"/>
           <p:cNvSpPr txBox="1"/>
           <p:nvPr/>
         </p:nvSpPr>
         <p:spPr>
           <a:xfrm>
-            <a:off x="3547872" y="4901184"/>
-            <a:ext cx="530352" cy="256032"/>
+            <a:off x="9784080" y="4187952"/>
+            <a:ext cx="1463040" cy="182880"/>
           </a:xfrm>
           <a:prstGeom prst="rect">
             <a:avLst/>
@@ -4279,26 +4360,59 @@
           <a:lstStyle/>
           <a:p>
             <a:r>
-              <a:rPr sz="1800" b="1">
-                <a:solidFill>
-                  <a:srgbClr val="1EB074"/>
+              <a:rPr sz="1050" b="1">
+                <a:solidFill>
+                  <a:srgbClr val="FFFFFF"/>
                 </a:solidFill>
               </a:rPr>
-              <a:t>02</a:t>
-            </a:r>
-          </a:p>
-        </p:txBody>
-      </p:sp>
-      <p:sp>
-        <p:nvSpPr>
-          <p:cNvPr id="34" name="TextBox 33"/>
+              <a:t>PILOT MILESTONE</a:t>
+            </a:r>
+          </a:p>
+        </p:txBody>
+      </p:sp>
+      <p:sp>
+        <p:nvSpPr>
+          <p:cNvPr id="36" name="TextBox 35"/>
           <p:cNvSpPr txBox="1"/>
           <p:nvPr/>
         </p:nvSpPr>
         <p:spPr>
           <a:xfrm>
-            <a:off x="4114800" y="4846320"/>
-            <a:ext cx="1600200" cy="256032"/>
+            <a:off x="9756648" y="4434840"/>
+            <a:ext cx="1097280" cy="411480"/>
+          </a:xfrm>
+          <a:prstGeom prst="rect">
+            <a:avLst/>
+          </a:prstGeom>
+          <a:noFill/>
+        </p:spPr>
+        <p:txBody>
+          <a:bodyPr wrap="none">
+            <a:spAutoFit/>
+          </a:bodyPr>
+          <a:lstStyle/>
+          <a:p>
+            <a:r>
+              <a:rPr sz="3100" b="1">
+                <a:solidFill>
+                  <a:srgbClr val="FFFFFF"/>
+                </a:solidFill>
+              </a:rPr>
+              <a:t>1.5</a:t>
+            </a:r>
+          </a:p>
+        </p:txBody>
+      </p:sp>
+      <p:sp>
+        <p:nvSpPr>
+          <p:cNvPr id="37" name="TextBox 36"/>
+          <p:cNvSpPr txBox="1"/>
+          <p:nvPr/>
+        </p:nvSpPr>
+        <p:spPr>
+          <a:xfrm>
+            <a:off x="9774936" y="4846320"/>
+            <a:ext cx="1783080" cy="274320"/>
           </a:xfrm>
           <a:prstGeom prst="rect">
             <a:avLst/>
@@ -4312,26 +4426,26 @@
           <a:lstStyle/>
           <a:p>
             <a:r>
-              <a:rPr sz="1150" b="1">
-                <a:solidFill>
-                  <a:srgbClr val="162543"/>
+              <a:rPr sz="930">
+                <a:solidFill>
+                  <a:srgbClr val="FFFFFF"/>
                 </a:solidFill>
               </a:rPr>
-              <a:t>Automated control</a:t>
-            </a:r>
-          </a:p>
-        </p:txBody>
-      </p:sp>
-      <p:sp>
-        <p:nvSpPr>
-          <p:cNvPr id="35" name="TextBox 34"/>
+              <a:t>Production-focused foundation for SmartTune adoption</a:t>
+            </a:r>
+          </a:p>
+        </p:txBody>
+      </p:sp>
+      <p:sp>
+        <p:nvSpPr>
+          <p:cNvPr id="38" name="TextBox 37"/>
           <p:cNvSpPr txBox="1"/>
           <p:nvPr/>
         </p:nvSpPr>
         <p:spPr>
           <a:xfrm>
-            <a:off x="4114800" y="5193792"/>
-            <a:ext cx="1600200" cy="493776"/>
+            <a:off x="320040" y="5513832"/>
+            <a:ext cx="2560320" cy="201168"/>
           </a:xfrm>
           <a:prstGeom prst="rect">
             <a:avLst/>
@@ -4339,43 +4453,41 @@
           <a:noFill/>
         </p:spPr>
         <p:txBody>
-          <a:bodyPr wrap="square">
+          <a:bodyPr wrap="none">
             <a:spAutoFit/>
           </a:bodyPr>
           <a:lstStyle/>
           <a:p>
             <a:r>
-              <a:rPr sz="880">
-                <a:solidFill>
-                  <a:srgbClr val="525F78"/>
+              <a:rPr sz="1050" b="1">
+                <a:solidFill>
+                  <a:srgbClr val="61708C"/>
                 </a:solidFill>
               </a:rPr>
-              <a:t>Balances resources with cgroup-based limits, launch management, and protection policies.</a:t>
-            </a:r>
-          </a:p>
-        </p:txBody>
-      </p:sp>
-      <p:sp>
-        <p:nvSpPr>
-          <p:cNvPr id="36" name="Rounded Rectangle 35"/>
+              <a:t>RELEASE HIGHLIGHTS</a:t>
+            </a:r>
+          </a:p>
+        </p:txBody>
+      </p:sp>
+      <p:sp>
+        <p:nvSpPr>
+          <p:cNvPr id="39" name="Rectangle 38"/>
           <p:cNvSpPr/>
           <p:nvPr/>
         </p:nvSpPr>
         <p:spPr>
           <a:xfrm>
-            <a:off x="6263640" y="4736592"/>
-            <a:ext cx="2560320" cy="1234440"/>
-          </a:xfrm>
-          <a:prstGeom prst="roundRect">
+            <a:off x="320040" y="5751576"/>
+            <a:ext cx="11457432" cy="9144"/>
+          </a:xfrm>
+          <a:prstGeom prst="rect">
             <a:avLst/>
           </a:prstGeom>
           <a:solidFill>
-            <a:srgbClr val="FFFFFF"/>
+            <a:srgbClr val="D6DFEB"/>
           </a:solidFill>
           <a:ln>
-            <a:solidFill>
-              <a:srgbClr val="DBE2EC"/>
-            </a:solidFill>
+            <a:noFill/>
           </a:ln>
         </p:spPr>
         <p:style>
@@ -4402,20 +4514,20 @@
       </p:sp>
       <p:sp>
         <p:nvSpPr>
-          <p:cNvPr id="37" name="Rectangle 36"/>
+          <p:cNvPr id="40" name="Oval 39"/>
           <p:cNvSpPr/>
           <p:nvPr/>
         </p:nvSpPr>
         <p:spPr>
           <a:xfrm>
-            <a:off x="6263640" y="4736592"/>
-            <a:ext cx="73152" cy="1234440"/>
-          </a:xfrm>
-          <a:prstGeom prst="rect">
+            <a:off x="457200" y="5925312"/>
+            <a:ext cx="292608" cy="292608"/>
+          </a:xfrm>
+          <a:prstGeom prst="ellipse">
             <a:avLst/>
           </a:prstGeom>
           <a:solidFill>
-            <a:srgbClr val="F2A42A"/>
+            <a:srgbClr val="146BC1"/>
           </a:solidFill>
           <a:ln>
             <a:noFill/>
@@ -4440,19 +4552,27 @@
           <a:lstStyle/>
           <a:p>
             <a:pPr algn="ctr"/>
-          </a:p>
-        </p:txBody>
-      </p:sp>
-      <p:sp>
-        <p:nvSpPr>
-          <p:cNvPr id="38" name="TextBox 37"/>
+            <a:r>
+              <a:rPr sz="850" b="1">
+                <a:solidFill>
+                  <a:srgbClr val="FFFFFF"/>
+                </a:solidFill>
+              </a:rPr>
+              <a:t>01</a:t>
+            </a:r>
+          </a:p>
+        </p:txBody>
+      </p:sp>
+      <p:sp>
+        <p:nvSpPr>
+          <p:cNvPr id="41" name="TextBox 40"/>
           <p:cNvSpPr txBox="1"/>
           <p:nvPr/>
         </p:nvSpPr>
         <p:spPr>
           <a:xfrm>
-            <a:off x="6428231" y="4901184"/>
-            <a:ext cx="530352" cy="256032"/>
+            <a:off x="868680" y="5897880"/>
+            <a:ext cx="2468880" cy="201168"/>
           </a:xfrm>
           <a:prstGeom prst="rect">
             <a:avLst/>
@@ -4466,26 +4586,26 @@
           <a:lstStyle/>
           <a:p>
             <a:r>
-              <a:rPr sz="1800" b="1">
-                <a:solidFill>
-                  <a:srgbClr val="F2A42A"/>
+              <a:rPr sz="1100" b="1">
+                <a:solidFill>
+                  <a:srgbClr val="192747"/>
                 </a:solidFill>
               </a:rPr>
-              <a:t>03</a:t>
-            </a:r>
-          </a:p>
-        </p:txBody>
-      </p:sp>
-      <p:sp>
-        <p:nvSpPr>
-          <p:cNvPr id="39" name="TextBox 38"/>
+              <a:t>PLATFORM READY</a:t>
+            </a:r>
+          </a:p>
+        </p:txBody>
+      </p:sp>
+      <p:sp>
+        <p:nvSpPr>
+          <p:cNvPr id="42" name="TextBox 41"/>
           <p:cNvSpPr txBox="1"/>
           <p:nvPr/>
         </p:nvSpPr>
         <p:spPr>
           <a:xfrm>
-            <a:off x="6995159" y="4846320"/>
-            <a:ext cx="1600200" cy="256032"/>
+            <a:off x="868680" y="6163056"/>
+            <a:ext cx="2697480" cy="301752"/>
           </a:xfrm>
           <a:prstGeom prst="rect">
             <a:avLst/>
@@ -4499,70 +4619,35 @@
           <a:lstStyle/>
           <a:p>
             <a:r>
-              <a:rPr sz="1150" b="1">
-                <a:solidFill>
-                  <a:srgbClr val="162543"/>
+              <a:rPr sz="880">
+                <a:solidFill>
+                  <a:srgbClr val="54607A"/>
                 </a:solidFill>
               </a:rPr>
-              <a:t>Faster enablement</a:t>
-            </a:r>
-          </a:p>
-        </p:txBody>
-      </p:sp>
-      <p:sp>
-        <p:nvSpPr>
-          <p:cNvPr id="40" name="TextBox 39"/>
-          <p:cNvSpPr txBox="1"/>
-          <p:nvPr/>
-        </p:nvSpPr>
-        <p:spPr>
-          <a:xfrm>
-            <a:off x="6995159" y="5193792"/>
-            <a:ext cx="1600200" cy="493776"/>
-          </a:xfrm>
-          <a:prstGeom prst="rect">
-            <a:avLst/>
-          </a:prstGeom>
-          <a:noFill/>
-        </p:spPr>
-        <p:txBody>
-          <a:bodyPr wrap="square">
-            <a:spAutoFit/>
-          </a:bodyPr>
-          <a:lstStyle/>
-          <a:p>
-            <a:r>
-              <a:rPr sz="880">
-                <a:solidFill>
-                  <a:srgbClr val="525F78"/>
-                </a:solidFill>
-              </a:rPr>
-              <a:t>Shortens platform tuning cycles and supports more predictable pilot deployment outcomes.</a:t>
-            </a:r>
-          </a:p>
-        </p:txBody>
-      </p:sp>
-      <p:sp>
-        <p:nvSpPr>
-          <p:cNvPr id="41" name="Rounded Rectangle 40"/>
+              <a:t>Integrated telemetry and balancing workflow aligned for pilot deployment.</a:t>
+            </a:r>
+          </a:p>
+        </p:txBody>
+      </p:sp>
+      <p:sp>
+        <p:nvSpPr>
+          <p:cNvPr id="43" name="Oval 42"/>
           <p:cNvSpPr/>
           <p:nvPr/>
         </p:nvSpPr>
         <p:spPr>
           <a:xfrm>
-            <a:off x="9144000" y="4736592"/>
-            <a:ext cx="2560320" cy="1234440"/>
-          </a:xfrm>
-          <a:prstGeom prst="roundRect">
+            <a:off x="4343400" y="5925312"/>
+            <a:ext cx="292608" cy="292608"/>
+          </a:xfrm>
+          <a:prstGeom prst="ellipse">
             <a:avLst/>
           </a:prstGeom>
           <a:solidFill>
-            <a:srgbClr val="FFFFFF"/>
+            <a:srgbClr val="1FB074"/>
           </a:solidFill>
           <a:ln>
-            <a:solidFill>
-              <a:srgbClr val="DBE2EC"/>
-            </a:solidFill>
+            <a:noFill/>
           </a:ln>
         </p:spPr>
         <p:style>
@@ -4584,25 +4669,99 @@
           <a:lstStyle/>
           <a:p>
             <a:pPr algn="ctr"/>
-          </a:p>
-        </p:txBody>
-      </p:sp>
-      <p:sp>
-        <p:nvSpPr>
-          <p:cNvPr id="42" name="Rectangle 41"/>
+            <a:r>
+              <a:rPr sz="850" b="1">
+                <a:solidFill>
+                  <a:srgbClr val="FFFFFF"/>
+                </a:solidFill>
+              </a:rPr>
+              <a:t>02</a:t>
+            </a:r>
+          </a:p>
+        </p:txBody>
+      </p:sp>
+      <p:sp>
+        <p:nvSpPr>
+          <p:cNvPr id="44" name="TextBox 43"/>
+          <p:cNvSpPr txBox="1"/>
+          <p:nvPr/>
+        </p:nvSpPr>
+        <p:spPr>
+          <a:xfrm>
+            <a:off x="4754880" y="5897880"/>
+            <a:ext cx="2468880" cy="201168"/>
+          </a:xfrm>
+          <a:prstGeom prst="rect">
+            <a:avLst/>
+          </a:prstGeom>
+          <a:noFill/>
+        </p:spPr>
+        <p:txBody>
+          <a:bodyPr wrap="none">
+            <a:spAutoFit/>
+          </a:bodyPr>
+          <a:lstStyle/>
+          <a:p>
+            <a:r>
+              <a:rPr sz="1100" b="1">
+                <a:solidFill>
+                  <a:srgbClr val="192747"/>
+                </a:solidFill>
+              </a:rPr>
+              <a:t>STABLE + ACTIONABLE</a:t>
+            </a:r>
+          </a:p>
+        </p:txBody>
+      </p:sp>
+      <p:sp>
+        <p:nvSpPr>
+          <p:cNvPr id="45" name="TextBox 44"/>
+          <p:cNvSpPr txBox="1"/>
+          <p:nvPr/>
+        </p:nvSpPr>
+        <p:spPr>
+          <a:xfrm>
+            <a:off x="4754880" y="6163056"/>
+            <a:ext cx="2697480" cy="301752"/>
+          </a:xfrm>
+          <a:prstGeom prst="rect">
+            <a:avLst/>
+          </a:prstGeom>
+          <a:noFill/>
+        </p:spPr>
+        <p:txBody>
+          <a:bodyPr wrap="square">
+            <a:spAutoFit/>
+          </a:bodyPr>
+          <a:lstStyle/>
+          <a:p>
+            <a:r>
+              <a:rPr sz="880">
+                <a:solidFill>
+                  <a:srgbClr val="54607A"/>
+                </a:solidFill>
+              </a:rPr>
+              <a:t>Resource governance and workload visibility packaged for real operational use.</a:t>
+            </a:r>
+          </a:p>
+        </p:txBody>
+      </p:sp>
+      <p:sp>
+        <p:nvSpPr>
+          <p:cNvPr id="46" name="Oval 45"/>
           <p:cNvSpPr/>
           <p:nvPr/>
         </p:nvSpPr>
         <p:spPr>
           <a:xfrm>
-            <a:off x="9144000" y="4736592"/>
-            <a:ext cx="73152" cy="1234440"/>
-          </a:xfrm>
-          <a:prstGeom prst="rect">
+            <a:off x="8183879" y="5925312"/>
+            <a:ext cx="292608" cy="292608"/>
+          </a:xfrm>
+          <a:prstGeom prst="ellipse">
             <a:avLst/>
           </a:prstGeom>
           <a:solidFill>
-            <a:srgbClr val="1269BF"/>
+            <a:srgbClr val="F5A82A"/>
           </a:solidFill>
           <a:ln>
             <a:noFill/>
@@ -4627,19 +4786,27 @@
           <a:lstStyle/>
           <a:p>
             <a:pPr algn="ctr"/>
-          </a:p>
-        </p:txBody>
-      </p:sp>
-      <p:sp>
-        <p:nvSpPr>
-          <p:cNvPr id="43" name="TextBox 42"/>
+            <a:r>
+              <a:rPr sz="850" b="1">
+                <a:solidFill>
+                  <a:srgbClr val="FFFFFF"/>
+                </a:solidFill>
+              </a:rPr>
+              <a:t>03</a:t>
+            </a:r>
+          </a:p>
+        </p:txBody>
+      </p:sp>
+      <p:sp>
+        <p:nvSpPr>
+          <p:cNvPr id="47" name="TextBox 46"/>
           <p:cNvSpPr txBox="1"/>
           <p:nvPr/>
         </p:nvSpPr>
         <p:spPr>
           <a:xfrm>
-            <a:off x="9308592" y="4901184"/>
-            <a:ext cx="530352" cy="256032"/>
+            <a:off x="8595359" y="5897880"/>
+            <a:ext cx="2468880" cy="201168"/>
           </a:xfrm>
           <a:prstGeom prst="rect">
             <a:avLst/>
@@ -4653,26 +4820,26 @@
           <a:lstStyle/>
           <a:p>
             <a:r>
-              <a:rPr sz="2200" b="1">
-                <a:solidFill>
-                  <a:srgbClr val="1269BF"/>
+              <a:rPr sz="1100" b="1">
+                <a:solidFill>
+                  <a:srgbClr val="192747"/>
                 </a:solidFill>
               </a:rPr>
-              <a:t>1.5</a:t>
-            </a:r>
-          </a:p>
-        </p:txBody>
-      </p:sp>
-      <p:sp>
-        <p:nvSpPr>
-          <p:cNvPr id="44" name="TextBox 43"/>
+              <a:t>CUSTOMER-READY STORY</a:t>
+            </a:r>
+          </a:p>
+        </p:txBody>
+      </p:sp>
+      <p:sp>
+        <p:nvSpPr>
+          <p:cNvPr id="48" name="TextBox 47"/>
           <p:cNvSpPr txBox="1"/>
           <p:nvPr/>
         </p:nvSpPr>
         <p:spPr>
           <a:xfrm>
-            <a:off x="9875520" y="4846320"/>
-            <a:ext cx="1600200" cy="256032"/>
+            <a:off x="8595359" y="6163056"/>
+            <a:ext cx="2697480" cy="301752"/>
           </a:xfrm>
           <a:prstGeom prst="rect">
             <a:avLst/>
@@ -4686,65 +4853,32 @@
           <a:lstStyle/>
           <a:p>
             <a:r>
-              <a:rPr sz="1150" b="1">
-                <a:solidFill>
-                  <a:srgbClr val="162543"/>
+              <a:rPr sz="880">
+                <a:solidFill>
+                  <a:srgbClr val="54607A"/>
                 </a:solidFill>
               </a:rPr>
-              <a:t>Pilot momentum</a:t>
-            </a:r>
-          </a:p>
-        </p:txBody>
-      </p:sp>
-      <p:sp>
-        <p:nvSpPr>
-          <p:cNvPr id="45" name="TextBox 44"/>
-          <p:cNvSpPr txBox="1"/>
-          <p:nvPr/>
-        </p:nvSpPr>
-        <p:spPr>
-          <a:xfrm>
-            <a:off x="9875520" y="5193792"/>
-            <a:ext cx="1600200" cy="493776"/>
-          </a:xfrm>
-          <a:prstGeom prst="rect">
-            <a:avLst/>
-          </a:prstGeom>
-          <a:noFill/>
-        </p:spPr>
-        <p:txBody>
-          <a:bodyPr wrap="square">
-            <a:spAutoFit/>
-          </a:bodyPr>
-          <a:lstStyle/>
-          <a:p>
-            <a:r>
-              <a:rPr sz="880">
-                <a:solidFill>
-                  <a:srgbClr val="525F78"/>
-                </a:solidFill>
-              </a:rPr>
-              <a:t>Current pilot-customer placeholders are ready to be replaced with real account names.</a:t>
-            </a:r>
-          </a:p>
-        </p:txBody>
-      </p:sp>
-      <p:sp>
-        <p:nvSpPr>
-          <p:cNvPr id="46" name="Rectangle 45"/>
+              <a:t>Executive-ready slide narrative and editable pilot-customer section included.</a:t>
+            </a:r>
+          </a:p>
+        </p:txBody>
+      </p:sp>
+      <p:sp>
+        <p:nvSpPr>
+          <p:cNvPr id="49" name="Rounded Rectangle 48"/>
           <p:cNvSpPr/>
           <p:nvPr/>
         </p:nvSpPr>
         <p:spPr>
           <a:xfrm>
-            <a:off x="502920" y="6199632"/>
-            <a:ext cx="11201400" cy="9144"/>
-          </a:xfrm>
-          <a:prstGeom prst="rect">
+            <a:off x="274320" y="6510528"/>
+            <a:ext cx="11640312" cy="274320"/>
+          </a:xfrm>
+          <a:prstGeom prst="roundRect">
             <a:avLst/>
           </a:prstGeom>
           <a:solidFill>
-            <a:srgbClr val="DBE2EC"/>
+            <a:srgbClr val="192747"/>
           </a:solidFill>
           <a:ln>
             <a:noFill/>
@@ -4774,14 +4908,14 @@
       </p:sp>
       <p:sp>
         <p:nvSpPr>
-          <p:cNvPr id="47" name="TextBox 46"/>
+          <p:cNvPr id="50" name="TextBox 49"/>
           <p:cNvSpPr txBox="1"/>
           <p:nvPr/>
         </p:nvSpPr>
         <p:spPr>
           <a:xfrm>
-            <a:off x="502920" y="6309360"/>
-            <a:ext cx="3200400" cy="201168"/>
+            <a:off x="438912" y="6565392"/>
+            <a:ext cx="1417320" cy="109728"/>
           </a:xfrm>
           <a:prstGeom prst="rect">
             <a:avLst/>
@@ -4795,58 +4929,41 @@
           <a:lstStyle/>
           <a:p>
             <a:r>
-              <a:rPr sz="1100" b="1">
-                <a:solidFill>
-                  <a:srgbClr val="6A7891"/>
+              <a:rPr sz="880" b="1">
+                <a:solidFill>
+                  <a:srgbClr val="FFFFFF"/>
                 </a:solidFill>
               </a:rPr>
-              <a:t>CUSTOMERS IN PILOT / EARLY ADOPTION</a:t>
-            </a:r>
-          </a:p>
-        </p:txBody>
-      </p:sp>
-      <p:sp>
-        <p:nvSpPr>
-          <p:cNvPr id="48" name="Rounded Rectangle 47"/>
-          <p:cNvSpPr/>
+              <a:t>PILOT CUSTOMERS</a:t>
+            </a:r>
+          </a:p>
+        </p:txBody>
+      </p:sp>
+      <p:sp>
+        <p:nvSpPr>
+          <p:cNvPr id="51" name="TextBox 50"/>
+          <p:cNvSpPr txBox="1"/>
           <p:nvPr/>
         </p:nvSpPr>
         <p:spPr>
           <a:xfrm>
-            <a:off x="502920" y="6492240"/>
-            <a:ext cx="1965960" cy="256032"/>
-          </a:xfrm>
-          <a:prstGeom prst="roundRect">
-            <a:avLst/>
-          </a:prstGeom>
-          <a:solidFill>
-            <a:srgbClr val="162543"/>
-          </a:solidFill>
-          <a:ln>
-            <a:noFill/>
-          </a:ln>
-        </p:spPr>
-        <p:style>
-          <a:lnRef idx="1">
-            <a:schemeClr val="accent1"/>
-          </a:lnRef>
-          <a:fillRef idx="3">
-            <a:schemeClr val="accent1"/>
-          </a:fillRef>
-          <a:effectRef idx="2">
-            <a:schemeClr val="accent1"/>
-          </a:effectRef>
-          <a:fontRef idx="minor">
-            <a:schemeClr val="lt1"/>
-          </a:fontRef>
-        </p:style>
-        <p:txBody>
-          <a:bodyPr rtlCol="0" anchor="ctr"/>
+            <a:off x="1783080" y="6556248"/>
+            <a:ext cx="1783080" cy="118872"/>
+          </a:xfrm>
+          <a:prstGeom prst="rect">
+            <a:avLst/>
+          </a:prstGeom>
+          <a:noFill/>
+        </p:spPr>
+        <p:txBody>
+          <a:bodyPr wrap="none">
+            <a:spAutoFit/>
+          </a:bodyPr>
           <a:lstStyle/>
           <a:p>
             <a:pPr algn="ctr"/>
             <a:r>
-              <a:rPr sz="980" b="1">
+              <a:rPr sz="880" b="1">
                 <a:solidFill>
                   <a:srgbClr val="FFFFFF"/>
                 </a:solidFill>
@@ -4858,46 +4975,29 @@
       </p:sp>
       <p:sp>
         <p:nvSpPr>
-          <p:cNvPr id="49" name="Rounded Rectangle 48"/>
-          <p:cNvSpPr/>
+          <p:cNvPr id="52" name="TextBox 51"/>
+          <p:cNvSpPr txBox="1"/>
           <p:nvPr/>
         </p:nvSpPr>
         <p:spPr>
           <a:xfrm>
-            <a:off x="2743200" y="6492240"/>
-            <a:ext cx="1965960" cy="256032"/>
-          </a:xfrm>
-          <a:prstGeom prst="roundRect">
-            <a:avLst/>
-          </a:prstGeom>
-          <a:solidFill>
-            <a:srgbClr val="1269BF"/>
-          </a:solidFill>
-          <a:ln>
-            <a:noFill/>
-          </a:ln>
-        </p:spPr>
-        <p:style>
-          <a:lnRef idx="1">
-            <a:schemeClr val="accent1"/>
-          </a:lnRef>
-          <a:fillRef idx="3">
-            <a:schemeClr val="accent1"/>
-          </a:fillRef>
-          <a:effectRef idx="2">
-            <a:schemeClr val="accent1"/>
-          </a:effectRef>
-          <a:fontRef idx="minor">
-            <a:schemeClr val="lt1"/>
-          </a:fontRef>
-        </p:style>
-        <p:txBody>
-          <a:bodyPr rtlCol="0" anchor="ctr"/>
+            <a:off x="3657600" y="6556248"/>
+            <a:ext cx="1783080" cy="118872"/>
+          </a:xfrm>
+          <a:prstGeom prst="rect">
+            <a:avLst/>
+          </a:prstGeom>
+          <a:noFill/>
+        </p:spPr>
+        <p:txBody>
+          <a:bodyPr wrap="none">
+            <a:spAutoFit/>
+          </a:bodyPr>
           <a:lstStyle/>
           <a:p>
             <a:pPr algn="ctr"/>
             <a:r>
-              <a:rPr sz="980" b="1">
+              <a:rPr sz="880" b="1">
                 <a:solidFill>
                   <a:srgbClr val="FFFFFF"/>
                 </a:solidFill>
@@ -4909,46 +5009,29 @@
       </p:sp>
       <p:sp>
         <p:nvSpPr>
-          <p:cNvPr id="50" name="Rounded Rectangle 49"/>
-          <p:cNvSpPr/>
+          <p:cNvPr id="53" name="TextBox 52"/>
+          <p:cNvSpPr txBox="1"/>
           <p:nvPr/>
         </p:nvSpPr>
         <p:spPr>
           <a:xfrm>
-            <a:off x="4983480" y="6492240"/>
-            <a:ext cx="1965960" cy="256032"/>
-          </a:xfrm>
-          <a:prstGeom prst="roundRect">
-            <a:avLst/>
-          </a:prstGeom>
-          <a:solidFill>
-            <a:srgbClr val="1EB074"/>
-          </a:solidFill>
-          <a:ln>
-            <a:noFill/>
-          </a:ln>
-        </p:spPr>
-        <p:style>
-          <a:lnRef idx="1">
-            <a:schemeClr val="accent1"/>
-          </a:lnRef>
-          <a:fillRef idx="3">
-            <a:schemeClr val="accent1"/>
-          </a:fillRef>
-          <a:effectRef idx="2">
-            <a:schemeClr val="accent1"/>
-          </a:effectRef>
-          <a:fontRef idx="minor">
-            <a:schemeClr val="lt1"/>
-          </a:fontRef>
-        </p:style>
-        <p:txBody>
-          <a:bodyPr rtlCol="0" anchor="ctr"/>
+            <a:off x="5532120" y="6556248"/>
+            <a:ext cx="1783080" cy="118872"/>
+          </a:xfrm>
+          <a:prstGeom prst="rect">
+            <a:avLst/>
+          </a:prstGeom>
+          <a:noFill/>
+        </p:spPr>
+        <p:txBody>
+          <a:bodyPr wrap="none">
+            <a:spAutoFit/>
+          </a:bodyPr>
           <a:lstStyle/>
           <a:p>
             <a:pPr algn="ctr"/>
             <a:r>
-              <a:rPr sz="980" b="1">
+              <a:rPr sz="880" b="1">
                 <a:solidFill>
                   <a:srgbClr val="FFFFFF"/>
                 </a:solidFill>
@@ -4960,46 +5043,29 @@
       </p:sp>
       <p:sp>
         <p:nvSpPr>
-          <p:cNvPr id="51" name="Rounded Rectangle 50"/>
-          <p:cNvSpPr/>
+          <p:cNvPr id="54" name="TextBox 53"/>
+          <p:cNvSpPr txBox="1"/>
           <p:nvPr/>
         </p:nvSpPr>
         <p:spPr>
           <a:xfrm>
-            <a:off x="7223760" y="6492240"/>
-            <a:ext cx="1965960" cy="256032"/>
-          </a:xfrm>
-          <a:prstGeom prst="roundRect">
-            <a:avLst/>
-          </a:prstGeom>
-          <a:solidFill>
-            <a:srgbClr val="F2A42A"/>
-          </a:solidFill>
-          <a:ln>
-            <a:noFill/>
-          </a:ln>
-        </p:spPr>
-        <p:style>
-          <a:lnRef idx="1">
-            <a:schemeClr val="accent1"/>
-          </a:lnRef>
-          <a:fillRef idx="3">
-            <a:schemeClr val="accent1"/>
-          </a:fillRef>
-          <a:effectRef idx="2">
-            <a:schemeClr val="accent1"/>
-          </a:effectRef>
-          <a:fontRef idx="minor">
-            <a:schemeClr val="lt1"/>
-          </a:fontRef>
-        </p:style>
-        <p:txBody>
-          <a:bodyPr rtlCol="0" anchor="ctr"/>
+            <a:off x="7406640" y="6556248"/>
+            <a:ext cx="1783080" cy="118872"/>
+          </a:xfrm>
+          <a:prstGeom prst="rect">
+            <a:avLst/>
+          </a:prstGeom>
+          <a:noFill/>
+        </p:spPr>
+        <p:txBody>
+          <a:bodyPr wrap="none">
+            <a:spAutoFit/>
+          </a:bodyPr>
           <a:lstStyle/>
           <a:p>
             <a:pPr algn="ctr"/>
             <a:r>
-              <a:rPr sz="980" b="1">
+              <a:rPr sz="880" b="1">
                 <a:solidFill>
                   <a:srgbClr val="FFFFFF"/>
                 </a:solidFill>
@@ -5011,46 +5077,29 @@
       </p:sp>
       <p:sp>
         <p:nvSpPr>
-          <p:cNvPr id="52" name="Rounded Rectangle 51"/>
-          <p:cNvSpPr/>
+          <p:cNvPr id="55" name="TextBox 54"/>
+          <p:cNvSpPr txBox="1"/>
           <p:nvPr/>
         </p:nvSpPr>
         <p:spPr>
           <a:xfrm>
-            <a:off x="9464040" y="6492240"/>
-            <a:ext cx="1965960" cy="256032"/>
-          </a:xfrm>
-          <a:prstGeom prst="roundRect">
-            <a:avLst/>
-          </a:prstGeom>
-          <a:solidFill>
-            <a:srgbClr val="162543"/>
-          </a:solidFill>
-          <a:ln>
-            <a:noFill/>
-          </a:ln>
-        </p:spPr>
-        <p:style>
-          <a:lnRef idx="1">
-            <a:schemeClr val="accent1"/>
-          </a:lnRef>
-          <a:fillRef idx="3">
-            <a:schemeClr val="accent1"/>
-          </a:fillRef>
-          <a:effectRef idx="2">
-            <a:schemeClr val="accent1"/>
-          </a:effectRef>
-          <a:fontRef idx="minor">
-            <a:schemeClr val="lt1"/>
-          </a:fontRef>
-        </p:style>
-        <p:txBody>
-          <a:bodyPr rtlCol="0" anchor="ctr"/>
+            <a:off x="9281159" y="6556248"/>
+            <a:ext cx="1783080" cy="118872"/>
+          </a:xfrm>
+          <a:prstGeom prst="rect">
+            <a:avLst/>
+          </a:prstGeom>
+          <a:noFill/>
+        </p:spPr>
+        <p:txBody>
+          <a:bodyPr wrap="none">
+            <a:spAutoFit/>
+          </a:bodyPr>
           <a:lstStyle/>
           <a:p>
             <a:pPr algn="ctr"/>
             <a:r>
-              <a:rPr sz="980" b="1">
+              <a:rPr sz="880" b="1">
                 <a:solidFill>
                   <a:srgbClr val="FFFFFF"/>
                 </a:solidFill>

</xml_diff>

<commit_message>
docs: update pilot customer row entries in milestone slide
</commit_message>
<xml_diff>
--- a/docs/presentations/smartune_q3_milestone_slide.pptx
+++ b/docs/presentations/smartune_q3_milestone_slide.pptx
@@ -3079,7 +3079,7 @@
 </file>
 
 <file path=ppt/slides/slide1.xml><?xml version="1.0" encoding="utf-8"?>
-<p:sld xmlns:a="http://schemas.openxmlformats.org/drawingml/2006/main" xmlns:p="http://schemas.openxmlformats.org/presentationml/2006/main" xmlns:r="http://schemas.openxmlformats.org/officeDocument/2006/relationships">
+<p:sld xmlns:a="http://schemas.openxmlformats.org/drawingml/2006/main" xmlns:ns2="http://schemas.openxmlformats.org/officeDocument/2006/relationships" xmlns:p="http://schemas.openxmlformats.org/presentationml/2006/main">
   <p:cSld>
     <p:spTree>
       <p:nvGrpSpPr>
@@ -3424,7 +3424,7 @@
           <p:nvPr/>
         </p:nvPicPr>
         <p:blipFill>
-          <a:blip r:embed="rId2"/>
+          <a:blip ns2:embed="rId2"/>
           <a:stretch>
             <a:fillRect/>
           </a:stretch>
@@ -4941,14 +4941,14 @@
       </p:sp>
       <p:sp>
         <p:nvSpPr>
-          <p:cNvPr id="51" name="TextBox 50"/>
+          <p:cNvPr id="56" name="TextBox 55"/>
           <p:cNvSpPr txBox="1"/>
           <p:nvPr/>
         </p:nvSpPr>
         <p:spPr>
           <a:xfrm>
-            <a:off x="1783080" y="6556248"/>
-            <a:ext cx="1783080" cy="118872"/>
+            <a:off x="3575520" y="6556248"/>
+            <a:ext cx="1130125" cy="118872"/>
           </a:xfrm>
           <a:prstGeom prst="rect">
             <a:avLst/>
@@ -4968,21 +4968,21 @@
                   <a:srgbClr val="FFFFFF"/>
                 </a:solidFill>
               </a:rPr>
-              <a:t>AsterAI</a:t>
-            </a:r>
-          </a:p>
-        </p:txBody>
-      </p:sp>
-      <p:sp>
-        <p:nvSpPr>
-          <p:cNvPr id="52" name="TextBox 51"/>
+              <a:t>铁威马 (TerraMaster)</a:t>
+            </a:r>
+          </a:p>
+        </p:txBody>
+      </p:sp>
+      <p:sp>
+        <p:nvSpPr>
+          <p:cNvPr id="57" name="TextBox 56"/>
           <p:cNvSpPr txBox="1"/>
           <p:nvPr/>
         </p:nvSpPr>
         <p:spPr>
           <a:xfrm>
-            <a:off x="3657600" y="6556248"/>
-            <a:ext cx="1783080" cy="118872"/>
+            <a:off x="4715005" y="6556248"/>
+            <a:ext cx="1130125" cy="118872"/>
           </a:xfrm>
           <a:prstGeom prst="rect">
             <a:avLst/>
@@ -5002,21 +5002,21 @@
                   <a:srgbClr val="FFFFFF"/>
                 </a:solidFill>
               </a:rPr>
-              <a:t>NovaEdge Systems</a:t>
-            </a:r>
-          </a:p>
-        </p:txBody>
-      </p:sp>
-      <p:sp>
-        <p:nvSpPr>
-          <p:cNvPr id="53" name="TextBox 52"/>
+              <a:t>海高特 (AWOL)</a:t>
+            </a:r>
+          </a:p>
+        </p:txBody>
+      </p:sp>
+      <p:sp>
+        <p:nvSpPr>
+          <p:cNvPr id="58" name="TextBox 57"/>
           <p:cNvSpPr txBox="1"/>
           <p:nvPr/>
         </p:nvSpPr>
         <p:spPr>
           <a:xfrm>
-            <a:off x="5532120" y="6556248"/>
-            <a:ext cx="1783080" cy="118872"/>
+            <a:off x="5854490" y="6556248"/>
+            <a:ext cx="1130125" cy="118872"/>
           </a:xfrm>
           <a:prstGeom prst="rect">
             <a:avLst/>
@@ -5036,21 +5036,21 @@
                   <a:srgbClr val="FFFFFF"/>
                 </a:solidFill>
               </a:rPr>
-              <a:t>BlueMesa Robotics</a:t>
-            </a:r>
-          </a:p>
-        </p:txBody>
-      </p:sp>
-      <p:sp>
-        <p:nvSpPr>
-          <p:cNvPr id="54" name="TextBox 53"/>
+              <a:t>联想</a:t>
+            </a:r>
+          </a:p>
+        </p:txBody>
+      </p:sp>
+      <p:sp>
+        <p:nvSpPr>
+          <p:cNvPr id="59" name="TextBox 58"/>
           <p:cNvSpPr txBox="1"/>
           <p:nvPr/>
         </p:nvSpPr>
         <p:spPr>
           <a:xfrm>
-            <a:off x="7406640" y="6556248"/>
-            <a:ext cx="1783080" cy="118872"/>
+            <a:off x="6993975" y="6556248"/>
+            <a:ext cx="1130125" cy="118872"/>
           </a:xfrm>
           <a:prstGeom prst="rect">
             <a:avLst/>
@@ -5070,21 +5070,21 @@
                   <a:srgbClr val="FFFFFF"/>
                 </a:solidFill>
               </a:rPr>
-              <a:t>VertexVision</a:t>
-            </a:r>
-          </a:p>
-        </p:txBody>
-      </p:sp>
-      <p:sp>
-        <p:nvSpPr>
-          <p:cNvPr id="55" name="TextBox 54"/>
+              <a:t>畅网</a:t>
+            </a:r>
+          </a:p>
+        </p:txBody>
+      </p:sp>
+      <p:sp>
+        <p:nvSpPr>
+          <p:cNvPr id="60" name="TextBox 59"/>
           <p:cNvSpPr txBox="1"/>
           <p:nvPr/>
         </p:nvSpPr>
         <p:spPr>
           <a:xfrm>
-            <a:off x="9281159" y="6556248"/>
-            <a:ext cx="1783080" cy="118872"/>
+            <a:off x="8133460" y="6556248"/>
+            <a:ext cx="1130125" cy="118872"/>
           </a:xfrm>
           <a:prstGeom prst="rect">
             <a:avLst/>
@@ -5104,7 +5104,75 @@
                   <a:srgbClr val="FFFFFF"/>
                 </a:solidFill>
               </a:rPr>
-              <a:t>Orion Compute</a:t>
+              <a:t>威联通 (QNAP)</a:t>
+            </a:r>
+          </a:p>
+        </p:txBody>
+      </p:sp>
+      <p:sp>
+        <p:nvSpPr>
+          <p:cNvPr id="61" name="TextBox 60"/>
+          <p:cNvSpPr txBox="1"/>
+          <p:nvPr/>
+        </p:nvSpPr>
+        <p:spPr>
+          <a:xfrm>
+            <a:off x="9272945" y="6556248"/>
+            <a:ext cx="1130125" cy="118872"/>
+          </a:xfrm>
+          <a:prstGeom prst="rect">
+            <a:avLst/>
+          </a:prstGeom>
+          <a:noFill/>
+        </p:spPr>
+        <p:txBody>
+          <a:bodyPr wrap="none">
+            <a:spAutoFit/>
+          </a:bodyPr>
+          <a:lstStyle/>
+          <a:p>
+            <a:pPr algn="ctr"/>
+            <a:r>
+              <a:rPr sz="880" b="1">
+                <a:solidFill>
+                  <a:srgbClr val="FFFFFF"/>
+                </a:solidFill>
+              </a:rPr>
+              <a:t>nimo</a:t>
+            </a:r>
+          </a:p>
+        </p:txBody>
+      </p:sp>
+      <p:sp>
+        <p:nvSpPr>
+          <p:cNvPr id="62" name="TextBox 61"/>
+          <p:cNvSpPr txBox="1"/>
+          <p:nvPr/>
+        </p:nvSpPr>
+        <p:spPr>
+          <a:xfrm>
+            <a:off x="10412430" y="6556248"/>
+            <a:ext cx="1139490" cy="118872"/>
+          </a:xfrm>
+          <a:prstGeom prst="rect">
+            <a:avLst/>
+          </a:prstGeom>
+          <a:noFill/>
+        </p:spPr>
+        <p:txBody>
+          <a:bodyPr wrap="none">
+            <a:spAutoFit/>
+          </a:bodyPr>
+          <a:lstStyle/>
+          <a:p>
+            <a:pPr algn="ctr"/>
+            <a:r>
+              <a:rPr sz="880" b="1">
+                <a:solidFill>
+                  <a:srgbClr val="FFFFFF"/>
+                </a:solidFill>
+              </a:rPr>
+              <a:t>geakos</a:t>
             </a:r>
           </a:p>
         </p:txBody>

</xml_diff>

<commit_message>
Update SmartTune role description
</commit_message>
<xml_diff>
--- a/docs/presentations/smartune_q3_milestone_slide.pptx
+++ b/docs/presentations/smartune_q3_milestone_slide.pptx
@@ -3079,7 +3079,7 @@
 </file>
 
 <file path=ppt/slides/slide1.xml><?xml version="1.0" encoding="utf-8"?>
-<p:sld xmlns:a="http://schemas.openxmlformats.org/drawingml/2006/main" xmlns:ns2="http://schemas.openxmlformats.org/officeDocument/2006/relationships" xmlns:p="http://schemas.openxmlformats.org/presentationml/2006/main">
+<p:sld xmlns:a="http://schemas.openxmlformats.org/drawingml/2006/main" xmlns:p="http://schemas.openxmlformats.org/presentationml/2006/main" xmlns:r="http://schemas.openxmlformats.org/officeDocument/2006/relationships">
   <p:cSld>
     <p:spTree>
       <p:nvGrpSpPr>
@@ -3424,7 +3424,7 @@
           <p:nvPr/>
         </p:nvPicPr>
         <p:blipFill>
-          <a:blip ns2:embed="rId2"/>
+          <a:blip r:embed="rId2"/>
           <a:stretch>
             <a:fillRect/>
           </a:stretch>
@@ -3695,7 +3695,7 @@
                   <a:srgbClr val="CED6E5"/>
                 </a:solidFill>
               </a:rPr>
-              <a:t>Middle-section emphasis: what SmartTune is, what it does, and why it matters to business outcomes.</a:t>
+              <a:t>SmartTune orchestrates platform telemetry, resource policies, and workload controls to keep Intel® XPU systems balanced, stable, and deployment-ready.</a:t>
             </a:r>
           </a:p>
         </p:txBody>

</xml_diff>